<commit_message>
Plaquette EDLC : pictogrammes vectoriels natifs et chiffres clés lisibles après import Canva
Co-Authored-By: Claude Opus 5.5 <noreply@anthropic.com>
Claude-Session: https://claude.ai/code/session_013b5GF7ZW93Jhurg8kHyqui
</commit_message>
<xml_diff>
--- a/edlc-plaquette/EDLC_Plaquette_mecenat.pptx
+++ b/edlc-plaquette/EDLC_Plaquette_mecenat.pptx
@@ -3275,7 +3275,7 @@
       </p:sp>
       <p:pic>
         <p:nvPicPr>
-          <p:cNvPr id="7" name="Logo EDLC" descr="1_crop.png"/>
+          <p:cNvPr id="7" name="Logo EDLC" descr="logo_edlc_crop.png"/>
           <p:cNvPicPr>
             <a:picLocks noChangeAspect="1"/>
           </p:cNvPicPr>
@@ -3329,7 +3329,7 @@
       </p:sp>
       <p:pic>
         <p:nvPicPr>
-          <p:cNvPr id="9" name="Illustration – entrepreneur et maison" descr="2.png"/>
+          <p:cNvPr id="9" name="Illustration – entrepreneur et maison" descr="entrepreneur_maison.png"/>
           <p:cNvPicPr>
             <a:picLocks noChangeAspect="1"/>
           </p:cNvPicPr>
@@ -5076,231 +5076,123 @@
           <a:p/>
         </p:txBody>
       </p:sp>
-      <p:grpSp>
-        <p:nvGrpSpPr>
-          <p:cNvPr id="62" name="Pictogramme PROTÉGER"/>
-          <p:cNvGrpSpPr/>
-          <p:nvPr/>
-        </p:nvGrpSpPr>
-        <p:grpSpPr>
+      <p:sp>
+        <p:nvSpPr>
+          <p:cNvPr id="59" name="Picto protéger – fond"/>
+          <p:cNvSpPr/>
+          <p:nvPr/>
+        </p:nvSpPr>
+        <p:spPr>
           <a:xfrm>
             <a:off x="584200" y="7226300"/>
             <a:ext cx="355600" cy="355600"/>
-            <a:chOff x="584200" y="7226300"/>
-            <a:chExt cx="355600" cy="355600"/>
-          </a:xfrm>
-        </p:grpSpPr>
-        <p:sp>
-          <p:nvSpPr>
-            <p:cNvPr id="59" name="Picto protéger – fond"/>
-            <p:cNvSpPr/>
-            <p:nvPr/>
-          </p:nvSpPr>
-          <p:spPr>
-            <a:xfrm>
-              <a:off x="584200" y="7226300"/>
-              <a:ext cx="355600" cy="355600"/>
-            </a:xfrm>
-            <a:prstGeom prst="ellipse">
-              <a:avLst/>
-            </a:prstGeom>
-            <a:solidFill>
-              <a:srgbClr val="EF3F34"/>
-            </a:solidFill>
-            <a:ln>
-              <a:noFill/>
-            </a:ln>
-            <a:effectLst/>
-          </p:spPr>
-          <p:txBody>
-            <a:bodyPr rtlCol="0" anchor="ctr"/>
-            <a:lstStyle/>
-            <a:p>
-              <a:pPr algn="ctr"/>
-            </a:p>
-          </p:txBody>
-        </p:sp>
-        <p:sp>
-          <p:nvSpPr>
-            <p:cNvPr id="60" name="Picto protéger – bouclier"/>
-            <p:cNvSpPr/>
-            <p:nvPr/>
-          </p:nvSpPr>
-          <p:spPr>
-            <a:xfrm>
-              <a:off x="667173" y="7291493"/>
-              <a:ext cx="189653" cy="219287"/>
-            </a:xfrm>
-            <a:custGeom>
-              <a:avLst/>
-              <a:gdLst/>
-              <a:ahLst/>
-              <a:cxnLst/>
-              <a:rect l="l" t="t" r="r" b="b"/>
-              <a:pathLst>
-                <a:path w="189653" h="219287">
-                  <a:moveTo>
-                    <a:pt x="0" y="23707"/>
-                  </a:moveTo>
-                  <a:lnTo>
-                    <a:pt x="94827" y="0"/>
-                  </a:lnTo>
-                  <a:lnTo>
-                    <a:pt x="189653" y="23707"/>
-                  </a:lnTo>
-                  <a:lnTo>
-                    <a:pt x="189653" y="106680"/>
-                  </a:lnTo>
-                  <a:lnTo>
-                    <a:pt x="181751" y="120604"/>
-                  </a:lnTo>
-                  <a:lnTo>
-                    <a:pt x="173849" y="134291"/>
-                  </a:lnTo>
-                  <a:lnTo>
-                    <a:pt x="165946" y="147505"/>
-                  </a:lnTo>
-                  <a:lnTo>
-                    <a:pt x="158044" y="160020"/>
-                  </a:lnTo>
-                  <a:lnTo>
-                    <a:pt x="150142" y="171623"/>
-                  </a:lnTo>
-                  <a:lnTo>
-                    <a:pt x="142240" y="182114"/>
-                  </a:lnTo>
-                  <a:lnTo>
-                    <a:pt x="134338" y="191315"/>
-                  </a:lnTo>
-                  <a:lnTo>
-                    <a:pt x="126435" y="199067"/>
-                  </a:lnTo>
-                  <a:lnTo>
-                    <a:pt x="118533" y="205239"/>
-                  </a:lnTo>
-                  <a:lnTo>
-                    <a:pt x="110631" y="209725"/>
-                  </a:lnTo>
-                  <a:lnTo>
-                    <a:pt x="102729" y="212447"/>
-                  </a:lnTo>
-                  <a:lnTo>
-                    <a:pt x="94827" y="219287"/>
-                  </a:lnTo>
-                  <a:lnTo>
-                    <a:pt x="86924" y="212447"/>
-                  </a:lnTo>
-                  <a:lnTo>
-                    <a:pt x="79022" y="209725"/>
-                  </a:lnTo>
-                  <a:lnTo>
-                    <a:pt x="71120" y="205239"/>
-                  </a:lnTo>
-                  <a:lnTo>
-                    <a:pt x="63218" y="199067"/>
-                  </a:lnTo>
-                  <a:lnTo>
-                    <a:pt x="55315" y="191315"/>
-                  </a:lnTo>
-                  <a:lnTo>
-                    <a:pt x="47413" y="182114"/>
-                  </a:lnTo>
-                  <a:lnTo>
-                    <a:pt x="39511" y="171623"/>
-                  </a:lnTo>
-                  <a:lnTo>
-                    <a:pt x="31609" y="160020"/>
-                  </a:lnTo>
-                  <a:lnTo>
-                    <a:pt x="23707" y="147505"/>
-                  </a:lnTo>
-                  <a:lnTo>
-                    <a:pt x="15804" y="134291"/>
-                  </a:lnTo>
-                  <a:lnTo>
-                    <a:pt x="7902" y="120604"/>
-                  </a:lnTo>
-                  <a:lnTo>
-                    <a:pt x="0" y="106680"/>
-                  </a:lnTo>
-                  <a:close/>
-                </a:path>
-              </a:pathLst>
-            </a:custGeom>
-            <a:solidFill>
-              <a:srgbClr val="FFFFFF"/>
-            </a:solidFill>
-            <a:ln>
-              <a:noFill/>
-            </a:ln>
-            <a:effectLst/>
-          </p:spPr>
-          <p:txBody>
-            <a:bodyPr rtlCol="0" anchor="ctr"/>
-            <a:lstStyle/>
-            <a:p>
-              <a:pPr algn="ctr"/>
-            </a:p>
-          </p:txBody>
-        </p:sp>
-        <p:sp>
-          <p:nvSpPr>
-            <p:cNvPr id="61" name="Picto protéger – coche"/>
-            <p:cNvSpPr/>
-            <p:nvPr/>
-          </p:nvSpPr>
-          <p:spPr>
-            <a:xfrm>
-              <a:off x="716957" y="7349574"/>
-              <a:ext cx="109050" cy="92456"/>
-            </a:xfrm>
-            <a:custGeom>
-              <a:avLst/>
-              <a:gdLst/>
-              <a:ahLst/>
-              <a:cxnLst/>
-              <a:rect l="l" t="t" r="r" b="b"/>
-              <a:pathLst>
-                <a:path w="109050" h="92456">
-                  <a:moveTo>
-                    <a:pt x="0" y="53340"/>
-                  </a:moveTo>
-                  <a:lnTo>
-                    <a:pt x="21336" y="32004"/>
-                  </a:lnTo>
-                  <a:lnTo>
-                    <a:pt x="37931" y="49784"/>
-                  </a:lnTo>
-                  <a:lnTo>
-                    <a:pt x="87715" y="0"/>
-                  </a:lnTo>
-                  <a:lnTo>
-                    <a:pt x="109050" y="21336"/>
-                  </a:lnTo>
-                  <a:lnTo>
-                    <a:pt x="37931" y="92456"/>
-                  </a:lnTo>
-                  <a:close/>
-                </a:path>
-              </a:pathLst>
-            </a:custGeom>
-            <a:solidFill>
-              <a:srgbClr val="EF3F34"/>
-            </a:solidFill>
-            <a:ln>
-              <a:noFill/>
-            </a:ln>
-            <a:effectLst/>
-          </p:spPr>
-          <p:txBody>
-            <a:bodyPr rtlCol="0" anchor="ctr"/>
-            <a:lstStyle/>
-            <a:p>
-              <a:pPr algn="ctr"/>
-            </a:p>
-          </p:txBody>
-        </p:sp>
-      </p:grpSp>
+          </a:xfrm>
+          <a:prstGeom prst="ellipse">
+            <a:avLst/>
+          </a:prstGeom>
+          <a:solidFill>
+            <a:srgbClr val="EF3F34"/>
+          </a:solidFill>
+          <a:ln>
+            <a:noFill/>
+          </a:ln>
+          <a:effectLst/>
+        </p:spPr>
+        <p:txBody>
+          <a:bodyPr rtlCol="0" anchor="ctr"/>
+          <a:lstStyle/>
+          <a:p>
+            <a:pPr algn="ctr"/>
+          </a:p>
+        </p:txBody>
+      </p:sp>
+      <p:sp>
+        <p:nvSpPr>
+          <p:cNvPr id="60" name="Picto protéger – bouclier"/>
+          <p:cNvSpPr/>
+          <p:nvPr/>
+        </p:nvSpPr>
+        <p:spPr>
+          <a:xfrm>
+            <a:off x="679026" y="7303346"/>
+            <a:ext cx="165946" cy="201506"/>
+          </a:xfrm>
+          <a:prstGeom prst="flowChartOffpageConnector">
+            <a:avLst/>
+          </a:prstGeom>
+          <a:solidFill>
+            <a:srgbClr val="FFFFFF"/>
+          </a:solidFill>
+          <a:ln>
+            <a:noFill/>
+          </a:ln>
+        </p:spPr>
+        <p:txBody>
+          <a:bodyPr rtlCol="0" anchor="ctr"/>
+          <a:lstStyle/>
+          <a:p>
+            <a:pPr algn="ctr"/>
+          </a:p>
+        </p:txBody>
+      </p:sp>
+      <p:sp>
+        <p:nvSpPr>
+          <p:cNvPr id="61" name="Picto protéger – coche (court)"/>
+          <p:cNvSpPr/>
+          <p:nvPr/>
+        </p:nvSpPr>
+        <p:spPr>
+          <a:xfrm rot="2700000">
+            <a:off x="705104" y="7385134"/>
+            <a:ext cx="59266" cy="26077"/>
+          </a:xfrm>
+          <a:prstGeom prst="roundRect">
+            <a:avLst/>
+          </a:prstGeom>
+          <a:solidFill>
+            <a:srgbClr val="EF3F34"/>
+          </a:solidFill>
+          <a:ln>
+            <a:noFill/>
+          </a:ln>
+        </p:spPr>
+        <p:txBody>
+          <a:bodyPr rtlCol="0" anchor="ctr"/>
+          <a:lstStyle/>
+          <a:p>
+            <a:pPr algn="ctr"/>
+          </a:p>
+        </p:txBody>
+      </p:sp>
+      <p:sp>
+        <p:nvSpPr>
+          <p:cNvPr id="62" name="Picto protéger – coche (long)"/>
+          <p:cNvSpPr/>
+          <p:nvPr/>
+        </p:nvSpPr>
+        <p:spPr>
+          <a:xfrm rot="18600000">
+            <a:off x="733552" y="7366169"/>
+            <a:ext cx="100753" cy="26077"/>
+          </a:xfrm>
+          <a:prstGeom prst="roundRect">
+            <a:avLst/>
+          </a:prstGeom>
+          <a:solidFill>
+            <a:srgbClr val="EF3F34"/>
+          </a:solidFill>
+          <a:ln>
+            <a:noFill/>
+          </a:ln>
+        </p:spPr>
+        <p:txBody>
+          <a:bodyPr rtlCol="0" anchor="ctr"/>
+          <a:lstStyle/>
+          <a:p>
+            <a:pPr algn="ctr"/>
+          </a:p>
+        </p:txBody>
+      </p:sp>
       <p:sp>
         <p:nvSpPr>
           <p:cNvPr id="63" name="Carte PROTÉGER – titre"/>
@@ -5424,172 +5316,153 @@
           <a:p/>
         </p:txBody>
       </p:sp>
-      <p:grpSp>
-        <p:nvGrpSpPr>
-          <p:cNvPr id="71" name="Pictogramme PRÉVENIR"/>
-          <p:cNvGrpSpPr/>
-          <p:nvPr/>
-        </p:nvGrpSpPr>
-        <p:grpSpPr>
+      <p:sp>
+        <p:nvSpPr>
+          <p:cNvPr id="66" name="Picto prévenir – fond"/>
+          <p:cNvSpPr/>
+          <p:nvPr/>
+        </p:nvSpPr>
+        <p:spPr>
           <a:xfrm>
             <a:off x="3970654" y="7226300"/>
             <a:ext cx="355600" cy="355600"/>
-            <a:chOff x="3970654" y="7226300"/>
-            <a:chExt cx="355600" cy="355600"/>
-          </a:xfrm>
-        </p:grpSpPr>
-        <p:sp>
-          <p:nvSpPr>
-            <p:cNvPr id="66" name="Picto prévenir – fond"/>
-            <p:cNvSpPr/>
-            <p:nvPr/>
-          </p:nvSpPr>
-          <p:spPr>
-            <a:xfrm>
-              <a:off x="3970654" y="7226300"/>
-              <a:ext cx="355600" cy="355600"/>
-            </a:xfrm>
-            <a:prstGeom prst="ellipse">
-              <a:avLst/>
-            </a:prstGeom>
-            <a:solidFill>
-              <a:srgbClr val="26408F"/>
-            </a:solidFill>
-            <a:ln>
-              <a:noFill/>
-            </a:ln>
-            <a:effectLst/>
-          </p:spPr>
-          <p:txBody>
-            <a:bodyPr rtlCol="0" anchor="ctr"/>
-            <a:lstStyle/>
-            <a:p>
-              <a:pPr algn="ctr"/>
-            </a:p>
-          </p:txBody>
-        </p:sp>
-        <p:sp>
-          <p:nvSpPr>
-            <p:cNvPr id="67" name="Picto prévenir – ampoule"/>
-            <p:cNvSpPr/>
-            <p:nvPr/>
-          </p:nvSpPr>
-          <p:spPr>
-            <a:xfrm>
-              <a:off x="4077334" y="7285566"/>
-              <a:ext cx="142240" cy="142240"/>
-            </a:xfrm>
-            <a:prstGeom prst="ellipse">
-              <a:avLst/>
-            </a:prstGeom>
-            <a:solidFill>
-              <a:srgbClr val="FFCB1F"/>
-            </a:solidFill>
-            <a:ln>
-              <a:noFill/>
-            </a:ln>
-            <a:effectLst/>
-          </p:spPr>
-          <p:txBody>
-            <a:bodyPr rtlCol="0" anchor="ctr"/>
-            <a:lstStyle/>
-            <a:p>
-              <a:pPr algn="ctr"/>
-            </a:p>
-          </p:txBody>
-        </p:sp>
-        <p:sp>
-          <p:nvSpPr>
-            <p:cNvPr id="68" name="Picto prévenir – culot"/>
-            <p:cNvSpPr/>
-            <p:nvPr/>
-          </p:nvSpPr>
-          <p:spPr>
-            <a:xfrm>
-              <a:off x="4112894" y="7410026"/>
-              <a:ext cx="71120" cy="59266"/>
-            </a:xfrm>
-            <a:prstGeom prst="rect">
-              <a:avLst/>
-            </a:prstGeom>
-            <a:solidFill>
-              <a:srgbClr val="FFCB1F"/>
-            </a:solidFill>
-            <a:ln>
-              <a:noFill/>
-            </a:ln>
-            <a:effectLst/>
-          </p:spPr>
-          <p:txBody>
-            <a:bodyPr rtlCol="0" anchor="ctr"/>
-            <a:lstStyle/>
-            <a:p/>
-          </p:txBody>
-        </p:sp>
-        <p:sp>
-          <p:nvSpPr>
-            <p:cNvPr id="69" name="Picto prévenir – trait 1"/>
-            <p:cNvSpPr/>
-            <p:nvPr/>
-          </p:nvSpPr>
-          <p:spPr>
-            <a:xfrm>
-              <a:off x="4112894" y="7478776"/>
-              <a:ext cx="71120" cy="16594"/>
-            </a:xfrm>
-            <a:prstGeom prst="roundRect">
-              <a:avLst>
-                <a:gd name="adj" fmla="val 42857"/>
-              </a:avLst>
-            </a:prstGeom>
-            <a:solidFill>
-              <a:srgbClr val="FFCB1F"/>
-            </a:solidFill>
-            <a:ln>
-              <a:noFill/>
-            </a:ln>
-            <a:effectLst/>
-          </p:spPr>
-          <p:txBody>
-            <a:bodyPr rtlCol="0" anchor="ctr"/>
-            <a:lstStyle/>
-            <a:p/>
-          </p:txBody>
-        </p:sp>
-        <p:sp>
-          <p:nvSpPr>
-            <p:cNvPr id="70" name="Picto prévenir – trait 2"/>
-            <p:cNvSpPr/>
-            <p:nvPr/>
-          </p:nvSpPr>
-          <p:spPr>
-            <a:xfrm>
-              <a:off x="4124748" y="7504853"/>
-              <a:ext cx="47413" cy="16594"/>
-            </a:xfrm>
-            <a:prstGeom prst="roundRect">
-              <a:avLst>
-                <a:gd name="adj" fmla="val 42857"/>
-              </a:avLst>
-            </a:prstGeom>
-            <a:solidFill>
-              <a:srgbClr val="FFCB1F"/>
-            </a:solidFill>
-            <a:ln>
-              <a:noFill/>
-            </a:ln>
-            <a:effectLst/>
-          </p:spPr>
-          <p:txBody>
-            <a:bodyPr rtlCol="0" anchor="ctr"/>
-            <a:lstStyle/>
-            <a:p/>
-          </p:txBody>
-        </p:sp>
-      </p:grpSp>
-      <p:sp>
-        <p:nvSpPr>
-          <p:cNvPr id="72" name="Carte PRÉVENIR – titre"/>
+          </a:xfrm>
+          <a:prstGeom prst="ellipse">
+            <a:avLst/>
+          </a:prstGeom>
+          <a:solidFill>
+            <a:srgbClr val="26408F"/>
+          </a:solidFill>
+          <a:ln>
+            <a:noFill/>
+          </a:ln>
+          <a:effectLst/>
+        </p:spPr>
+        <p:txBody>
+          <a:bodyPr rtlCol="0" anchor="ctr"/>
+          <a:lstStyle/>
+          <a:p>
+            <a:pPr algn="ctr"/>
+          </a:p>
+        </p:txBody>
+      </p:sp>
+      <p:sp>
+        <p:nvSpPr>
+          <p:cNvPr id="67" name="Picto prévenir – ampoule"/>
+          <p:cNvSpPr/>
+          <p:nvPr/>
+        </p:nvSpPr>
+        <p:spPr>
+          <a:xfrm>
+            <a:off x="4077334" y="7285566"/>
+            <a:ext cx="142240" cy="142240"/>
+          </a:xfrm>
+          <a:prstGeom prst="ellipse">
+            <a:avLst/>
+          </a:prstGeom>
+          <a:solidFill>
+            <a:srgbClr val="FFCB1F"/>
+          </a:solidFill>
+          <a:ln>
+            <a:noFill/>
+          </a:ln>
+          <a:effectLst/>
+        </p:spPr>
+        <p:txBody>
+          <a:bodyPr rtlCol="0" anchor="ctr"/>
+          <a:lstStyle/>
+          <a:p>
+            <a:pPr algn="ctr"/>
+          </a:p>
+        </p:txBody>
+      </p:sp>
+      <p:sp>
+        <p:nvSpPr>
+          <p:cNvPr id="68" name="Picto prévenir – culot"/>
+          <p:cNvSpPr/>
+          <p:nvPr/>
+        </p:nvSpPr>
+        <p:spPr>
+          <a:xfrm>
+            <a:off x="4112894" y="7410026"/>
+            <a:ext cx="71120" cy="59266"/>
+          </a:xfrm>
+          <a:prstGeom prst="rect">
+            <a:avLst/>
+          </a:prstGeom>
+          <a:solidFill>
+            <a:srgbClr val="FFCB1F"/>
+          </a:solidFill>
+          <a:ln>
+            <a:noFill/>
+          </a:ln>
+          <a:effectLst/>
+        </p:spPr>
+        <p:txBody>
+          <a:bodyPr rtlCol="0" anchor="ctr"/>
+          <a:lstStyle/>
+          <a:p/>
+        </p:txBody>
+      </p:sp>
+      <p:sp>
+        <p:nvSpPr>
+          <p:cNvPr id="69" name="Picto prévenir – trait 1"/>
+          <p:cNvSpPr/>
+          <p:nvPr/>
+        </p:nvSpPr>
+        <p:spPr>
+          <a:xfrm>
+            <a:off x="4112894" y="7478776"/>
+            <a:ext cx="71120" cy="16594"/>
+          </a:xfrm>
+          <a:prstGeom prst="rect">
+            <a:avLst/>
+          </a:prstGeom>
+          <a:solidFill>
+            <a:srgbClr val="FFCB1F"/>
+          </a:solidFill>
+          <a:ln>
+            <a:noFill/>
+          </a:ln>
+          <a:effectLst/>
+        </p:spPr>
+        <p:txBody>
+          <a:bodyPr rtlCol="0" anchor="ctr"/>
+          <a:lstStyle/>
+          <a:p/>
+        </p:txBody>
+      </p:sp>
+      <p:sp>
+        <p:nvSpPr>
+          <p:cNvPr id="70" name="Picto prévenir – trait 2"/>
+          <p:cNvSpPr/>
+          <p:nvPr/>
+        </p:nvSpPr>
+        <p:spPr>
+          <a:xfrm>
+            <a:off x="4124748" y="7504853"/>
+            <a:ext cx="47413" cy="16594"/>
+          </a:xfrm>
+          <a:prstGeom prst="rect">
+            <a:avLst/>
+          </a:prstGeom>
+          <a:solidFill>
+            <a:srgbClr val="FFCB1F"/>
+          </a:solidFill>
+          <a:ln>
+            <a:noFill/>
+          </a:ln>
+          <a:effectLst/>
+        </p:spPr>
+        <p:txBody>
+          <a:bodyPr rtlCol="0" anchor="ctr"/>
+          <a:lstStyle/>
+          <a:p/>
+        </p:txBody>
+      </p:sp>
+      <p:sp>
+        <p:nvSpPr>
+          <p:cNvPr id="71" name="Carte PRÉVENIR – titre"/>
           <p:cNvSpPr txBox="1"/>
           <p:nvPr/>
         </p:nvSpPr>
@@ -5631,7 +5504,7 @@
       </p:sp>
       <p:sp>
         <p:nvSpPr>
-          <p:cNvPr id="73" name="Carte PRÉVENIR – texte"/>
+          <p:cNvPr id="72" name="Carte PRÉVENIR – texte"/>
           <p:cNvSpPr txBox="1"/>
           <p:nvPr/>
         </p:nvSpPr>
@@ -5673,7 +5546,7 @@
       </p:sp>
       <p:sp>
         <p:nvSpPr>
-          <p:cNvPr id="74" name="Un impact social documenté"/>
+          <p:cNvPr id="73" name="Un impact social documenté"/>
           <p:cNvSpPr txBox="1"/>
           <p:nvPr/>
         </p:nvSpPr>
@@ -5715,32 +5588,32 @@
       </p:sp>
       <p:grpSp>
         <p:nvGrpSpPr>
-          <p:cNvPr id="78" name="Profil bénéficiaires 1"/>
+          <p:cNvPr id="77" name="Profil bénéficiaires 1"/>
           <p:cNvGrpSpPr/>
           <p:nvPr/>
         </p:nvGrpSpPr>
         <p:grpSpPr>
           <a:xfrm>
             <a:off x="457200" y="8851900"/>
-            <a:ext cx="1585277" cy="508000"/>
+            <a:ext cx="1585277" cy="584200"/>
             <a:chOff x="457200" y="8851900"/>
-            <a:chExt cx="1585277" cy="508000"/>
+            <a:chExt cx="1585277" cy="584200"/>
           </a:xfrm>
         </p:grpSpPr>
         <p:sp>
           <p:nvSpPr>
-            <p:cNvPr id="75" name="Profil 1 – cadre"/>
+            <p:cNvPr id="74" name="Profil 1 – cadre"/>
             <p:cNvSpPr/>
             <p:nvPr/>
           </p:nvSpPr>
           <p:spPr>
             <a:xfrm>
               <a:off x="457200" y="8851900"/>
-              <a:ext cx="1585277" cy="508000"/>
+              <a:ext cx="1585277" cy="584200"/>
             </a:xfrm>
             <a:prstGeom prst="roundRect">
               <a:avLst>
-                <a:gd name="adj" fmla="val 17500"/>
+                <a:gd name="adj" fmla="val 15217"/>
               </a:avLst>
             </a:prstGeom>
             <a:solidFill>
@@ -5761,14 +5634,14 @@
         </p:sp>
         <p:sp>
           <p:nvSpPr>
-            <p:cNvPr id="76" name="Profil 1 – accent"/>
+            <p:cNvPr id="75" name="Profil 1 – accent"/>
             <p:cNvSpPr/>
             <p:nvPr/>
           </p:nvSpPr>
           <p:spPr>
             <a:xfrm>
-              <a:off x="457200" y="8953500"/>
-              <a:ext cx="44450" cy="304800"/>
+              <a:off x="457200" y="8966200"/>
+              <a:ext cx="44450" cy="355600"/>
             </a:xfrm>
             <a:prstGeom prst="rect">
               <a:avLst/>
@@ -5789,14 +5662,14 @@
         </p:sp>
         <p:sp>
           <p:nvSpPr>
-            <p:cNvPr id="77" name="Profil 1"/>
+            <p:cNvPr id="76" name="Profil 1"/>
             <p:cNvSpPr txBox="1"/>
             <p:nvPr/>
           </p:nvSpPr>
           <p:spPr>
             <a:xfrm>
               <a:off x="584200" y="8851900"/>
-              <a:ext cx="1382077" cy="508000"/>
+              <a:ext cx="1407477" cy="584200"/>
             </a:xfrm>
             <a:prstGeom prst="rect">
               <a:avLst/>
@@ -5818,7 +5691,7 @@
                 </a:spcAft>
               </a:pPr>
               <a:r>
-                <a:rPr sz="1600" b="1" i="0">
+                <a:rPr sz="1500" b="1" i="0">
                   <a:solidFill>
                     <a:srgbClr val="EF3F34"/>
                   </a:solidFill>
@@ -5826,6 +5699,16 @@
                 </a:rPr>
                 <a:t>58</a:t>
               </a:r>
+            </a:p>
+            <a:p>
+              <a:pPr algn="l">
+                <a:lnSpc>
+                  <a:spcPct val="100000"/>
+                </a:lnSpc>
+                <a:spcAft>
+                  <a:spcPts val="0"/>
+                </a:spcAft>
+              </a:pPr>
               <a:r>
                 <a:rPr sz="760" b="1" i="0">
                   <a:solidFill>
@@ -5833,7 +5716,7 @@
                   </a:solidFill>
                   <a:latin typeface="Open Sans"/>
                 </a:rPr>
-                <a:t> % de femmes</a:t>
+                <a:t>% de femmes</a:t>
               </a:r>
             </a:p>
           </p:txBody>
@@ -5841,32 +5724,32 @@
       </p:grpSp>
       <p:grpSp>
         <p:nvGrpSpPr>
-          <p:cNvPr id="82" name="Profil bénéficiaires 2"/>
+          <p:cNvPr id="81" name="Profil bénéficiaires 2"/>
           <p:cNvGrpSpPr/>
           <p:nvPr/>
         </p:nvGrpSpPr>
         <p:grpSpPr>
           <a:xfrm>
             <a:off x="2144077" y="8851900"/>
-            <a:ext cx="1585277" cy="508000"/>
+            <a:ext cx="1585277" cy="584200"/>
             <a:chOff x="2144077" y="8851900"/>
-            <a:chExt cx="1585277" cy="508000"/>
+            <a:chExt cx="1585277" cy="584200"/>
           </a:xfrm>
         </p:grpSpPr>
         <p:sp>
           <p:nvSpPr>
-            <p:cNvPr id="79" name="Profil 2 – cadre"/>
+            <p:cNvPr id="78" name="Profil 2 – cadre"/>
             <p:cNvSpPr/>
             <p:nvPr/>
           </p:nvSpPr>
           <p:spPr>
             <a:xfrm>
               <a:off x="2144077" y="8851900"/>
-              <a:ext cx="1585277" cy="508000"/>
+              <a:ext cx="1585277" cy="584200"/>
             </a:xfrm>
             <a:prstGeom prst="roundRect">
               <a:avLst>
-                <a:gd name="adj" fmla="val 17500"/>
+                <a:gd name="adj" fmla="val 15217"/>
               </a:avLst>
             </a:prstGeom>
             <a:solidFill>
@@ -5887,14 +5770,14 @@
         </p:sp>
         <p:sp>
           <p:nvSpPr>
-            <p:cNvPr id="80" name="Profil 2 – accent"/>
+            <p:cNvPr id="79" name="Profil 2 – accent"/>
             <p:cNvSpPr/>
             <p:nvPr/>
           </p:nvSpPr>
           <p:spPr>
             <a:xfrm>
-              <a:off x="2144077" y="8953500"/>
-              <a:ext cx="44450" cy="304800"/>
+              <a:off x="2144077" y="8966200"/>
+              <a:ext cx="44450" cy="355600"/>
             </a:xfrm>
             <a:prstGeom prst="rect">
               <a:avLst/>
@@ -5915,14 +5798,14 @@
         </p:sp>
         <p:sp>
           <p:nvSpPr>
-            <p:cNvPr id="81" name="Profil 2"/>
+            <p:cNvPr id="80" name="Profil 2"/>
             <p:cNvSpPr txBox="1"/>
             <p:nvPr/>
           </p:nvSpPr>
           <p:spPr>
             <a:xfrm>
               <a:off x="2271077" y="8851900"/>
-              <a:ext cx="1382077" cy="508000"/>
+              <a:ext cx="1407477" cy="584200"/>
             </a:xfrm>
             <a:prstGeom prst="rect">
               <a:avLst/>
@@ -5944,7 +5827,7 @@
                 </a:spcAft>
               </a:pPr>
               <a:r>
-                <a:rPr sz="1600" b="1" i="0">
+                <a:rPr sz="1500" b="1" i="0">
                   <a:solidFill>
                     <a:srgbClr val="F89410"/>
                   </a:solidFill>
@@ -5952,6 +5835,16 @@
                 </a:rPr>
                 <a:t>82</a:t>
               </a:r>
+            </a:p>
+            <a:p>
+              <a:pPr algn="l">
+                <a:lnSpc>
+                  <a:spcPct val="100000"/>
+                </a:lnSpc>
+                <a:spcAft>
+                  <a:spcPts val="0"/>
+                </a:spcAft>
+              </a:pPr>
               <a:r>
                 <a:rPr sz="760" b="1" i="0">
                   <a:solidFill>
@@ -5959,7 +5852,7 @@
                   </a:solidFill>
                   <a:latin typeface="Open Sans"/>
                 </a:rPr>
-                <a:t> % d’anciens demandeurs d’emploi</a:t>
+                <a:t>% d’anciens demandeurs d’emploi</a:t>
               </a:r>
             </a:p>
           </p:txBody>
@@ -5967,32 +5860,32 @@
       </p:grpSp>
       <p:grpSp>
         <p:nvGrpSpPr>
-          <p:cNvPr id="86" name="Profil bénéficiaires 3"/>
+          <p:cNvPr id="85" name="Profil bénéficiaires 3"/>
           <p:cNvGrpSpPr/>
           <p:nvPr/>
         </p:nvGrpSpPr>
         <p:grpSpPr>
           <a:xfrm>
             <a:off x="3830954" y="8851900"/>
-            <a:ext cx="1585277" cy="508000"/>
+            <a:ext cx="1585277" cy="584200"/>
             <a:chOff x="3830954" y="8851900"/>
-            <a:chExt cx="1585277" cy="508000"/>
+            <a:chExt cx="1585277" cy="584200"/>
           </a:xfrm>
         </p:grpSpPr>
         <p:sp>
           <p:nvSpPr>
-            <p:cNvPr id="83" name="Profil 3 – cadre"/>
+            <p:cNvPr id="82" name="Profil 3 – cadre"/>
             <p:cNvSpPr/>
             <p:nvPr/>
           </p:nvSpPr>
           <p:spPr>
             <a:xfrm>
               <a:off x="3830954" y="8851900"/>
-              <a:ext cx="1585277" cy="508000"/>
+              <a:ext cx="1585277" cy="584200"/>
             </a:xfrm>
             <a:prstGeom prst="roundRect">
               <a:avLst>
-                <a:gd name="adj" fmla="val 17500"/>
+                <a:gd name="adj" fmla="val 15217"/>
               </a:avLst>
             </a:prstGeom>
             <a:solidFill>
@@ -6013,14 +5906,14 @@
         </p:sp>
         <p:sp>
           <p:nvSpPr>
-            <p:cNvPr id="84" name="Profil 3 – accent"/>
+            <p:cNvPr id="83" name="Profil 3 – accent"/>
             <p:cNvSpPr/>
             <p:nvPr/>
           </p:nvSpPr>
           <p:spPr>
             <a:xfrm>
-              <a:off x="3830954" y="8953500"/>
-              <a:ext cx="44450" cy="304800"/>
+              <a:off x="3830954" y="8966200"/>
+              <a:ext cx="44450" cy="355600"/>
             </a:xfrm>
             <a:prstGeom prst="rect">
               <a:avLst/>
@@ -6041,14 +5934,14 @@
         </p:sp>
         <p:sp>
           <p:nvSpPr>
-            <p:cNvPr id="85" name="Profil 3"/>
+            <p:cNvPr id="84" name="Profil 3"/>
             <p:cNvSpPr txBox="1"/>
             <p:nvPr/>
           </p:nvSpPr>
           <p:spPr>
             <a:xfrm>
               <a:off x="3957954" y="8851900"/>
-              <a:ext cx="1382077" cy="508000"/>
+              <a:ext cx="1407477" cy="584200"/>
             </a:xfrm>
             <a:prstGeom prst="rect">
               <a:avLst/>
@@ -6070,7 +5963,7 @@
                 </a:spcAft>
               </a:pPr>
               <a:r>
-                <a:rPr sz="1600" b="1" i="0">
+                <a:rPr sz="1500" b="1" i="0">
                   <a:solidFill>
                     <a:srgbClr val="26408F"/>
                   </a:solidFill>
@@ -6078,6 +5971,16 @@
                 </a:rPr>
                 <a:t>81</a:t>
               </a:r>
+            </a:p>
+            <a:p>
+              <a:pPr algn="l">
+                <a:lnSpc>
+                  <a:spcPct val="100000"/>
+                </a:lnSpc>
+                <a:spcAft>
+                  <a:spcPts val="0"/>
+                </a:spcAft>
+              </a:pPr>
               <a:r>
                 <a:rPr sz="760" b="1" i="0">
                   <a:solidFill>
@@ -6085,7 +5988,7 @@
                   </a:solidFill>
                   <a:latin typeface="Open Sans"/>
                 </a:rPr>
-                <a:t> % de travailleurs handicapés</a:t>
+                <a:t>% de travailleurs handicapés</a:t>
               </a:r>
             </a:p>
           </p:txBody>
@@ -6093,32 +5996,32 @@
       </p:grpSp>
       <p:grpSp>
         <p:nvGrpSpPr>
-          <p:cNvPr id="90" name="Profil bénéficiaires 4"/>
+          <p:cNvPr id="89" name="Profil bénéficiaires 4"/>
           <p:cNvGrpSpPr/>
           <p:nvPr/>
         </p:nvGrpSpPr>
         <p:grpSpPr>
           <a:xfrm>
             <a:off x="5517832" y="8851900"/>
-            <a:ext cx="1585277" cy="508000"/>
+            <a:ext cx="1585277" cy="584200"/>
             <a:chOff x="5517832" y="8851900"/>
-            <a:chExt cx="1585277" cy="508000"/>
+            <a:chExt cx="1585277" cy="584200"/>
           </a:xfrm>
         </p:grpSpPr>
         <p:sp>
           <p:nvSpPr>
-            <p:cNvPr id="87" name="Profil 4 – cadre"/>
+            <p:cNvPr id="86" name="Profil 4 – cadre"/>
             <p:cNvSpPr/>
             <p:nvPr/>
           </p:nvSpPr>
           <p:spPr>
             <a:xfrm>
               <a:off x="5517832" y="8851900"/>
-              <a:ext cx="1585277" cy="508000"/>
+              <a:ext cx="1585277" cy="584200"/>
             </a:xfrm>
             <a:prstGeom prst="roundRect">
               <a:avLst>
-                <a:gd name="adj" fmla="val 17500"/>
+                <a:gd name="adj" fmla="val 15217"/>
               </a:avLst>
             </a:prstGeom>
             <a:solidFill>
@@ -6139,14 +6042,14 @@
         </p:sp>
         <p:sp>
           <p:nvSpPr>
-            <p:cNvPr id="88" name="Profil 4 – accent"/>
+            <p:cNvPr id="87" name="Profil 4 – accent"/>
             <p:cNvSpPr/>
             <p:nvPr/>
           </p:nvSpPr>
           <p:spPr>
             <a:xfrm>
-              <a:off x="5517832" y="8953500"/>
-              <a:ext cx="44450" cy="304800"/>
+              <a:off x="5517832" y="8966200"/>
+              <a:ext cx="44450" cy="355600"/>
             </a:xfrm>
             <a:prstGeom prst="rect">
               <a:avLst/>
@@ -6167,14 +6070,14 @@
         </p:sp>
         <p:sp>
           <p:nvSpPr>
-            <p:cNvPr id="89" name="Profil 4"/>
+            <p:cNvPr id="88" name="Profil 4"/>
             <p:cNvSpPr txBox="1"/>
             <p:nvPr/>
           </p:nvSpPr>
           <p:spPr>
             <a:xfrm>
               <a:off x="5644832" y="8851900"/>
-              <a:ext cx="1382077" cy="508000"/>
+              <a:ext cx="1407477" cy="584200"/>
             </a:xfrm>
             <a:prstGeom prst="rect">
               <a:avLst/>
@@ -6229,13 +6132,13 @@
       </p:grpSp>
       <p:sp>
         <p:nvSpPr>
-          <p:cNvPr id="91" name="Écosystème – texte"/>
+          <p:cNvPr id="90" name="Écosystème – texte"/>
           <p:cNvSpPr txBox="1"/>
           <p:nvPr/>
         </p:nvSpPr>
         <p:spPr>
           <a:xfrm>
-            <a:off x="457200" y="9499600"/>
+            <a:off x="457200" y="9575800"/>
             <a:ext cx="6645909" cy="635000"/>
           </a:xfrm>
           <a:prstGeom prst="rect">
@@ -6473,7 +6376,7 @@
       </p:sp>
       <p:pic>
         <p:nvPicPr>
-          <p:cNvPr id="7" name="Logo EDLC" descr="1_crop.png"/>
+          <p:cNvPr id="7" name="Logo EDLC" descr="logo_edlc_crop.png"/>
           <p:cNvPicPr>
             <a:picLocks noChangeAspect="1"/>
           </p:cNvPicPr>
@@ -8720,7 +8623,7 @@
       </p:graphicFrame>
       <p:pic>
         <p:nvPicPr>
-          <p:cNvPr id="43" name="Illustration – analyse du document" descr="4.png"/>
+          <p:cNvPr id="43" name="Illustration – analyse du document" descr="analyse_document.png"/>
           <p:cNvPicPr>
             <a:picLocks noChangeAspect="1"/>
           </p:cNvPicPr>
@@ -8948,7 +8851,7 @@
       </p:sp>
       <p:pic>
         <p:nvPicPr>
-          <p:cNvPr id="50" name="Illustration – interlocutrice" descr="5_crop.png"/>
+          <p:cNvPr id="50" name="Illustration – interlocutrice" descr="interlocutrice_crop.png"/>
           <p:cNvPicPr>
             <a:picLocks noChangeAspect="1"/>
           </p:cNvPicPr>
@@ -9072,98 +8975,66 @@
           </a:p>
         </p:txBody>
       </p:sp>
-      <p:grpSp>
-        <p:nvGrpSpPr>
-          <p:cNvPr id="55" name="Pictogramme e-mail"/>
-          <p:cNvGrpSpPr/>
-          <p:nvPr/>
-        </p:nvGrpSpPr>
-        <p:grpSpPr>
+      <p:sp>
+        <p:nvSpPr>
+          <p:cNvPr id="53" name="Picto e-mail – enveloppe"/>
+          <p:cNvSpPr/>
+          <p:nvPr/>
+        </p:nvSpPr>
+        <p:spPr>
           <a:xfrm>
             <a:off x="685800" y="8724900"/>
             <a:ext cx="139700" cy="94996"/>
-            <a:chOff x="685800" y="8724900"/>
-            <a:chExt cx="139700" cy="94996"/>
-          </a:xfrm>
-        </p:grpSpPr>
-        <p:sp>
-          <p:nvSpPr>
-            <p:cNvPr id="53" name="Picto e-mail – enveloppe"/>
-            <p:cNvSpPr/>
-            <p:nvPr/>
-          </p:nvSpPr>
-          <p:spPr>
-            <a:xfrm>
-              <a:off x="685800" y="8724900"/>
-              <a:ext cx="139700" cy="94996"/>
-            </a:xfrm>
-            <a:prstGeom prst="rect">
-              <a:avLst/>
-            </a:prstGeom>
-            <a:noFill/>
-            <a:ln w="11430">
-              <a:solidFill>
-                <a:srgbClr val="FFCB1F"/>
-              </a:solidFill>
-            </a:ln>
-            <a:effectLst/>
-          </p:spPr>
-          <p:txBody>
-            <a:bodyPr rtlCol="0" anchor="ctr"/>
-            <a:lstStyle/>
-            <a:p/>
-          </p:txBody>
-        </p:sp>
-        <p:sp>
-          <p:nvSpPr>
-            <p:cNvPr id="54" name="Picto e-mail – rabat"/>
-            <p:cNvSpPr/>
-            <p:nvPr/>
-          </p:nvSpPr>
-          <p:spPr>
-            <a:xfrm>
-              <a:off x="685800" y="8724900"/>
-              <a:ext cx="139700" cy="52247"/>
-            </a:xfrm>
-            <a:custGeom>
-              <a:avLst/>
-              <a:gdLst/>
-              <a:ahLst/>
-              <a:cxnLst/>
-              <a:rect l="l" t="t" r="r" b="b"/>
-              <a:pathLst>
-                <a:path w="139700" h="52247">
-                  <a:moveTo>
-                    <a:pt x="0" y="0"/>
-                  </a:moveTo>
-                  <a:lnTo>
-                    <a:pt x="69850" y="52247"/>
-                  </a:lnTo>
-                  <a:lnTo>
-                    <a:pt x="139700" y="0"/>
-                  </a:lnTo>
-                </a:path>
-              </a:pathLst>
-            </a:custGeom>
-            <a:noFill/>
-            <a:ln w="11430">
-              <a:solidFill>
-                <a:srgbClr val="FFCB1F"/>
-              </a:solidFill>
-            </a:ln>
-          </p:spPr>
-          <p:txBody>
-            <a:bodyPr rtlCol="0" anchor="ctr"/>
-            <a:lstStyle/>
-            <a:p>
-              <a:pPr algn="ctr"/>
-            </a:p>
-          </p:txBody>
-        </p:sp>
-      </p:grpSp>
-      <p:sp>
-        <p:nvSpPr>
-          <p:cNvPr id="56" name="Contact – e-mail"/>
+          </a:xfrm>
+          <a:prstGeom prst="rect">
+            <a:avLst/>
+          </a:prstGeom>
+          <a:noFill/>
+          <a:ln w="11430">
+            <a:solidFill>
+              <a:srgbClr val="FFCB1F"/>
+            </a:solidFill>
+          </a:ln>
+          <a:effectLst/>
+        </p:spPr>
+        <p:txBody>
+          <a:bodyPr rtlCol="0" anchor="ctr"/>
+          <a:lstStyle/>
+          <a:p/>
+        </p:txBody>
+      </p:sp>
+      <p:sp>
+        <p:nvSpPr>
+          <p:cNvPr id="54" name="Picto e-mail – rabat"/>
+          <p:cNvSpPr/>
+          <p:nvPr/>
+        </p:nvSpPr>
+        <p:spPr>
+          <a:xfrm>
+            <a:off x="685800" y="8724900"/>
+            <a:ext cx="139700" cy="52247"/>
+          </a:xfrm>
+          <a:prstGeom prst="flowChartMerge">
+            <a:avLst/>
+          </a:prstGeom>
+          <a:noFill/>
+          <a:ln w="11430">
+            <a:solidFill>
+              <a:srgbClr val="FFCB1F"/>
+            </a:solidFill>
+          </a:ln>
+        </p:spPr>
+        <p:txBody>
+          <a:bodyPr rtlCol="0" anchor="ctr"/>
+          <a:lstStyle/>
+          <a:p>
+            <a:pPr algn="ctr"/>
+          </a:p>
+        </p:txBody>
+      </p:sp>
+      <p:sp>
+        <p:nvSpPr>
+          <p:cNvPr id="55" name="Contact – e-mail"/>
           <p:cNvSpPr txBox="1"/>
           <p:nvPr/>
         </p:nvSpPr>
@@ -9206,7 +9077,7 @@
       </p:sp>
       <p:cxnSp>
         <p:nvCxnSpPr>
-          <p:cNvPr id="57" name="Contact – séparateur"/>
+          <p:cNvPr id="56" name="Contact – séparateur"/>
           <p:cNvCxnSpPr/>
           <p:nvPr/>
         </p:nvCxnSpPr>
@@ -9225,132 +9096,98 @@
           </a:ln>
         </p:spPr>
       </p:cxnSp>
-      <p:grpSp>
-        <p:nvGrpSpPr>
-          <p:cNvPr id="61" name="Pictogramme adresse"/>
-          <p:cNvGrpSpPr/>
-          <p:nvPr/>
-        </p:nvGrpSpPr>
-        <p:grpSpPr>
+      <p:sp>
+        <p:nvSpPr>
+          <p:cNvPr id="57" name="Picto adresse – pointe"/>
+          <p:cNvSpPr/>
+          <p:nvPr/>
+        </p:nvSpPr>
+        <p:spPr>
+          <a:xfrm>
+            <a:off x="713613" y="9152572"/>
+            <a:ext cx="77724" cy="80962"/>
+          </a:xfrm>
+          <a:prstGeom prst="flowChartMerge">
+            <a:avLst/>
+          </a:prstGeom>
+          <a:solidFill>
+            <a:srgbClr val="FFCB1F"/>
+          </a:solidFill>
+          <a:ln>
+            <a:noFill/>
+          </a:ln>
+        </p:spPr>
+        <p:txBody>
+          <a:bodyPr rtlCol="0" anchor="ctr"/>
+          <a:lstStyle/>
+          <a:p>
+            <a:pPr algn="ctr"/>
+          </a:p>
+        </p:txBody>
+      </p:sp>
+      <p:sp>
+        <p:nvSpPr>
+          <p:cNvPr id="58" name="Picto adresse – tête"/>
+          <p:cNvSpPr/>
+          <p:nvPr/>
+        </p:nvSpPr>
+        <p:spPr>
           <a:xfrm>
             <a:off x="698500" y="9093200"/>
-            <a:ext cx="107950" cy="145732"/>
-            <a:chOff x="698500" y="9093200"/>
-            <a:chExt cx="107950" cy="145732"/>
-          </a:xfrm>
-        </p:grpSpPr>
-        <p:sp>
-          <p:nvSpPr>
-            <p:cNvPr id="58" name="Picto adresse – tête"/>
-            <p:cNvSpPr/>
-            <p:nvPr/>
-          </p:nvSpPr>
-          <p:spPr>
-            <a:xfrm>
-              <a:off x="698500" y="9093200"/>
-              <a:ext cx="107950" cy="107950"/>
-            </a:xfrm>
-            <a:prstGeom prst="ellipse">
-              <a:avLst/>
-            </a:prstGeom>
-            <a:solidFill>
-              <a:srgbClr val="FFCB1F"/>
-            </a:solidFill>
-            <a:ln>
-              <a:noFill/>
-            </a:ln>
-            <a:effectLst/>
-          </p:spPr>
-          <p:txBody>
-            <a:bodyPr rtlCol="0" anchor="ctr"/>
-            <a:lstStyle/>
-            <a:p>
-              <a:pPr algn="ctr"/>
-            </a:p>
-          </p:txBody>
-        </p:sp>
-        <p:sp>
-          <p:nvSpPr>
-            <p:cNvPr id="59" name="Picto adresse – pointe"/>
-            <p:cNvSpPr/>
-            <p:nvPr/>
-          </p:nvSpPr>
-          <p:spPr>
-            <a:xfrm>
-              <a:off x="711454" y="9160129"/>
-              <a:ext cx="82042" cy="78803"/>
-            </a:xfrm>
-            <a:custGeom>
-              <a:avLst/>
-              <a:gdLst/>
-              <a:ahLst/>
-              <a:cxnLst/>
-              <a:rect l="l" t="t" r="r" b="b"/>
-              <a:pathLst>
-                <a:path w="82042" h="78803">
-                  <a:moveTo>
-                    <a:pt x="0" y="0"/>
-                  </a:moveTo>
-                  <a:lnTo>
-                    <a:pt x="82042" y="0"/>
-                  </a:lnTo>
-                  <a:lnTo>
-                    <a:pt x="41021" y="78803"/>
-                  </a:lnTo>
-                  <a:close/>
-                </a:path>
-              </a:pathLst>
-            </a:custGeom>
-            <a:solidFill>
-              <a:srgbClr val="FFCB1F"/>
-            </a:solidFill>
-            <a:ln>
-              <a:noFill/>
-            </a:ln>
-            <a:effectLst/>
-          </p:spPr>
-          <p:txBody>
-            <a:bodyPr rtlCol="0" anchor="ctr"/>
-            <a:lstStyle/>
-            <a:p>
-              <a:pPr algn="ctr"/>
-            </a:p>
-          </p:txBody>
-        </p:sp>
-        <p:sp>
-          <p:nvSpPr>
-            <p:cNvPr id="60" name="Picto adresse – centre"/>
-            <p:cNvSpPr/>
-            <p:nvPr/>
-          </p:nvSpPr>
-          <p:spPr>
-            <a:xfrm>
-              <a:off x="730885" y="9125585"/>
-              <a:ext cx="43180" cy="43180"/>
-            </a:xfrm>
-            <a:prstGeom prst="ellipse">
-              <a:avLst/>
-            </a:prstGeom>
-            <a:solidFill>
-              <a:srgbClr val="26408F"/>
-            </a:solidFill>
-            <a:ln>
-              <a:noFill/>
-            </a:ln>
-            <a:effectLst/>
-          </p:spPr>
-          <p:txBody>
-            <a:bodyPr rtlCol="0" anchor="ctr"/>
-            <a:lstStyle/>
-            <a:p>
-              <a:pPr algn="ctr"/>
-            </a:p>
-          </p:txBody>
-        </p:sp>
-      </p:grpSp>
-      <p:sp>
-        <p:nvSpPr>
-          <p:cNvPr id="62" name="Contact – adresse"/>
+            <a:ext cx="107950" cy="107950"/>
+          </a:xfrm>
+          <a:prstGeom prst="ellipse">
+            <a:avLst/>
+          </a:prstGeom>
+          <a:solidFill>
+            <a:srgbClr val="FFCB1F"/>
+          </a:solidFill>
+          <a:ln>
+            <a:noFill/>
+          </a:ln>
+          <a:effectLst/>
+        </p:spPr>
+        <p:txBody>
+          <a:bodyPr rtlCol="0" anchor="ctr"/>
+          <a:lstStyle/>
+          <a:p>
+            <a:pPr algn="ctr"/>
+          </a:p>
+        </p:txBody>
+      </p:sp>
+      <p:sp>
+        <p:nvSpPr>
+          <p:cNvPr id="59" name="Picto adresse – centre"/>
+          <p:cNvSpPr/>
+          <p:nvPr/>
+        </p:nvSpPr>
+        <p:spPr>
+          <a:xfrm>
+            <a:off x="730885" y="9125585"/>
+            <a:ext cx="43180" cy="43180"/>
+          </a:xfrm>
+          <a:prstGeom prst="ellipse">
+            <a:avLst/>
+          </a:prstGeom>
+          <a:solidFill>
+            <a:srgbClr val="26408F"/>
+          </a:solidFill>
+          <a:ln>
+            <a:noFill/>
+          </a:ln>
+          <a:effectLst/>
+        </p:spPr>
+        <p:txBody>
+          <a:bodyPr rtlCol="0" anchor="ctr"/>
+          <a:lstStyle/>
+          <a:p>
+            <a:pPr algn="ctr"/>
+          </a:p>
+        </p:txBody>
+      </p:sp>
+      <p:sp>
+        <p:nvSpPr>
+          <p:cNvPr id="60" name="Contact – adresse"/>
           <p:cNvSpPr txBox="1"/>
           <p:nvPr/>
         </p:nvSpPr>
@@ -9409,103 +9246,88 @@
           </a:p>
         </p:txBody>
       </p:sp>
-      <p:grpSp>
-        <p:nvGrpSpPr>
-          <p:cNvPr id="66" name="Pictogramme site web"/>
-          <p:cNvGrpSpPr/>
-          <p:nvPr/>
-        </p:nvGrpSpPr>
-        <p:grpSpPr>
+      <p:sp>
+        <p:nvSpPr>
+          <p:cNvPr id="61" name="Picto web – globe"/>
+          <p:cNvSpPr/>
+          <p:nvPr/>
+        </p:nvSpPr>
+        <p:spPr>
           <a:xfrm>
             <a:off x="685800" y="9461500"/>
             <a:ext cx="127000" cy="127000"/>
-            <a:chOff x="685800" y="9461500"/>
-            <a:chExt cx="127000" cy="127000"/>
-          </a:xfrm>
-        </p:grpSpPr>
-        <p:sp>
-          <p:nvSpPr>
-            <p:cNvPr id="63" name="Picto web – globe"/>
-            <p:cNvSpPr/>
-            <p:nvPr/>
-          </p:nvSpPr>
-          <p:spPr>
-            <a:xfrm>
-              <a:off x="685800" y="9461500"/>
-              <a:ext cx="127000" cy="127000"/>
-            </a:xfrm>
-            <a:prstGeom prst="ellipse">
-              <a:avLst/>
-            </a:prstGeom>
-            <a:noFill/>
-            <a:ln w="11430">
-              <a:solidFill>
-                <a:srgbClr val="FFCB1F"/>
-              </a:solidFill>
-            </a:ln>
-          </p:spPr>
-          <p:txBody>
-            <a:bodyPr rtlCol="0" anchor="ctr"/>
-            <a:lstStyle/>
-            <a:p>
-              <a:pPr algn="ctr"/>
-            </a:p>
-          </p:txBody>
-        </p:sp>
-        <p:sp>
-          <p:nvSpPr>
-            <p:cNvPr id="64" name="Picto web – méridien"/>
-            <p:cNvSpPr/>
-            <p:nvPr/>
-          </p:nvSpPr>
-          <p:spPr>
-            <a:xfrm>
-              <a:off x="723900" y="9461500"/>
-              <a:ext cx="50800" cy="127000"/>
-            </a:xfrm>
-            <a:prstGeom prst="ellipse">
-              <a:avLst/>
-            </a:prstGeom>
-            <a:noFill/>
-            <a:ln w="11430">
-              <a:solidFill>
-                <a:srgbClr val="FFCB1F"/>
-              </a:solidFill>
-            </a:ln>
-          </p:spPr>
-          <p:txBody>
-            <a:bodyPr rtlCol="0" anchor="ctr"/>
-            <a:lstStyle/>
-            <a:p>
-              <a:pPr algn="ctr"/>
-            </a:p>
-          </p:txBody>
-        </p:sp>
-        <p:cxnSp>
-          <p:nvCxnSpPr>
-            <p:cNvPr id="65" name="Picto web – équateur"/>
-            <p:cNvCxnSpPr/>
-            <p:nvPr/>
-          </p:nvCxnSpPr>
-          <p:spPr>
-            <a:xfrm>
-              <a:off x="685800" y="9525000"/>
-              <a:ext cx="127000" cy="0"/>
-            </a:xfrm>
-            <a:prstGeom prst="line">
-              <a:avLst/>
-            </a:prstGeom>
-            <a:ln w="11430">
-              <a:solidFill>
-                <a:srgbClr val="FFCB1F"/>
-              </a:solidFill>
-            </a:ln>
-          </p:spPr>
-        </p:cxnSp>
-      </p:grpSp>
-      <p:sp>
-        <p:nvSpPr>
-          <p:cNvPr id="67" name="Contact – site web"/>
+          </a:xfrm>
+          <a:prstGeom prst="ellipse">
+            <a:avLst/>
+          </a:prstGeom>
+          <a:noFill/>
+          <a:ln w="11430">
+            <a:solidFill>
+              <a:srgbClr val="FFCB1F"/>
+            </a:solidFill>
+          </a:ln>
+        </p:spPr>
+        <p:txBody>
+          <a:bodyPr rtlCol="0" anchor="ctr"/>
+          <a:lstStyle/>
+          <a:p>
+            <a:pPr algn="ctr"/>
+          </a:p>
+        </p:txBody>
+      </p:sp>
+      <p:sp>
+        <p:nvSpPr>
+          <p:cNvPr id="62" name="Picto web – méridien"/>
+          <p:cNvSpPr/>
+          <p:nvPr/>
+        </p:nvSpPr>
+        <p:spPr>
+          <a:xfrm>
+            <a:off x="723900" y="9461500"/>
+            <a:ext cx="50800" cy="127000"/>
+          </a:xfrm>
+          <a:prstGeom prst="ellipse">
+            <a:avLst/>
+          </a:prstGeom>
+          <a:noFill/>
+          <a:ln w="11430">
+            <a:solidFill>
+              <a:srgbClr val="FFCB1F"/>
+            </a:solidFill>
+          </a:ln>
+        </p:spPr>
+        <p:txBody>
+          <a:bodyPr rtlCol="0" anchor="ctr"/>
+          <a:lstStyle/>
+          <a:p>
+            <a:pPr algn="ctr"/>
+          </a:p>
+        </p:txBody>
+      </p:sp>
+      <p:cxnSp>
+        <p:nvCxnSpPr>
+          <p:cNvPr id="63" name="Picto web – équateur"/>
+          <p:cNvCxnSpPr/>
+          <p:nvPr/>
+        </p:nvCxnSpPr>
+        <p:spPr>
+          <a:xfrm>
+            <a:off x="685800" y="9525000"/>
+            <a:ext cx="127000" cy="0"/>
+          </a:xfrm>
+          <a:prstGeom prst="line">
+            <a:avLst/>
+          </a:prstGeom>
+          <a:ln w="11430">
+            <a:solidFill>
+              <a:srgbClr val="FFCB1F"/>
+            </a:solidFill>
+          </a:ln>
+        </p:spPr>
+      </p:cxnSp>
+      <p:sp>
+        <p:nvSpPr>
+          <p:cNvPr id="64" name="Contact – site web"/>
           <p:cNvSpPr txBox="1"/>
           <p:nvPr/>
         </p:nvSpPr>
@@ -9548,7 +9370,7 @@
       </p:sp>
       <p:sp>
         <p:nvSpPr>
-          <p:cNvPr id="68" name="Contact – accroche"/>
+          <p:cNvPr id="65" name="Contact – accroche"/>
           <p:cNvSpPr txBox="1"/>
           <p:nvPr/>
         </p:nvSpPr>

</xml_diff>

<commit_message>
Plaquette EDLC : texte et ordre strictement identiques au Word
Co-Authored-By: Claude Opus 5.5 <noreply@anthropic.com>
Claude-Session: https://claude.ai/code/session_013b5GF7ZW93Jhurg8kHyqui
</commit_message>
<xml_diff>
--- a/edlc-plaquette/EDLC_Plaquette_mecenat.pptx
+++ b/edlc-plaquette/EDLC_Plaquette_mecenat.pptx
@@ -3159,123 +3159,9 @@
           </a:p>
         </p:txBody>
       </p:sp>
-      <p:cxnSp>
-        <p:nvCxnSpPr>
-          <p:cNvPr id="4" name="Pied de page – filet"/>
-          <p:cNvCxnSpPr/>
-          <p:nvPr/>
-        </p:nvCxnSpPr>
-        <p:spPr>
-          <a:xfrm>
-            <a:off x="457200" y="10260330"/>
-            <a:ext cx="6645909" cy="0"/>
-          </a:xfrm>
-          <a:prstGeom prst="line">
-            <a:avLst/>
-          </a:prstGeom>
-          <a:ln w="9525">
-            <a:solidFill>
-              <a:srgbClr val="EF3F34"/>
-            </a:solidFill>
-          </a:ln>
-        </p:spPr>
-      </p:cxnSp>
-      <p:sp>
-        <p:nvSpPr>
-          <p:cNvPr id="5" name="Pied de page"/>
-          <p:cNvSpPr txBox="1"/>
-          <p:nvPr/>
-        </p:nvSpPr>
-        <p:spPr>
-          <a:xfrm>
-            <a:off x="457200" y="10349230"/>
-            <a:ext cx="6645909" cy="127000"/>
-          </a:xfrm>
-          <a:prstGeom prst="rect">
-            <a:avLst/>
-          </a:prstGeom>
-          <a:noFill/>
-        </p:spPr>
-        <p:txBody>
-          <a:bodyPr wrap="square" lIns="0" rIns="0" tIns="0" bIns="0" anchor="t">
-            <a:noAutofit/>
-          </a:bodyPr>
-          <a:lstStyle/>
-          <a:p>
-            <a:pPr algn="ctr">
-              <a:lnSpc>
-                <a:spcPct val="120000"/>
-              </a:lnSpc>
-              <a:spcAft>
-                <a:spcPts val="0"/>
-              </a:spcAft>
-            </a:pPr>
-            <a:r>
-              <a:rPr sz="680" b="1" i="0" spc="30">
-                <a:solidFill>
-                  <a:srgbClr val="EF3F34"/>
-                </a:solidFill>
-                <a:latin typeface="Open Sans"/>
-              </a:rPr>
-              <a:t>ENTREPRENEURS DE LA CITÉ</a:t>
-            </a:r>
-            <a:r>
-              <a:rPr sz="680" b="0" i="0" spc="30">
-                <a:solidFill>
-                  <a:srgbClr val="6B6B6B"/>
-                </a:solidFill>
-                <a:latin typeface="Open Sans"/>
-              </a:rPr>
-              <a:t>  •  Prévenir, protéger, pérenniser</a:t>
-            </a:r>
-          </a:p>
-        </p:txBody>
-      </p:sp>
-      <p:sp>
-        <p:nvSpPr>
-          <p:cNvPr id="6" name="Numéro de page"/>
-          <p:cNvSpPr txBox="1"/>
-          <p:nvPr/>
-        </p:nvSpPr>
-        <p:spPr>
-          <a:xfrm>
-            <a:off x="6849109" y="10349230"/>
-            <a:ext cx="254000" cy="127000"/>
-          </a:xfrm>
-          <a:prstGeom prst="rect">
-            <a:avLst/>
-          </a:prstGeom>
-          <a:noFill/>
-        </p:spPr>
-        <p:txBody>
-          <a:bodyPr wrap="square" lIns="0" rIns="0" tIns="0" bIns="0" anchor="t">
-            <a:noAutofit/>
-          </a:bodyPr>
-          <a:lstStyle/>
-          <a:p>
-            <a:pPr algn="r">
-              <a:lnSpc>
-                <a:spcPct val="120000"/>
-              </a:lnSpc>
-              <a:spcAft>
-                <a:spcPts val="0"/>
-              </a:spcAft>
-            </a:pPr>
-            <a:r>
-              <a:rPr sz="680" b="1" i="0">
-                <a:solidFill>
-                  <a:srgbClr val="6B6B6B"/>
-                </a:solidFill>
-                <a:latin typeface="Open Sans"/>
-              </a:rPr>
-              <a:t>1</a:t>
-            </a:r>
-          </a:p>
-        </p:txBody>
-      </p:sp>
       <p:pic>
         <p:nvPicPr>
-          <p:cNvPr id="7" name="Logo EDLC" descr="logo_edlc_crop.png"/>
+          <p:cNvPr id="4" name="Logo EDLC" descr="logo_edlc_crop.png"/>
           <p:cNvPicPr>
             <a:picLocks noChangeAspect="1"/>
           </p:cNvPicPr>
@@ -3299,7 +3185,7 @@
       </p:pic>
       <p:sp>
         <p:nvSpPr>
-          <p:cNvPr id="8" name="Décor – cercle jaune"/>
+          <p:cNvPr id="5" name="Décor – cercle jaune"/>
           <p:cNvSpPr/>
           <p:nvPr/>
         </p:nvSpPr>
@@ -3329,7 +3215,7 @@
       </p:sp>
       <p:pic>
         <p:nvPicPr>
-          <p:cNvPr id="9" name="Illustration – entrepreneur et maison" descr="entrepreneur_maison.png"/>
+          <p:cNvPr id="6" name="Illustration – entrepreneur et maison" descr="entrepreneur_maison.png"/>
           <p:cNvPicPr>
             <a:picLocks noChangeAspect="1"/>
           </p:cNvPicPr>
@@ -3353,7 +3239,7 @@
       </p:pic>
       <p:sp>
         <p:nvSpPr>
-          <p:cNvPr id="10" name="Surtitre"/>
+          <p:cNvPr id="7" name="Surtitre"/>
           <p:cNvSpPr txBox="1"/>
           <p:nvPr/>
         </p:nvSpPr>
@@ -3395,7 +3281,7 @@
       </p:sp>
       <p:sp>
         <p:nvSpPr>
-          <p:cNvPr id="11" name="Titre principal"/>
+          <p:cNvPr id="8" name="Titre principal"/>
           <p:cNvSpPr txBox="1"/>
           <p:nvPr/>
         </p:nvSpPr>
@@ -3437,7 +3323,7 @@
       </p:sp>
       <p:sp>
         <p:nvSpPr>
-          <p:cNvPr id="12" name="Sous-titre"/>
+          <p:cNvPr id="9" name="Sous-titre"/>
           <p:cNvSpPr txBox="1"/>
           <p:nvPr/>
         </p:nvSpPr>
@@ -3477,103 +3363,16 @@
           </a:p>
         </p:txBody>
       </p:sp>
-      <p:grpSp>
-        <p:nvGrpSpPr>
-          <p:cNvPr id="15" name="Pilier PRÉVENIR"/>
-          <p:cNvGrpSpPr/>
-          <p:nvPr/>
-        </p:nvGrpSpPr>
-        <p:grpSpPr>
-          <a:xfrm>
-            <a:off x="457200" y="2794000"/>
-            <a:ext cx="683260" cy="215900"/>
-            <a:chOff x="457200" y="2794000"/>
-            <a:chExt cx="683260" cy="215900"/>
-          </a:xfrm>
-        </p:grpSpPr>
-        <p:sp>
-          <p:nvSpPr>
-            <p:cNvPr id="13" name="Pilier PRÉVENIR – fond"/>
-            <p:cNvSpPr/>
-            <p:nvPr/>
-          </p:nvSpPr>
-          <p:spPr>
-            <a:xfrm>
-              <a:off x="457200" y="2794000"/>
-              <a:ext cx="683260" cy="215900"/>
-            </a:xfrm>
-            <a:prstGeom prst="roundRect">
-              <a:avLst>
-                <a:gd name="adj" fmla="val 50000"/>
-              </a:avLst>
-            </a:prstGeom>
-            <a:solidFill>
-              <a:srgbClr val="FFCB1F"/>
-            </a:solidFill>
-            <a:ln>
-              <a:noFill/>
-            </a:ln>
-            <a:effectLst/>
-          </p:spPr>
-          <p:txBody>
-            <a:bodyPr rtlCol="0" anchor="ctr"/>
-            <a:lstStyle/>
-            <a:p/>
-          </p:txBody>
-        </p:sp>
-        <p:sp>
-          <p:nvSpPr>
-            <p:cNvPr id="14" name="Pilier PRÉVENIR"/>
-            <p:cNvSpPr txBox="1"/>
-            <p:nvPr/>
-          </p:nvSpPr>
-          <p:spPr>
-            <a:xfrm>
-              <a:off x="457200" y="2794000"/>
-              <a:ext cx="683260" cy="215900"/>
-            </a:xfrm>
-            <a:prstGeom prst="rect">
-              <a:avLst/>
-            </a:prstGeom>
-            <a:noFill/>
-          </p:spPr>
-          <p:txBody>
-            <a:bodyPr wrap="square" lIns="0" rIns="0" tIns="0" bIns="0" anchor="ctr">
-              <a:noAutofit/>
-            </a:bodyPr>
-            <a:lstStyle/>
-            <a:p>
-              <a:pPr algn="ctr">
-                <a:lnSpc>
-                  <a:spcPct val="120000"/>
-                </a:lnSpc>
-                <a:spcAft>
-                  <a:spcPts val="0"/>
-                </a:spcAft>
-              </a:pPr>
-              <a:r>
-                <a:rPr sz="750" b="1" i="0" spc="80">
-                  <a:solidFill>
-                    <a:srgbClr val="26408F"/>
-                  </a:solidFill>
-                  <a:latin typeface="Open Sans"/>
-                </a:rPr>
-                <a:t>PRÉVENIR</a:t>
-              </a:r>
-            </a:p>
-          </p:txBody>
-        </p:sp>
-      </p:grpSp>
-      <p:sp>
-        <p:nvSpPr>
-          <p:cNvPr id="16" name="Séparateur piliers"/>
+      <p:sp>
+        <p:nvSpPr>
+          <p:cNvPr id="10" name="Piliers"/>
           <p:cNvSpPr txBox="1"/>
           <p:nvPr/>
         </p:nvSpPr>
         <p:spPr>
           <a:xfrm>
-            <a:off x="1191260" y="2794000"/>
-            <a:ext cx="101600" cy="215900"/>
+            <a:off x="457200" y="2794000"/>
+            <a:ext cx="4762500" cy="203200"/>
           </a:xfrm>
           <a:prstGeom prst="rect">
             <a:avLst/>
@@ -3586,7 +3385,7 @@
           </a:bodyPr>
           <a:lstStyle/>
           <a:p>
-            <a:pPr algn="ctr">
+            <a:pPr algn="l">
               <a:lnSpc>
                 <a:spcPct val="120000"/>
               </a:lnSpc>
@@ -3595,236 +3394,56 @@
               </a:spcAft>
             </a:pPr>
             <a:r>
-              <a:rPr sz="900" b="1" i="0">
+              <a:rPr sz="950" b="1" i="0" spc="100">
+                <a:solidFill>
+                  <a:srgbClr val="26408F"/>
+                </a:solidFill>
+                <a:latin typeface="Open Sans"/>
+              </a:rPr>
+              <a:t>PRÉVENIR</a:t>
+            </a:r>
+            <a:r>
+              <a:rPr sz="950" b="1" i="0" spc="100">
                 <a:solidFill>
                   <a:srgbClr val="EF3F34"/>
                 </a:solidFill>
                 <a:latin typeface="Open Sans"/>
               </a:rPr>
-              <a:t>•</a:t>
-            </a:r>
-          </a:p>
-        </p:txBody>
-      </p:sp>
-      <p:grpSp>
-        <p:nvGrpSpPr>
-          <p:cNvPr id="19" name="Pilier PROTÉGER"/>
-          <p:cNvGrpSpPr/>
-          <p:nvPr/>
-        </p:nvGrpSpPr>
-        <p:grpSpPr>
-          <a:xfrm>
-            <a:off x="1343660" y="2794000"/>
-            <a:ext cx="683260" cy="215900"/>
-            <a:chOff x="1343660" y="2794000"/>
-            <a:chExt cx="683260" cy="215900"/>
-          </a:xfrm>
-        </p:grpSpPr>
-        <p:sp>
-          <p:nvSpPr>
-            <p:cNvPr id="17" name="Pilier PROTÉGER – fond"/>
-            <p:cNvSpPr/>
-            <p:nvPr/>
-          </p:nvSpPr>
-          <p:spPr>
-            <a:xfrm>
-              <a:off x="1343660" y="2794000"/>
-              <a:ext cx="683260" cy="215900"/>
-            </a:xfrm>
-            <a:prstGeom prst="roundRect">
-              <a:avLst>
-                <a:gd name="adj" fmla="val 50000"/>
-              </a:avLst>
-            </a:prstGeom>
-            <a:solidFill>
-              <a:srgbClr val="EF3F34"/>
-            </a:solidFill>
-            <a:ln>
-              <a:noFill/>
-            </a:ln>
-            <a:effectLst/>
-          </p:spPr>
-          <p:txBody>
-            <a:bodyPr rtlCol="0" anchor="ctr"/>
-            <a:lstStyle/>
-            <a:p/>
-          </p:txBody>
-        </p:sp>
-        <p:sp>
-          <p:nvSpPr>
-            <p:cNvPr id="18" name="Pilier PROTÉGER"/>
-            <p:cNvSpPr txBox="1"/>
-            <p:nvPr/>
-          </p:nvSpPr>
-          <p:spPr>
-            <a:xfrm>
-              <a:off x="1343660" y="2794000"/>
-              <a:ext cx="683260" cy="215900"/>
-            </a:xfrm>
-            <a:prstGeom prst="rect">
-              <a:avLst/>
-            </a:prstGeom>
-            <a:noFill/>
-          </p:spPr>
-          <p:txBody>
-            <a:bodyPr wrap="square" lIns="0" rIns="0" tIns="0" bIns="0" anchor="ctr">
-              <a:noAutofit/>
-            </a:bodyPr>
-            <a:lstStyle/>
-            <a:p>
-              <a:pPr algn="ctr">
-                <a:lnSpc>
-                  <a:spcPct val="120000"/>
-                </a:lnSpc>
-                <a:spcAft>
-                  <a:spcPts val="0"/>
-                </a:spcAft>
-              </a:pPr>
-              <a:r>
-                <a:rPr sz="750" b="1" i="0" spc="80">
-                  <a:solidFill>
-                    <a:srgbClr val="FFFFFF"/>
-                  </a:solidFill>
-                  <a:latin typeface="Open Sans"/>
-                </a:rPr>
-                <a:t>PROTÉGER</a:t>
-              </a:r>
-            </a:p>
-          </p:txBody>
-        </p:sp>
-      </p:grpSp>
-      <p:sp>
-        <p:nvSpPr>
-          <p:cNvPr id="20" name="Séparateur piliers"/>
-          <p:cNvSpPr txBox="1"/>
-          <p:nvPr/>
-        </p:nvSpPr>
-        <p:spPr>
-          <a:xfrm>
-            <a:off x="2077720" y="2794000"/>
-            <a:ext cx="101600" cy="215900"/>
-          </a:xfrm>
-          <a:prstGeom prst="rect">
-            <a:avLst/>
-          </a:prstGeom>
-          <a:noFill/>
-        </p:spPr>
-        <p:txBody>
-          <a:bodyPr wrap="square" lIns="0" rIns="0" tIns="0" bIns="0" anchor="ctr">
-            <a:noAutofit/>
-          </a:bodyPr>
-          <a:lstStyle/>
-          <a:p>
-            <a:pPr algn="ctr">
-              <a:lnSpc>
-                <a:spcPct val="120000"/>
-              </a:lnSpc>
-              <a:spcAft>
-                <a:spcPts val="0"/>
-              </a:spcAft>
-            </a:pPr>
-            <a:r>
-              <a:rPr sz="900" b="1" i="0">
+              <a:t>  •  </a:t>
+            </a:r>
+            <a:r>
+              <a:rPr sz="950" b="1" i="0" spc="100">
+                <a:solidFill>
+                  <a:srgbClr val="26408F"/>
+                </a:solidFill>
+                <a:latin typeface="Open Sans"/>
+              </a:rPr>
+              <a:t>PROTÉGER</a:t>
+            </a:r>
+            <a:r>
+              <a:rPr sz="950" b="1" i="0" spc="100">
                 <a:solidFill>
                   <a:srgbClr val="EF3F34"/>
                 </a:solidFill>
                 <a:latin typeface="Open Sans"/>
               </a:rPr>
-              <a:t>•</a:t>
-            </a:r>
-          </a:p>
-        </p:txBody>
-      </p:sp>
-      <p:grpSp>
-        <p:nvGrpSpPr>
-          <p:cNvPr id="23" name="Pilier PÉRENNISER"/>
-          <p:cNvGrpSpPr/>
-          <p:nvPr/>
-        </p:nvGrpSpPr>
-        <p:grpSpPr>
-          <a:xfrm>
-            <a:off x="2230120" y="2794000"/>
-            <a:ext cx="825500" cy="215900"/>
-            <a:chOff x="2230120" y="2794000"/>
-            <a:chExt cx="825500" cy="215900"/>
-          </a:xfrm>
-        </p:grpSpPr>
-        <p:sp>
-          <p:nvSpPr>
-            <p:cNvPr id="21" name="Pilier PÉRENNISER – fond"/>
-            <p:cNvSpPr/>
-            <p:nvPr/>
-          </p:nvSpPr>
-          <p:spPr>
-            <a:xfrm>
-              <a:off x="2230120" y="2794000"/>
-              <a:ext cx="825500" cy="215900"/>
-            </a:xfrm>
-            <a:prstGeom prst="roundRect">
-              <a:avLst>
-                <a:gd name="adj" fmla="val 50000"/>
-              </a:avLst>
-            </a:prstGeom>
-            <a:solidFill>
-              <a:srgbClr val="26408F"/>
-            </a:solidFill>
-            <a:ln>
-              <a:noFill/>
-            </a:ln>
-            <a:effectLst/>
-          </p:spPr>
-          <p:txBody>
-            <a:bodyPr rtlCol="0" anchor="ctr"/>
-            <a:lstStyle/>
-            <a:p/>
-          </p:txBody>
-        </p:sp>
-        <p:sp>
-          <p:nvSpPr>
-            <p:cNvPr id="22" name="Pilier PÉRENNISER"/>
-            <p:cNvSpPr txBox="1"/>
-            <p:nvPr/>
-          </p:nvSpPr>
-          <p:spPr>
-            <a:xfrm>
-              <a:off x="2230120" y="2794000"/>
-              <a:ext cx="825500" cy="215900"/>
-            </a:xfrm>
-            <a:prstGeom prst="rect">
-              <a:avLst/>
-            </a:prstGeom>
-            <a:noFill/>
-          </p:spPr>
-          <p:txBody>
-            <a:bodyPr wrap="square" lIns="0" rIns="0" tIns="0" bIns="0" anchor="ctr">
-              <a:noAutofit/>
-            </a:bodyPr>
-            <a:lstStyle/>
-            <a:p>
-              <a:pPr algn="ctr">
-                <a:lnSpc>
-                  <a:spcPct val="120000"/>
-                </a:lnSpc>
-                <a:spcAft>
-                  <a:spcPts val="0"/>
-                </a:spcAft>
-              </a:pPr>
-              <a:r>
-                <a:rPr sz="750" b="1" i="0" spc="80">
-                  <a:solidFill>
-                    <a:srgbClr val="FFFFFF"/>
-                  </a:solidFill>
-                  <a:latin typeface="Open Sans"/>
-                </a:rPr>
-                <a:t>PÉRENNISER</a:t>
-              </a:r>
-            </a:p>
-          </p:txBody>
-        </p:sp>
-      </p:grpSp>
-      <p:sp>
-        <p:nvSpPr>
-          <p:cNvPr id="24" name="Introduction – filet"/>
+              <a:t>  •  </a:t>
+            </a:r>
+            <a:r>
+              <a:rPr sz="950" b="1" i="0" spc="100">
+                <a:solidFill>
+                  <a:srgbClr val="26408F"/>
+                </a:solidFill>
+                <a:latin typeface="Open Sans"/>
+              </a:rPr>
+              <a:t>PÉRENNISER</a:t>
+            </a:r>
+          </a:p>
+        </p:txBody>
+      </p:sp>
+      <p:sp>
+        <p:nvSpPr>
+          <p:cNvPr id="11" name="Introduction – filet"/>
           <p:cNvSpPr/>
           <p:nvPr/>
         </p:nvSpPr>
@@ -3852,7 +3471,7 @@
       </p:sp>
       <p:sp>
         <p:nvSpPr>
-          <p:cNvPr id="25" name="Introduction"/>
+          <p:cNvPr id="12" name="Introduction"/>
           <p:cNvSpPr txBox="1"/>
           <p:nvPr/>
         </p:nvSpPr>
@@ -3894,7 +3513,7 @@
       </p:sp>
       <p:grpSp>
         <p:nvGrpSpPr>
-          <p:cNvPr id="29" name="Chiffre clé 3 362"/>
+          <p:cNvPr id="16" name="Chiffre clé 3 362"/>
           <p:cNvGrpSpPr/>
           <p:nvPr/>
         </p:nvGrpSpPr>
@@ -3908,7 +3527,7 @@
         </p:grpSpPr>
         <p:sp>
           <p:nvSpPr>
-            <p:cNvPr id="26" name="Chiffre 3 362 – fond"/>
+            <p:cNvPr id="13" name="Chiffre 3 362 – fond"/>
             <p:cNvSpPr/>
             <p:nvPr/>
           </p:nvSpPr>
@@ -3938,7 +3557,7 @@
         </p:sp>
         <p:sp>
           <p:nvSpPr>
-            <p:cNvPr id="27" name="Chiffre 3 362"/>
+            <p:cNvPr id="14" name="Chiffre 3 362"/>
             <p:cNvSpPr txBox="1"/>
             <p:nvPr/>
           </p:nvSpPr>
@@ -3980,7 +3599,7 @@
         </p:sp>
         <p:sp>
           <p:nvSpPr>
-            <p:cNvPr id="28" name="Chiffre 3 362 – légende"/>
+            <p:cNvPr id="15" name="Chiffre 3 362 – légende"/>
             <p:cNvSpPr txBox="1"/>
             <p:nvPr/>
           </p:nvSpPr>
@@ -4042,7 +3661,7 @@
       </p:grpSp>
       <p:grpSp>
         <p:nvGrpSpPr>
-          <p:cNvPr id="33" name="Chiffre clé 2 544"/>
+          <p:cNvPr id="20" name="Chiffre clé 2 544"/>
           <p:cNvGrpSpPr/>
           <p:nvPr/>
         </p:nvGrpSpPr>
@@ -4056,7 +3675,7 @@
         </p:grpSpPr>
         <p:sp>
           <p:nvSpPr>
-            <p:cNvPr id="30" name="Chiffre 2 544 – fond"/>
+            <p:cNvPr id="17" name="Chiffre 2 544 – fond"/>
             <p:cNvSpPr/>
             <p:nvPr/>
           </p:nvSpPr>
@@ -4086,7 +3705,7 @@
         </p:sp>
         <p:sp>
           <p:nvSpPr>
-            <p:cNvPr id="31" name="Chiffre 2 544"/>
+            <p:cNvPr id="18" name="Chiffre 2 544"/>
             <p:cNvSpPr txBox="1"/>
             <p:nvPr/>
           </p:nvSpPr>
@@ -4128,7 +3747,7 @@
         </p:sp>
         <p:sp>
           <p:nvSpPr>
-            <p:cNvPr id="32" name="Chiffre 2 544 – légende"/>
+            <p:cNvPr id="19" name="Chiffre 2 544 – légende"/>
             <p:cNvSpPr txBox="1"/>
             <p:nvPr/>
           </p:nvSpPr>
@@ -4190,7 +3809,7 @@
       </p:grpSp>
       <p:grpSp>
         <p:nvGrpSpPr>
-          <p:cNvPr id="37" name="Chiffre clé 89 %"/>
+          <p:cNvPr id="24" name="Chiffre clé 89 %"/>
           <p:cNvGrpSpPr/>
           <p:nvPr/>
         </p:nvGrpSpPr>
@@ -4204,7 +3823,7 @@
         </p:grpSpPr>
         <p:sp>
           <p:nvSpPr>
-            <p:cNvPr id="34" name="Chiffre 89 % – fond"/>
+            <p:cNvPr id="21" name="Chiffre 89 % – fond"/>
             <p:cNvSpPr/>
             <p:nvPr/>
           </p:nvSpPr>
@@ -4234,7 +3853,7 @@
         </p:sp>
         <p:sp>
           <p:nvSpPr>
-            <p:cNvPr id="35" name="Chiffre 89 %"/>
+            <p:cNvPr id="22" name="Chiffre 89 %"/>
             <p:cNvSpPr txBox="1"/>
             <p:nvPr/>
           </p:nvSpPr>
@@ -4276,7 +3895,7 @@
         </p:sp>
         <p:sp>
           <p:nvSpPr>
-            <p:cNvPr id="36" name="Chiffre 89 % – légende"/>
+            <p:cNvPr id="23" name="Chiffre 89 % – légende"/>
             <p:cNvSpPr txBox="1"/>
             <p:nvPr/>
           </p:nvSpPr>
@@ -4338,7 +3957,7 @@
       </p:grpSp>
       <p:grpSp>
         <p:nvGrpSpPr>
-          <p:cNvPr id="41" name="Chiffre clé 350+"/>
+          <p:cNvPr id="28" name="Chiffre clé 350+"/>
           <p:cNvGrpSpPr/>
           <p:nvPr/>
         </p:nvGrpSpPr>
@@ -4352,7 +3971,7 @@
         </p:grpSpPr>
         <p:sp>
           <p:nvSpPr>
-            <p:cNvPr id="38" name="Chiffre 350+ – fond"/>
+            <p:cNvPr id="25" name="Chiffre 350+ – fond"/>
             <p:cNvSpPr/>
             <p:nvPr/>
           </p:nvSpPr>
@@ -4382,7 +4001,7 @@
         </p:sp>
         <p:sp>
           <p:nvSpPr>
-            <p:cNvPr id="39" name="Chiffre 350+"/>
+            <p:cNvPr id="26" name="Chiffre 350+"/>
             <p:cNvSpPr txBox="1"/>
             <p:nvPr/>
           </p:nvSpPr>
@@ -4424,7 +4043,7 @@
         </p:sp>
         <p:sp>
           <p:nvSpPr>
-            <p:cNvPr id="40" name="Chiffre 350+ – légende"/>
+            <p:cNvPr id="27" name="Chiffre 350+ – légende"/>
             <p:cNvSpPr txBox="1"/>
             <p:nvPr/>
           </p:nvSpPr>
@@ -4486,7 +4105,7 @@
       </p:grpSp>
       <p:grpSp>
         <p:nvGrpSpPr>
-          <p:cNvPr id="45" name="Chiffre clé 11 741"/>
+          <p:cNvPr id="32" name="Chiffre clé 11 741"/>
           <p:cNvGrpSpPr/>
           <p:nvPr/>
         </p:nvGrpSpPr>
@@ -4500,7 +4119,7 @@
         </p:grpSpPr>
         <p:sp>
           <p:nvSpPr>
-            <p:cNvPr id="42" name="Chiffre 11 741 – fond"/>
+            <p:cNvPr id="29" name="Chiffre 11 741 – fond"/>
             <p:cNvSpPr/>
             <p:nvPr/>
           </p:nvSpPr>
@@ -4530,7 +4149,7 @@
         </p:sp>
         <p:sp>
           <p:nvSpPr>
-            <p:cNvPr id="43" name="Chiffre 11 741"/>
+            <p:cNvPr id="30" name="Chiffre 11 741"/>
             <p:cNvSpPr txBox="1"/>
             <p:nvPr/>
           </p:nvSpPr>
@@ -4572,7 +4191,7 @@
         </p:sp>
         <p:sp>
           <p:nvSpPr>
-            <p:cNvPr id="44" name="Chiffre 11 741 – légende"/>
+            <p:cNvPr id="31" name="Chiffre 11 741 – légende"/>
             <p:cNvSpPr txBox="1"/>
             <p:nvPr/>
           </p:nvSpPr>
@@ -4615,7 +4234,7 @@
       </p:grpSp>
       <p:grpSp>
         <p:nvGrpSpPr>
-          <p:cNvPr id="49" name="Chiffre clé 38 816"/>
+          <p:cNvPr id="36" name="Chiffre clé 38 816"/>
           <p:cNvGrpSpPr/>
           <p:nvPr/>
         </p:nvGrpSpPr>
@@ -4629,7 +4248,7 @@
         </p:grpSpPr>
         <p:sp>
           <p:nvSpPr>
-            <p:cNvPr id="46" name="Chiffre 38 816 – fond"/>
+            <p:cNvPr id="33" name="Chiffre 38 816 – fond"/>
             <p:cNvSpPr/>
             <p:nvPr/>
           </p:nvSpPr>
@@ -4659,7 +4278,7 @@
         </p:sp>
         <p:sp>
           <p:nvSpPr>
-            <p:cNvPr id="47" name="Chiffre 38 816"/>
+            <p:cNvPr id="34" name="Chiffre 38 816"/>
             <p:cNvSpPr txBox="1"/>
             <p:nvPr/>
           </p:nvSpPr>
@@ -4701,7 +4320,7 @@
         </p:sp>
         <p:sp>
           <p:nvSpPr>
-            <p:cNvPr id="48" name="Chiffre 38 816 – légende"/>
+            <p:cNvPr id="35" name="Chiffre 38 816 – légende"/>
             <p:cNvSpPr txBox="1"/>
             <p:nvPr/>
           </p:nvSpPr>
@@ -4744,7 +4363,7 @@
       </p:grpSp>
       <p:grpSp>
         <p:nvGrpSpPr>
-          <p:cNvPr id="53" name="Chiffre clé 20 ans"/>
+          <p:cNvPr id="40" name="Chiffre clé 20 ans"/>
           <p:cNvGrpSpPr/>
           <p:nvPr/>
         </p:nvGrpSpPr>
@@ -4758,7 +4377,7 @@
         </p:grpSpPr>
         <p:sp>
           <p:nvSpPr>
-            <p:cNvPr id="50" name="Chiffre 20 ans – fond"/>
+            <p:cNvPr id="37" name="Chiffre 20 ans – fond"/>
             <p:cNvSpPr/>
             <p:nvPr/>
           </p:nvSpPr>
@@ -4788,7 +4407,7 @@
         </p:sp>
         <p:sp>
           <p:nvSpPr>
-            <p:cNvPr id="51" name="Chiffre 20 ans"/>
+            <p:cNvPr id="38" name="Chiffre 20 ans"/>
             <p:cNvSpPr txBox="1"/>
             <p:nvPr/>
           </p:nvSpPr>
@@ -4830,7 +4449,7 @@
         </p:sp>
         <p:sp>
           <p:nvSpPr>
-            <p:cNvPr id="52" name="Chiffre 20 ans – légende"/>
+            <p:cNvPr id="39" name="Chiffre 20 ans – légende"/>
             <p:cNvSpPr txBox="1"/>
             <p:nvPr/>
           </p:nvSpPr>
@@ -4873,7 +4492,7 @@
       </p:grpSp>
       <p:sp>
         <p:nvSpPr>
-          <p:cNvPr id="54" name="Pourquoi soutenir EDLC ? – repère"/>
+          <p:cNvPr id="41" name="Pourquoi soutenir EDLC ? – repère"/>
           <p:cNvSpPr/>
           <p:nvPr/>
         </p:nvSpPr>
@@ -4903,7 +4522,7 @@
       </p:sp>
       <p:sp>
         <p:nvSpPr>
-          <p:cNvPr id="55" name="Pourquoi soutenir EDLC ?"/>
+          <p:cNvPr id="42" name="Pourquoi soutenir EDLC ?"/>
           <p:cNvSpPr txBox="1"/>
           <p:nvPr/>
         </p:nvSpPr>
@@ -4945,7 +4564,7 @@
       </p:sp>
       <p:sp>
         <p:nvSpPr>
-          <p:cNvPr id="56" name="Pourquoi soutenir – texte"/>
+          <p:cNvPr id="43" name="Pourquoi soutenir – texte"/>
           <p:cNvSpPr txBox="1"/>
           <p:nvPr/>
         </p:nvSpPr>
@@ -5006,7 +4625,7 @@
       </p:sp>
       <p:sp>
         <p:nvSpPr>
-          <p:cNvPr id="57" name="Un modèle qui associe protection et prévention"/>
+          <p:cNvPr id="44" name="Un modèle qui associe protection et prévention"/>
           <p:cNvSpPr txBox="1"/>
           <p:nvPr/>
         </p:nvSpPr>
@@ -5048,7 +4667,7 @@
       </p:sp>
       <p:sp>
         <p:nvSpPr>
-          <p:cNvPr id="58" name="Carte PROTÉGER – fond"/>
+          <p:cNvPr id="45" name="Carte PROTÉGER – fond"/>
           <p:cNvSpPr/>
           <p:nvPr/>
         </p:nvSpPr>
@@ -5078,7 +4697,7 @@
       </p:sp>
       <p:sp>
         <p:nvSpPr>
-          <p:cNvPr id="59" name="Picto protéger – fond"/>
+          <p:cNvPr id="46" name="Picto protéger – fond"/>
           <p:cNvSpPr/>
           <p:nvPr/>
         </p:nvSpPr>
@@ -5108,7 +4727,7 @@
       </p:sp>
       <p:sp>
         <p:nvSpPr>
-          <p:cNvPr id="60" name="Picto protéger – bouclier"/>
+          <p:cNvPr id="47" name="Picto protéger – bouclier"/>
           <p:cNvSpPr/>
           <p:nvPr/>
         </p:nvSpPr>
@@ -5137,7 +4756,7 @@
       </p:sp>
       <p:sp>
         <p:nvSpPr>
-          <p:cNvPr id="61" name="Picto protéger – coche (court)"/>
+          <p:cNvPr id="48" name="Picto protéger – coche (court)"/>
           <p:cNvSpPr/>
           <p:nvPr/>
         </p:nvSpPr>
@@ -5166,7 +4785,7 @@
       </p:sp>
       <p:sp>
         <p:nvSpPr>
-          <p:cNvPr id="62" name="Picto protéger – coche (long)"/>
+          <p:cNvPr id="49" name="Picto protéger – coche (long)"/>
           <p:cNvSpPr/>
           <p:nvPr/>
         </p:nvSpPr>
@@ -5195,7 +4814,7 @@
       </p:sp>
       <p:sp>
         <p:nvSpPr>
-          <p:cNvPr id="63" name="Carte PROTÉGER – titre"/>
+          <p:cNvPr id="50" name="Carte PROTÉGER – titre"/>
           <p:cNvSpPr txBox="1"/>
           <p:nvPr/>
         </p:nvSpPr>
@@ -5237,7 +4856,7 @@
       </p:sp>
       <p:sp>
         <p:nvSpPr>
-          <p:cNvPr id="64" name="Carte PROTÉGER – texte"/>
+          <p:cNvPr id="51" name="Carte PROTÉGER – texte"/>
           <p:cNvSpPr txBox="1"/>
           <p:nvPr/>
         </p:nvSpPr>
@@ -5288,7 +4907,7 @@
       </p:sp>
       <p:sp>
         <p:nvSpPr>
-          <p:cNvPr id="65" name="Carte PRÉVENIR – fond"/>
+          <p:cNvPr id="52" name="Carte PRÉVENIR – fond"/>
           <p:cNvSpPr/>
           <p:nvPr/>
         </p:nvSpPr>
@@ -5318,7 +4937,7 @@
       </p:sp>
       <p:sp>
         <p:nvSpPr>
-          <p:cNvPr id="66" name="Picto prévenir – fond"/>
+          <p:cNvPr id="53" name="Picto prévenir – fond"/>
           <p:cNvSpPr/>
           <p:nvPr/>
         </p:nvSpPr>
@@ -5348,7 +4967,7 @@
       </p:sp>
       <p:sp>
         <p:nvSpPr>
-          <p:cNvPr id="67" name="Picto prévenir – ampoule"/>
+          <p:cNvPr id="54" name="Picto prévenir – ampoule"/>
           <p:cNvSpPr/>
           <p:nvPr/>
         </p:nvSpPr>
@@ -5378,7 +4997,7 @@
       </p:sp>
       <p:sp>
         <p:nvSpPr>
-          <p:cNvPr id="68" name="Picto prévenir – culot"/>
+          <p:cNvPr id="55" name="Picto prévenir – culot"/>
           <p:cNvSpPr/>
           <p:nvPr/>
         </p:nvSpPr>
@@ -5406,7 +5025,7 @@
       </p:sp>
       <p:sp>
         <p:nvSpPr>
-          <p:cNvPr id="69" name="Picto prévenir – trait 1"/>
+          <p:cNvPr id="56" name="Picto prévenir – trait 1"/>
           <p:cNvSpPr/>
           <p:nvPr/>
         </p:nvSpPr>
@@ -5434,7 +5053,7 @@
       </p:sp>
       <p:sp>
         <p:nvSpPr>
-          <p:cNvPr id="70" name="Picto prévenir – trait 2"/>
+          <p:cNvPr id="57" name="Picto prévenir – trait 2"/>
           <p:cNvSpPr/>
           <p:nvPr/>
         </p:nvSpPr>
@@ -5462,7 +5081,7 @@
       </p:sp>
       <p:sp>
         <p:nvSpPr>
-          <p:cNvPr id="71" name="Carte PRÉVENIR – titre"/>
+          <p:cNvPr id="58" name="Carte PRÉVENIR – titre"/>
           <p:cNvSpPr txBox="1"/>
           <p:nvPr/>
         </p:nvSpPr>
@@ -5504,7 +5123,7 @@
       </p:sp>
       <p:sp>
         <p:nvSpPr>
-          <p:cNvPr id="72" name="Carte PRÉVENIR – texte"/>
+          <p:cNvPr id="59" name="Carte PRÉVENIR – texte"/>
           <p:cNvSpPr txBox="1"/>
           <p:nvPr/>
         </p:nvSpPr>
@@ -5546,7 +5165,7 @@
       </p:sp>
       <p:sp>
         <p:nvSpPr>
-          <p:cNvPr id="73" name="Un impact social documenté"/>
+          <p:cNvPr id="60" name="Un impact social documenté"/>
           <p:cNvSpPr txBox="1"/>
           <p:nvPr/>
         </p:nvSpPr>
@@ -5588,7 +5207,7 @@
       </p:sp>
       <p:grpSp>
         <p:nvGrpSpPr>
-          <p:cNvPr id="77" name="Profil bénéficiaires 1"/>
+          <p:cNvPr id="64" name="Profil bénéficiaires 1"/>
           <p:cNvGrpSpPr/>
           <p:nvPr/>
         </p:nvGrpSpPr>
@@ -5602,7 +5221,7 @@
         </p:grpSpPr>
         <p:sp>
           <p:nvSpPr>
-            <p:cNvPr id="74" name="Profil 1 – cadre"/>
+            <p:cNvPr id="61" name="Profil 1 – cadre"/>
             <p:cNvSpPr/>
             <p:nvPr/>
           </p:nvSpPr>
@@ -5634,7 +5253,7 @@
         </p:sp>
         <p:sp>
           <p:nvSpPr>
-            <p:cNvPr id="75" name="Profil 1 – accent"/>
+            <p:cNvPr id="62" name="Profil 1 – accent"/>
             <p:cNvSpPr/>
             <p:nvPr/>
           </p:nvSpPr>
@@ -5662,14 +5281,14 @@
         </p:sp>
         <p:sp>
           <p:nvSpPr>
-            <p:cNvPr id="76" name="Profil 1"/>
+            <p:cNvPr id="63" name="Profil 1"/>
             <p:cNvSpPr txBox="1"/>
             <p:nvPr/>
           </p:nvSpPr>
           <p:spPr>
             <a:xfrm>
-              <a:off x="584200" y="8851900"/>
-              <a:ext cx="1407477" cy="584200"/>
+              <a:off x="609600" y="8851900"/>
+              <a:ext cx="1356677" cy="584200"/>
             </a:xfrm>
             <a:prstGeom prst="rect">
               <a:avLst/>
@@ -5684,39 +5303,29 @@
             <a:p>
               <a:pPr algn="l">
                 <a:lnSpc>
-                  <a:spcPct val="100000"/>
+                  <a:spcPct val="110000"/>
                 </a:lnSpc>
                 <a:spcAft>
                   <a:spcPts val="0"/>
                 </a:spcAft>
               </a:pPr>
               <a:r>
-                <a:rPr sz="1500" b="1" i="0">
+                <a:rPr sz="900" b="1" i="0">
                   <a:solidFill>
                     <a:srgbClr val="EF3F34"/>
                   </a:solidFill>
-                  <a:latin typeface="Poppins"/>
+                  <a:latin typeface="Open Sans"/>
                 </a:rPr>
                 <a:t>58</a:t>
               </a:r>
-            </a:p>
-            <a:p>
-              <a:pPr algn="l">
-                <a:lnSpc>
-                  <a:spcPct val="100000"/>
-                </a:lnSpc>
-                <a:spcAft>
-                  <a:spcPts val="0"/>
-                </a:spcAft>
-              </a:pPr>
               <a:r>
-                <a:rPr sz="760" b="1" i="0">
+                <a:rPr sz="900" b="1" i="0">
                   <a:solidFill>
                     <a:srgbClr val="2B2B2B"/>
                   </a:solidFill>
                   <a:latin typeface="Open Sans"/>
                 </a:rPr>
-                <a:t>% de femmes</a:t>
+                <a:t> % de femmes</a:t>
               </a:r>
             </a:p>
           </p:txBody>
@@ -5724,7 +5333,7 @@
       </p:grpSp>
       <p:grpSp>
         <p:nvGrpSpPr>
-          <p:cNvPr id="81" name="Profil bénéficiaires 2"/>
+          <p:cNvPr id="68" name="Profil bénéficiaires 2"/>
           <p:cNvGrpSpPr/>
           <p:nvPr/>
         </p:nvGrpSpPr>
@@ -5738,7 +5347,7 @@
         </p:grpSpPr>
         <p:sp>
           <p:nvSpPr>
-            <p:cNvPr id="78" name="Profil 2 – cadre"/>
+            <p:cNvPr id="65" name="Profil 2 – cadre"/>
             <p:cNvSpPr/>
             <p:nvPr/>
           </p:nvSpPr>
@@ -5770,7 +5379,7 @@
         </p:sp>
         <p:sp>
           <p:nvSpPr>
-            <p:cNvPr id="79" name="Profil 2 – accent"/>
+            <p:cNvPr id="66" name="Profil 2 – accent"/>
             <p:cNvSpPr/>
             <p:nvPr/>
           </p:nvSpPr>
@@ -5798,14 +5407,14 @@
         </p:sp>
         <p:sp>
           <p:nvSpPr>
-            <p:cNvPr id="80" name="Profil 2"/>
+            <p:cNvPr id="67" name="Profil 2"/>
             <p:cNvSpPr txBox="1"/>
             <p:nvPr/>
           </p:nvSpPr>
           <p:spPr>
             <a:xfrm>
-              <a:off x="2271077" y="8851900"/>
-              <a:ext cx="1407477" cy="584200"/>
+              <a:off x="2296477" y="8851900"/>
+              <a:ext cx="1356677" cy="584200"/>
             </a:xfrm>
             <a:prstGeom prst="rect">
               <a:avLst/>
@@ -5820,39 +5429,29 @@
             <a:p>
               <a:pPr algn="l">
                 <a:lnSpc>
-                  <a:spcPct val="100000"/>
+                  <a:spcPct val="110000"/>
                 </a:lnSpc>
                 <a:spcAft>
                   <a:spcPts val="0"/>
                 </a:spcAft>
               </a:pPr>
               <a:r>
-                <a:rPr sz="1500" b="1" i="0">
+                <a:rPr sz="900" b="1" i="0">
                   <a:solidFill>
                     <a:srgbClr val="F89410"/>
                   </a:solidFill>
-                  <a:latin typeface="Poppins"/>
+                  <a:latin typeface="Open Sans"/>
                 </a:rPr>
                 <a:t>82</a:t>
               </a:r>
-            </a:p>
-            <a:p>
-              <a:pPr algn="l">
-                <a:lnSpc>
-                  <a:spcPct val="100000"/>
-                </a:lnSpc>
-                <a:spcAft>
-                  <a:spcPts val="0"/>
-                </a:spcAft>
-              </a:pPr>
               <a:r>
-                <a:rPr sz="760" b="1" i="0">
+                <a:rPr sz="900" b="1" i="0">
                   <a:solidFill>
                     <a:srgbClr val="2B2B2B"/>
                   </a:solidFill>
                   <a:latin typeface="Open Sans"/>
                 </a:rPr>
-                <a:t>% d’anciens demandeurs d’emploi</a:t>
+                <a:t> % d’anciens demandeurs d’emploi</a:t>
               </a:r>
             </a:p>
           </p:txBody>
@@ -5860,7 +5459,7 @@
       </p:grpSp>
       <p:grpSp>
         <p:nvGrpSpPr>
-          <p:cNvPr id="85" name="Profil bénéficiaires 3"/>
+          <p:cNvPr id="72" name="Profil bénéficiaires 3"/>
           <p:cNvGrpSpPr/>
           <p:nvPr/>
         </p:nvGrpSpPr>
@@ -5874,7 +5473,7 @@
         </p:grpSpPr>
         <p:sp>
           <p:nvSpPr>
-            <p:cNvPr id="82" name="Profil 3 – cadre"/>
+            <p:cNvPr id="69" name="Profil 3 – cadre"/>
             <p:cNvSpPr/>
             <p:nvPr/>
           </p:nvSpPr>
@@ -5906,7 +5505,7 @@
         </p:sp>
         <p:sp>
           <p:nvSpPr>
-            <p:cNvPr id="83" name="Profil 3 – accent"/>
+            <p:cNvPr id="70" name="Profil 3 – accent"/>
             <p:cNvSpPr/>
             <p:nvPr/>
           </p:nvSpPr>
@@ -5934,14 +5533,14 @@
         </p:sp>
         <p:sp>
           <p:nvSpPr>
-            <p:cNvPr id="84" name="Profil 3"/>
+            <p:cNvPr id="71" name="Profil 3"/>
             <p:cNvSpPr txBox="1"/>
             <p:nvPr/>
           </p:nvSpPr>
           <p:spPr>
             <a:xfrm>
-              <a:off x="3957954" y="8851900"/>
-              <a:ext cx="1407477" cy="584200"/>
+              <a:off x="3983354" y="8851900"/>
+              <a:ext cx="1356677" cy="584200"/>
             </a:xfrm>
             <a:prstGeom prst="rect">
               <a:avLst/>
@@ -5956,39 +5555,29 @@
             <a:p>
               <a:pPr algn="l">
                 <a:lnSpc>
-                  <a:spcPct val="100000"/>
+                  <a:spcPct val="110000"/>
                 </a:lnSpc>
                 <a:spcAft>
                   <a:spcPts val="0"/>
                 </a:spcAft>
               </a:pPr>
               <a:r>
-                <a:rPr sz="1500" b="1" i="0">
+                <a:rPr sz="900" b="1" i="0">
                   <a:solidFill>
                     <a:srgbClr val="26408F"/>
                   </a:solidFill>
-                  <a:latin typeface="Poppins"/>
+                  <a:latin typeface="Open Sans"/>
                 </a:rPr>
                 <a:t>81</a:t>
               </a:r>
-            </a:p>
-            <a:p>
-              <a:pPr algn="l">
-                <a:lnSpc>
-                  <a:spcPct val="100000"/>
-                </a:lnSpc>
-                <a:spcAft>
-                  <a:spcPts val="0"/>
-                </a:spcAft>
-              </a:pPr>
               <a:r>
-                <a:rPr sz="760" b="1" i="0">
+                <a:rPr sz="900" b="1" i="0">
                   <a:solidFill>
                     <a:srgbClr val="2B2B2B"/>
                   </a:solidFill>
                   <a:latin typeface="Open Sans"/>
                 </a:rPr>
-                <a:t>% de travailleurs handicapés</a:t>
+                <a:t> % de travailleurs handicapés</a:t>
               </a:r>
             </a:p>
           </p:txBody>
@@ -5996,7 +5585,7 @@
       </p:grpSp>
       <p:grpSp>
         <p:nvGrpSpPr>
-          <p:cNvPr id="89" name="Profil bénéficiaires 4"/>
+          <p:cNvPr id="76" name="Profil bénéficiaires 4"/>
           <p:cNvGrpSpPr/>
           <p:nvPr/>
         </p:nvGrpSpPr>
@@ -6010,7 +5599,7 @@
         </p:grpSpPr>
         <p:sp>
           <p:nvSpPr>
-            <p:cNvPr id="86" name="Profil 4 – cadre"/>
+            <p:cNvPr id="73" name="Profil 4 – cadre"/>
             <p:cNvSpPr/>
             <p:nvPr/>
           </p:nvSpPr>
@@ -6042,7 +5631,7 @@
         </p:sp>
         <p:sp>
           <p:nvSpPr>
-            <p:cNvPr id="87" name="Profil 4 – accent"/>
+            <p:cNvPr id="74" name="Profil 4 – accent"/>
             <p:cNvSpPr/>
             <p:nvPr/>
           </p:nvSpPr>
@@ -6070,14 +5659,14 @@
         </p:sp>
         <p:sp>
           <p:nvSpPr>
-            <p:cNvPr id="88" name="Profil 4"/>
+            <p:cNvPr id="75" name="Profil 4"/>
             <p:cNvSpPr txBox="1"/>
             <p:nvPr/>
           </p:nvSpPr>
           <p:spPr>
             <a:xfrm>
-              <a:off x="5644832" y="8851900"/>
-              <a:ext cx="1407477" cy="584200"/>
+              <a:off x="5670232" y="8851900"/>
+              <a:ext cx="1356677" cy="584200"/>
             </a:xfrm>
             <a:prstGeom prst="rect">
               <a:avLst/>
@@ -6092,39 +5681,20 @@
             <a:p>
               <a:pPr algn="l">
                 <a:lnSpc>
-                  <a:spcPct val="100000"/>
+                  <a:spcPct val="110000"/>
                 </a:lnSpc>
                 <a:spcAft>
                   <a:spcPts val="0"/>
                 </a:spcAft>
               </a:pPr>
               <a:r>
-                <a:rPr sz="760" b="1" i="0">
+                <a:rPr sz="900" b="1" i="0">
                   <a:solidFill>
-                    <a:srgbClr val="2B2B2B"/>
+                    <a:srgbClr val="36B995"/>
                   </a:solidFill>
                   <a:latin typeface="Open Sans"/>
                 </a:rPr>
-                <a:t>Moyenne d’âge de</a:t>
-              </a:r>
-            </a:p>
-            <a:p>
-              <a:pPr algn="l">
-                <a:lnSpc>
-                  <a:spcPct val="100000"/>
-                </a:lnSpc>
-                <a:spcAft>
-                  <a:spcPts val="0"/>
-                </a:spcAft>
-              </a:pPr>
-              <a:r>
-                <a:rPr sz="1500" b="1" i="0">
-                  <a:solidFill>
-                    <a:srgbClr val="36B995"/>
-                  </a:solidFill>
-                  <a:latin typeface="Poppins"/>
-                </a:rPr>
-                <a:t>48 ans</a:t>
+                <a:t>Moyenne d’âge de 48 ans</a:t>
               </a:r>
             </a:p>
           </p:txBody>
@@ -6132,7 +5702,7 @@
       </p:grpSp>
       <p:sp>
         <p:nvSpPr>
-          <p:cNvPr id="90" name="Écosystème – texte"/>
+          <p:cNvPr id="77" name="Écosystème – texte"/>
           <p:cNvSpPr txBox="1"/>
           <p:nvPr/>
         </p:nvSpPr>
@@ -6168,6 +5738,78 @@
                 <a:latin typeface="Open Sans"/>
               </a:rPr>
               <a:t>EDLC s’appuie sur un écosystème engagé : France Assureurs, Bpifrance (Cap Créa), l’Agefiph, des réseaux d’accompagnement comme l’Adie, France Active, BGE ou France Travail, ainsi que des assureurs partenaires. Cette coopération réunit les compétences nécessaires autour d’un objectif commun : pérenniser les micro-entreprises nouvellement créées.</a:t>
+            </a:r>
+          </a:p>
+        </p:txBody>
+      </p:sp>
+      <p:cxnSp>
+        <p:nvCxnSpPr>
+          <p:cNvPr id="78" name="Pied de page – filet"/>
+          <p:cNvCxnSpPr/>
+          <p:nvPr/>
+        </p:nvCxnSpPr>
+        <p:spPr>
+          <a:xfrm>
+            <a:off x="457200" y="10260330"/>
+            <a:ext cx="6645909" cy="0"/>
+          </a:xfrm>
+          <a:prstGeom prst="line">
+            <a:avLst/>
+          </a:prstGeom>
+          <a:ln w="9525">
+            <a:solidFill>
+              <a:srgbClr val="EF3F34"/>
+            </a:solidFill>
+          </a:ln>
+        </p:spPr>
+      </p:cxnSp>
+      <p:sp>
+        <p:nvSpPr>
+          <p:cNvPr id="79" name="Pied de page"/>
+          <p:cNvSpPr txBox="1"/>
+          <p:nvPr/>
+        </p:nvSpPr>
+        <p:spPr>
+          <a:xfrm>
+            <a:off x="457200" y="10349230"/>
+            <a:ext cx="6645909" cy="127000"/>
+          </a:xfrm>
+          <a:prstGeom prst="rect">
+            <a:avLst/>
+          </a:prstGeom>
+          <a:noFill/>
+        </p:spPr>
+        <p:txBody>
+          <a:bodyPr wrap="square" lIns="0" rIns="0" tIns="0" bIns="0" anchor="t">
+            <a:noAutofit/>
+          </a:bodyPr>
+          <a:lstStyle/>
+          <a:p>
+            <a:pPr algn="ctr">
+              <a:lnSpc>
+                <a:spcPct val="120000"/>
+              </a:lnSpc>
+              <a:spcAft>
+                <a:spcPts val="0"/>
+              </a:spcAft>
+            </a:pPr>
+            <a:r>
+              <a:rPr sz="680" b="1" i="0" spc="30">
+                <a:solidFill>
+                  <a:srgbClr val="EF3F34"/>
+                </a:solidFill>
+                <a:latin typeface="Open Sans"/>
+              </a:rPr>
+              <a:t>ENTREPRENEURS DE LA CITÉ</a:t>
+            </a:r>
+            <a:r>
+              <a:rPr sz="680" b="0" i="0" spc="30">
+                <a:solidFill>
+                  <a:srgbClr val="6B6B6B"/>
+                </a:solidFill>
+                <a:latin typeface="Open Sans"/>
+              </a:rPr>
+              <a:t>  •  Prévenir, protéger, pérenniser</a:t>
             </a:r>
           </a:p>
         </p:txBody>
@@ -6260,123 +5902,9 @@
           </a:p>
         </p:txBody>
       </p:sp>
-      <p:cxnSp>
-        <p:nvCxnSpPr>
-          <p:cNvPr id="4" name="Pied de page – filet"/>
-          <p:cNvCxnSpPr/>
-          <p:nvPr/>
-        </p:nvCxnSpPr>
-        <p:spPr>
-          <a:xfrm>
-            <a:off x="457200" y="10260330"/>
-            <a:ext cx="6645909" cy="0"/>
-          </a:xfrm>
-          <a:prstGeom prst="line">
-            <a:avLst/>
-          </a:prstGeom>
-          <a:ln w="9525">
-            <a:solidFill>
-              <a:srgbClr val="EF3F34"/>
-            </a:solidFill>
-          </a:ln>
-        </p:spPr>
-      </p:cxnSp>
-      <p:sp>
-        <p:nvSpPr>
-          <p:cNvPr id="5" name="Pied de page"/>
-          <p:cNvSpPr txBox="1"/>
-          <p:nvPr/>
-        </p:nvSpPr>
-        <p:spPr>
-          <a:xfrm>
-            <a:off x="457200" y="10349230"/>
-            <a:ext cx="6645909" cy="127000"/>
-          </a:xfrm>
-          <a:prstGeom prst="rect">
-            <a:avLst/>
-          </a:prstGeom>
-          <a:noFill/>
-        </p:spPr>
-        <p:txBody>
-          <a:bodyPr wrap="square" lIns="0" rIns="0" tIns="0" bIns="0" anchor="t">
-            <a:noAutofit/>
-          </a:bodyPr>
-          <a:lstStyle/>
-          <a:p>
-            <a:pPr algn="ctr">
-              <a:lnSpc>
-                <a:spcPct val="120000"/>
-              </a:lnSpc>
-              <a:spcAft>
-                <a:spcPts val="0"/>
-              </a:spcAft>
-            </a:pPr>
-            <a:r>
-              <a:rPr sz="680" b="1" i="0" spc="30">
-                <a:solidFill>
-                  <a:srgbClr val="EF3F34"/>
-                </a:solidFill>
-                <a:latin typeface="Open Sans"/>
-              </a:rPr>
-              <a:t>ENTREPRENEURS DE LA CITÉ</a:t>
-            </a:r>
-            <a:r>
-              <a:rPr sz="680" b="0" i="0" spc="30">
-                <a:solidFill>
-                  <a:srgbClr val="6B6B6B"/>
-                </a:solidFill>
-                <a:latin typeface="Open Sans"/>
-              </a:rPr>
-              <a:t>  •  Prévenir, protéger, pérenniser</a:t>
-            </a:r>
-          </a:p>
-        </p:txBody>
-      </p:sp>
-      <p:sp>
-        <p:nvSpPr>
-          <p:cNvPr id="6" name="Numéro de page"/>
-          <p:cNvSpPr txBox="1"/>
-          <p:nvPr/>
-        </p:nvSpPr>
-        <p:spPr>
-          <a:xfrm>
-            <a:off x="6849109" y="10349230"/>
-            <a:ext cx="254000" cy="127000"/>
-          </a:xfrm>
-          <a:prstGeom prst="rect">
-            <a:avLst/>
-          </a:prstGeom>
-          <a:noFill/>
-        </p:spPr>
-        <p:txBody>
-          <a:bodyPr wrap="square" lIns="0" rIns="0" tIns="0" bIns="0" anchor="t">
-            <a:noAutofit/>
-          </a:bodyPr>
-          <a:lstStyle/>
-          <a:p>
-            <a:pPr algn="r">
-              <a:lnSpc>
-                <a:spcPct val="120000"/>
-              </a:lnSpc>
-              <a:spcAft>
-                <a:spcPts val="0"/>
-              </a:spcAft>
-            </a:pPr>
-            <a:r>
-              <a:rPr sz="680" b="1" i="0">
-                <a:solidFill>
-                  <a:srgbClr val="6B6B6B"/>
-                </a:solidFill>
-                <a:latin typeface="Open Sans"/>
-              </a:rPr>
-              <a:t>2</a:t>
-            </a:r>
-          </a:p>
-        </p:txBody>
-      </p:sp>
       <p:pic>
         <p:nvPicPr>
-          <p:cNvPr id="7" name="Logo EDLC" descr="logo_edlc_crop.png"/>
+          <p:cNvPr id="4" name="Logo EDLC" descr="logo_edlc_crop.png"/>
           <p:cNvPicPr>
             <a:picLocks noChangeAspect="1"/>
           </p:cNvPicPr>
@@ -6400,7 +5928,7 @@
       </p:pic>
       <p:sp>
         <p:nvSpPr>
-          <p:cNvPr id="8" name="Votre don, un levier d’action concret – repère"/>
+          <p:cNvPr id="5" name="Votre don, un levier d’action concret – repère"/>
           <p:cNvSpPr/>
           <p:nvPr/>
         </p:nvSpPr>
@@ -6430,7 +5958,7 @@
       </p:sp>
       <p:sp>
         <p:nvSpPr>
-          <p:cNvPr id="9" name="Votre don, un levier d’action concret"/>
+          <p:cNvPr id="6" name="Votre don, un levier d’action concret"/>
           <p:cNvSpPr txBox="1"/>
           <p:nvPr/>
         </p:nvSpPr>
@@ -6472,7 +6000,7 @@
       </p:sp>
       <p:sp>
         <p:nvSpPr>
-          <p:cNvPr id="10" name="Levier – texte"/>
+          <p:cNvPr id="7" name="Levier – texte"/>
           <p:cNvSpPr txBox="1"/>
           <p:nvPr/>
         </p:nvSpPr>
@@ -6514,13 +6042,13 @@
       </p:sp>
       <p:sp>
         <p:nvSpPr>
-          <p:cNvPr id="11" name="Quel est l’impact concret de votre soutien ?"/>
+          <p:cNvPr id="8" name="Quel est l’impact concret de votre soutien ?"/>
           <p:cNvSpPr txBox="1"/>
           <p:nvPr/>
         </p:nvSpPr>
         <p:spPr>
           <a:xfrm>
-            <a:off x="457200" y="2044700"/>
+            <a:off x="457200" y="1993900"/>
             <a:ext cx="6645909" cy="219075"/>
           </a:xfrm>
           <a:prstGeom prst="rect">
@@ -6554,148 +6082,681 @@
           </a:p>
         </p:txBody>
       </p:sp>
-      <p:sp>
-        <p:nvSpPr>
-          <p:cNvPr id="12" name="Carte don 5 000 € – fond"/>
-          <p:cNvSpPr/>
+      <p:graphicFrame>
+        <p:nvGraphicFramePr>
+          <p:cNvPr id="9" name="Tableau impact du don"/>
+          <p:cNvGraphicFramePr>
+            <a:graphicFrameLocks noGrp="1"/>
+          </p:cNvGraphicFramePr>
           <p:nvPr/>
-        </p:nvSpPr>
-        <p:spPr>
-          <a:xfrm>
-            <a:off x="457200" y="2324100"/>
-            <a:ext cx="1575752" cy="2082800"/>
-          </a:xfrm>
-          <a:prstGeom prst="roundRect">
-            <a:avLst>
-              <a:gd name="adj" fmla="val 7253"/>
-            </a:avLst>
-          </a:prstGeom>
-          <a:solidFill>
-            <a:srgbClr val="FFF5D2"/>
-          </a:solidFill>
-          <a:ln w="12700">
-            <a:solidFill>
-              <a:srgbClr val="FFCB1F"/>
-            </a:solidFill>
-          </a:ln>
-          <a:effectLst/>
-        </p:spPr>
-        <p:txBody>
-          <a:bodyPr rtlCol="0" anchor="ctr"/>
-          <a:lstStyle/>
-          <a:p/>
-        </p:txBody>
-      </p:sp>
-      <p:sp>
-        <p:nvSpPr>
-          <p:cNvPr id="13" name="Carte don 5 000 € – bandeau"/>
-          <p:cNvSpPr/>
-          <p:nvPr/>
-        </p:nvSpPr>
-        <p:spPr>
-          <a:xfrm>
-            <a:off x="457200" y="2324100"/>
-            <a:ext cx="1575752" cy="584200"/>
-          </a:xfrm>
-          <a:prstGeom prst="roundRect">
-            <a:avLst>
-              <a:gd name="adj" fmla="val 19565"/>
-            </a:avLst>
-          </a:prstGeom>
-          <a:solidFill>
-            <a:srgbClr val="FFCB1F"/>
-          </a:solidFill>
-          <a:ln>
-            <a:noFill/>
-          </a:ln>
-          <a:effectLst/>
-        </p:spPr>
-        <p:txBody>
-          <a:bodyPr rtlCol="0" anchor="ctr"/>
-          <a:lstStyle/>
-          <a:p/>
-        </p:txBody>
-      </p:sp>
-      <p:sp>
-        <p:nvSpPr>
-          <p:cNvPr id="14" name="Carte don 5 000 € – bandeau (raccord)"/>
-          <p:cNvSpPr/>
-          <p:nvPr/>
-        </p:nvSpPr>
-        <p:spPr>
-          <a:xfrm>
-            <a:off x="457200" y="2705100"/>
-            <a:ext cx="1575752" cy="203200"/>
-          </a:xfrm>
-          <a:prstGeom prst="rect">
-            <a:avLst/>
-          </a:prstGeom>
-          <a:solidFill>
-            <a:srgbClr val="FFCB1F"/>
-          </a:solidFill>
-          <a:ln>
-            <a:noFill/>
-          </a:ln>
-          <a:effectLst/>
-        </p:spPr>
-        <p:txBody>
-          <a:bodyPr rtlCol="0" anchor="ctr"/>
-          <a:lstStyle/>
-          <a:p/>
-        </p:txBody>
-      </p:sp>
-      <p:sp>
-        <p:nvSpPr>
-          <p:cNvPr id="15" name="Carte don 5 000 € – libellé"/>
+        </p:nvGraphicFramePr>
+        <p:xfrm>
+          <a:off x="457200" y="2247900"/>
+          <a:ext cx="6645909" cy="2273300"/>
+        </p:xfrm>
+        <a:graphic>
+          <a:graphicData uri="http://schemas.openxmlformats.org/drawingml/2006/table">
+            <a:tbl>
+              <a:tblPr firstRow="0" bandRow="0">
+                <a:tableStyleId>{5C22544A-7EE6-4342-B048-85BDC9FD1C3A}</a:tableStyleId>
+              </a:tblPr>
+              <a:tblGrid>
+                <a:gridCol w="1524000"/>
+                <a:gridCol w="5121909"/>
+              </a:tblGrid>
+              <a:tr h="254000">
+                <a:tc>
+                  <a:txBody>
+                    <a:bodyPr wrap="square"/>
+                    <a:lstStyle/>
+                    <a:p>
+                      <a:pPr algn="ctr">
+                        <a:lnSpc>
+                          <a:spcPct val="100000"/>
+                        </a:lnSpc>
+                      </a:pPr>
+                      <a:r>
+                        <a:rPr sz="800" b="1">
+                          <a:solidFill>
+                            <a:srgbClr val="FFFFFF"/>
+                          </a:solidFill>
+                          <a:latin typeface="Open Sans"/>
+                        </a:rPr>
+                        <a:t>DON</a:t>
+                      </a:r>
+                    </a:p>
+                  </a:txBody>
+                  <a:tcPr marL="76200" marR="76200" marT="25400" marB="25400" anchor="ctr">
+                    <a:solidFill>
+                      <a:srgbClr val="26408F"/>
+                    </a:solidFill>
+                    <a:lnL w="6350" cap="flat" cmpd="sng" algn="ctr">
+                      <a:solidFill>
+                        <a:srgbClr val="D9DCE6"/>
+                      </a:solidFill>
+                    </a:lnL>
+                    <a:lnR w="6350" cap="flat" cmpd="sng" algn="ctr">
+                      <a:solidFill>
+                        <a:srgbClr val="D9DCE6"/>
+                      </a:solidFill>
+                    </a:lnR>
+                    <a:lnT w="6350" cap="flat" cmpd="sng" algn="ctr">
+                      <a:solidFill>
+                        <a:srgbClr val="D9DCE6"/>
+                      </a:solidFill>
+                    </a:lnT>
+                    <a:lnB w="6350" cap="flat" cmpd="sng" algn="ctr">
+                      <a:solidFill>
+                        <a:srgbClr val="D9DCE6"/>
+                      </a:solidFill>
+                    </a:lnB>
+                  </a:tcPr>
+                </a:tc>
+                <a:tc>
+                  <a:txBody>
+                    <a:bodyPr wrap="square"/>
+                    <a:lstStyle/>
+                    <a:p>
+                      <a:pPr algn="ctr">
+                        <a:lnSpc>
+                          <a:spcPct val="100000"/>
+                        </a:lnSpc>
+                      </a:pPr>
+                      <a:r>
+                        <a:rPr sz="800" b="1">
+                          <a:solidFill>
+                            <a:srgbClr val="FFFFFF"/>
+                          </a:solidFill>
+                          <a:latin typeface="Open Sans"/>
+                        </a:rPr>
+                        <a:t>Impact mesurable</a:t>
+                      </a:r>
+                    </a:p>
+                  </a:txBody>
+                  <a:tcPr marL="76200" marR="76200" marT="25400" marB="25400" anchor="ctr">
+                    <a:solidFill>
+                      <a:srgbClr val="26408F"/>
+                    </a:solidFill>
+                    <a:lnL w="6350" cap="flat" cmpd="sng" algn="ctr">
+                      <a:solidFill>
+                        <a:srgbClr val="D9DCE6"/>
+                      </a:solidFill>
+                    </a:lnL>
+                    <a:lnR w="6350" cap="flat" cmpd="sng" algn="ctr">
+                      <a:solidFill>
+                        <a:srgbClr val="D9DCE6"/>
+                      </a:solidFill>
+                    </a:lnR>
+                    <a:lnT w="6350" cap="flat" cmpd="sng" algn="ctr">
+                      <a:solidFill>
+                        <a:srgbClr val="D9DCE6"/>
+                      </a:solidFill>
+                    </a:lnT>
+                    <a:lnB w="6350" cap="flat" cmpd="sng" algn="ctr">
+                      <a:solidFill>
+                        <a:srgbClr val="D9DCE6"/>
+                      </a:solidFill>
+                    </a:lnB>
+                  </a:tcPr>
+                </a:tc>
+              </a:tr>
+              <a:tr h="304800">
+                <a:tc>
+                  <a:txBody>
+                    <a:bodyPr wrap="square"/>
+                    <a:lstStyle/>
+                    <a:p>
+                      <a:pPr algn="ctr">
+                        <a:lnSpc>
+                          <a:spcPct val="100000"/>
+                        </a:lnSpc>
+                      </a:pPr>
+                      <a:r>
+                        <a:rPr sz="1100" b="1">
+                          <a:solidFill>
+                            <a:srgbClr val="26408F"/>
+                          </a:solidFill>
+                          <a:latin typeface="Open Sans"/>
+                        </a:rPr>
+                        <a:t>5 000 €</a:t>
+                      </a:r>
+                    </a:p>
+                  </a:txBody>
+                  <a:tcPr marL="76200" marR="76200" marT="25400" marB="25400" anchor="ctr">
+                    <a:solidFill>
+                      <a:srgbClr val="FFCB1F"/>
+                    </a:solidFill>
+                    <a:lnL w="6350" cap="flat" cmpd="sng" algn="ctr">
+                      <a:solidFill>
+                        <a:srgbClr val="D9DCE6"/>
+                      </a:solidFill>
+                    </a:lnL>
+                    <a:lnR w="6350" cap="flat" cmpd="sng" algn="ctr">
+                      <a:solidFill>
+                        <a:srgbClr val="D9DCE6"/>
+                      </a:solidFill>
+                    </a:lnR>
+                    <a:lnT w="6350" cap="flat" cmpd="sng" algn="ctr">
+                      <a:solidFill>
+                        <a:srgbClr val="D9DCE6"/>
+                      </a:solidFill>
+                    </a:lnT>
+                    <a:lnB w="6350" cap="flat" cmpd="sng" algn="ctr">
+                      <a:solidFill>
+                        <a:srgbClr val="D9DCE6"/>
+                      </a:solidFill>
+                    </a:lnB>
+                  </a:tcPr>
+                </a:tc>
+                <a:tc>
+                  <a:txBody>
+                    <a:bodyPr wrap="square"/>
+                    <a:lstStyle/>
+                    <a:p>
+                      <a:pPr algn="ctr">
+                        <a:lnSpc>
+                          <a:spcPct val="100000"/>
+                        </a:lnSpc>
+                      </a:pPr>
+                      <a:r>
+                        <a:rPr sz="800" b="1">
+                          <a:solidFill>
+                            <a:srgbClr val="2B2B2B"/>
+                          </a:solidFill>
+                          <a:latin typeface="Open Sans"/>
+                        </a:rPr>
+                        <a:t>30 entrepreneurs</a:t>
+                      </a:r>
+                      <a:r>
+                        <a:rPr sz="800" b="0">
+                          <a:solidFill>
+                            <a:srgbClr val="2B2B2B"/>
+                          </a:solidFill>
+                          <a:latin typeface="Open Sans"/>
+                        </a:rPr>
+                        <a:t> accèdent à l’assurance sociale et solidaire et sont accompagnés pendant 1 an</a:t>
+                      </a:r>
+                    </a:p>
+                  </a:txBody>
+                  <a:tcPr marL="76200" marR="76200" marT="25400" marB="25400" anchor="ctr">
+                    <a:solidFill>
+                      <a:srgbClr val="FFF5D2"/>
+                    </a:solidFill>
+                    <a:lnL w="6350" cap="flat" cmpd="sng" algn="ctr">
+                      <a:solidFill>
+                        <a:srgbClr val="D9DCE6"/>
+                      </a:solidFill>
+                    </a:lnL>
+                    <a:lnR w="6350" cap="flat" cmpd="sng" algn="ctr">
+                      <a:solidFill>
+                        <a:srgbClr val="D9DCE6"/>
+                      </a:solidFill>
+                    </a:lnR>
+                    <a:lnT w="6350" cap="flat" cmpd="sng" algn="ctr">
+                      <a:solidFill>
+                        <a:srgbClr val="D9DCE6"/>
+                      </a:solidFill>
+                    </a:lnT>
+                    <a:lnB w="6350" cap="flat" cmpd="sng" algn="ctr">
+                      <a:solidFill>
+                        <a:srgbClr val="D9DCE6"/>
+                      </a:solidFill>
+                    </a:lnB>
+                  </a:tcPr>
+                </a:tc>
+              </a:tr>
+              <a:tr h="571500">
+                <a:tc>
+                  <a:txBody>
+                    <a:bodyPr wrap="square"/>
+                    <a:lstStyle/>
+                    <a:p>
+                      <a:pPr algn="ctr">
+                        <a:lnSpc>
+                          <a:spcPct val="100000"/>
+                        </a:lnSpc>
+                      </a:pPr>
+                      <a:r>
+                        <a:rPr sz="1100" b="1">
+                          <a:solidFill>
+                            <a:srgbClr val="FFFFFF"/>
+                          </a:solidFill>
+                          <a:latin typeface="Open Sans"/>
+                        </a:rPr>
+                        <a:t>10 000 €</a:t>
+                      </a:r>
+                    </a:p>
+                  </a:txBody>
+                  <a:tcPr marL="76200" marR="76200" marT="25400" marB="25400" anchor="ctr">
+                    <a:solidFill>
+                      <a:srgbClr val="F89410"/>
+                    </a:solidFill>
+                    <a:lnL w="6350" cap="flat" cmpd="sng" algn="ctr">
+                      <a:solidFill>
+                        <a:srgbClr val="D9DCE6"/>
+                      </a:solidFill>
+                    </a:lnL>
+                    <a:lnR w="6350" cap="flat" cmpd="sng" algn="ctr">
+                      <a:solidFill>
+                        <a:srgbClr val="D9DCE6"/>
+                      </a:solidFill>
+                    </a:lnR>
+                    <a:lnT w="6350" cap="flat" cmpd="sng" algn="ctr">
+                      <a:solidFill>
+                        <a:srgbClr val="D9DCE6"/>
+                      </a:solidFill>
+                    </a:lnT>
+                    <a:lnB w="6350" cap="flat" cmpd="sng" algn="ctr">
+                      <a:solidFill>
+                        <a:srgbClr val="D9DCE6"/>
+                      </a:solidFill>
+                    </a:lnB>
+                  </a:tcPr>
+                </a:tc>
+                <a:tc>
+                  <a:txBody>
+                    <a:bodyPr wrap="square"/>
+                    <a:lstStyle/>
+                    <a:p>
+                      <a:pPr algn="ctr">
+                        <a:lnSpc>
+                          <a:spcPct val="100000"/>
+                        </a:lnSpc>
+                      </a:pPr>
+                      <a:r>
+                        <a:rPr sz="800" b="1">
+                          <a:solidFill>
+                            <a:srgbClr val="2B2B2B"/>
+                          </a:solidFill>
+                          <a:latin typeface="Open Sans"/>
+                        </a:rPr>
+                        <a:t>60 entrepreneurs</a:t>
+                      </a:r>
+                      <a:r>
+                        <a:rPr sz="800" b="0">
+                          <a:solidFill>
+                            <a:srgbClr val="2B2B2B"/>
+                          </a:solidFill>
+                          <a:latin typeface="Open Sans"/>
+                        </a:rPr>
+                        <a:t> accèdent à l’assurance sociale et solidaire </a:t>
+                      </a:r>
+                    </a:p>
+                    <a:p>
+                      <a:pPr algn="ctr">
+                        <a:lnSpc>
+                          <a:spcPct val="100000"/>
+                        </a:lnSpc>
+                      </a:pPr>
+                      <a:r>
+                        <a:rPr sz="800" b="0">
+                          <a:solidFill>
+                            <a:srgbClr val="2B2B2B"/>
+                          </a:solidFill>
+                          <a:latin typeface="Open Sans"/>
+                        </a:rPr>
+                        <a:t>ou</a:t>
+                      </a:r>
+                    </a:p>
+                    <a:p>
+                      <a:pPr algn="ctr">
+                        <a:lnSpc>
+                          <a:spcPct val="100000"/>
+                        </a:lnSpc>
+                      </a:pPr>
+                      <a:r>
+                        <a:rPr sz="800" b="1">
+                          <a:solidFill>
+                            <a:srgbClr val="2B2B2B"/>
+                          </a:solidFill>
+                          <a:latin typeface="Open Sans"/>
+                        </a:rPr>
+                        <a:t>44 entrepreneurs</a:t>
+                      </a:r>
+                      <a:r>
+                        <a:rPr sz="800" b="0">
+                          <a:solidFill>
+                            <a:srgbClr val="2B2B2B"/>
+                          </a:solidFill>
+                          <a:latin typeface="Open Sans"/>
+                        </a:rPr>
+                        <a:t> sont formés à la gestion des risques liés à l’entrepreneuriat</a:t>
+                      </a:r>
+                    </a:p>
+                  </a:txBody>
+                  <a:tcPr marL="76200" marR="76200" marT="25400" marB="25400" anchor="ctr">
+                    <a:solidFill>
+                      <a:srgbClr val="FEEFDB"/>
+                    </a:solidFill>
+                    <a:lnL w="6350" cap="flat" cmpd="sng" algn="ctr">
+                      <a:solidFill>
+                        <a:srgbClr val="D9DCE6"/>
+                      </a:solidFill>
+                    </a:lnL>
+                    <a:lnR w="6350" cap="flat" cmpd="sng" algn="ctr">
+                      <a:solidFill>
+                        <a:srgbClr val="D9DCE6"/>
+                      </a:solidFill>
+                    </a:lnR>
+                    <a:lnT w="6350" cap="flat" cmpd="sng" algn="ctr">
+                      <a:solidFill>
+                        <a:srgbClr val="D9DCE6"/>
+                      </a:solidFill>
+                    </a:lnT>
+                    <a:lnB w="6350" cap="flat" cmpd="sng" algn="ctr">
+                      <a:solidFill>
+                        <a:srgbClr val="D9DCE6"/>
+                      </a:solidFill>
+                    </a:lnB>
+                  </a:tcPr>
+                </a:tc>
+              </a:tr>
+              <a:tr h="571500">
+                <a:tc>
+                  <a:txBody>
+                    <a:bodyPr wrap="square"/>
+                    <a:lstStyle/>
+                    <a:p>
+                      <a:pPr algn="ctr">
+                        <a:lnSpc>
+                          <a:spcPct val="100000"/>
+                        </a:lnSpc>
+                      </a:pPr>
+                      <a:r>
+                        <a:rPr sz="1100" b="1">
+                          <a:solidFill>
+                            <a:srgbClr val="FFFFFF"/>
+                          </a:solidFill>
+                          <a:latin typeface="Open Sans"/>
+                        </a:rPr>
+                        <a:t>20 000 €</a:t>
+                      </a:r>
+                    </a:p>
+                  </a:txBody>
+                  <a:tcPr marL="76200" marR="76200" marT="25400" marB="25400" anchor="ctr">
+                    <a:solidFill>
+                      <a:srgbClr val="EF3F34"/>
+                    </a:solidFill>
+                    <a:lnL w="6350" cap="flat" cmpd="sng" algn="ctr">
+                      <a:solidFill>
+                        <a:srgbClr val="D9DCE6"/>
+                      </a:solidFill>
+                    </a:lnL>
+                    <a:lnR w="6350" cap="flat" cmpd="sng" algn="ctr">
+                      <a:solidFill>
+                        <a:srgbClr val="D9DCE6"/>
+                      </a:solidFill>
+                    </a:lnR>
+                    <a:lnT w="6350" cap="flat" cmpd="sng" algn="ctr">
+                      <a:solidFill>
+                        <a:srgbClr val="D9DCE6"/>
+                      </a:solidFill>
+                    </a:lnT>
+                    <a:lnB w="6350" cap="flat" cmpd="sng" algn="ctr">
+                      <a:solidFill>
+                        <a:srgbClr val="D9DCE6"/>
+                      </a:solidFill>
+                    </a:lnB>
+                  </a:tcPr>
+                </a:tc>
+                <a:tc>
+                  <a:txBody>
+                    <a:bodyPr wrap="square"/>
+                    <a:lstStyle/>
+                    <a:p>
+                      <a:pPr algn="ctr">
+                        <a:lnSpc>
+                          <a:spcPct val="100000"/>
+                        </a:lnSpc>
+                      </a:pPr>
+                      <a:r>
+                        <a:rPr sz="800" b="1">
+                          <a:solidFill>
+                            <a:srgbClr val="2B2B2B"/>
+                          </a:solidFill>
+                          <a:latin typeface="Open Sans"/>
+                        </a:rPr>
+                        <a:t>120 entrepreneurs</a:t>
+                      </a:r>
+                      <a:r>
+                        <a:rPr sz="800" b="0">
+                          <a:solidFill>
+                            <a:srgbClr val="2B2B2B"/>
+                          </a:solidFill>
+                          <a:latin typeface="Open Sans"/>
+                        </a:rPr>
+                        <a:t> accèdent à l’assurance sociale et solidaire </a:t>
+                      </a:r>
+                    </a:p>
+                    <a:p>
+                      <a:pPr algn="ctr">
+                        <a:lnSpc>
+                          <a:spcPct val="100000"/>
+                        </a:lnSpc>
+                      </a:pPr>
+                      <a:r>
+                        <a:rPr sz="800" b="0">
+                          <a:solidFill>
+                            <a:srgbClr val="2B2B2B"/>
+                          </a:solidFill>
+                          <a:latin typeface="Open Sans"/>
+                        </a:rPr>
+                        <a:t>ou</a:t>
+                      </a:r>
+                    </a:p>
+                    <a:p>
+                      <a:pPr algn="ctr">
+                        <a:lnSpc>
+                          <a:spcPct val="100000"/>
+                        </a:lnSpc>
+                      </a:pPr>
+                      <a:r>
+                        <a:rPr sz="800" b="1">
+                          <a:solidFill>
+                            <a:srgbClr val="2B2B2B"/>
+                          </a:solidFill>
+                          <a:latin typeface="Open Sans"/>
+                        </a:rPr>
+                        <a:t>88 entrepreneurs</a:t>
+                      </a:r>
+                      <a:r>
+                        <a:rPr sz="800" b="0">
+                          <a:solidFill>
+                            <a:srgbClr val="2B2B2B"/>
+                          </a:solidFill>
+                          <a:latin typeface="Open Sans"/>
+                        </a:rPr>
+                        <a:t> sont formés à la gestion des risques</a:t>
+                      </a:r>
+                    </a:p>
+                  </a:txBody>
+                  <a:tcPr marL="76200" marR="76200" marT="25400" marB="25400" anchor="ctr">
+                    <a:solidFill>
+                      <a:srgbClr val="FDE8E6"/>
+                    </a:solidFill>
+                    <a:lnL w="6350" cap="flat" cmpd="sng" algn="ctr">
+                      <a:solidFill>
+                        <a:srgbClr val="D9DCE6"/>
+                      </a:solidFill>
+                    </a:lnL>
+                    <a:lnR w="6350" cap="flat" cmpd="sng" algn="ctr">
+                      <a:solidFill>
+                        <a:srgbClr val="D9DCE6"/>
+                      </a:solidFill>
+                    </a:lnR>
+                    <a:lnT w="6350" cap="flat" cmpd="sng" algn="ctr">
+                      <a:solidFill>
+                        <a:srgbClr val="D9DCE6"/>
+                      </a:solidFill>
+                    </a:lnT>
+                    <a:lnB w="6350" cap="flat" cmpd="sng" algn="ctr">
+                      <a:solidFill>
+                        <a:srgbClr val="D9DCE6"/>
+                      </a:solidFill>
+                    </a:lnB>
+                  </a:tcPr>
+                </a:tc>
+              </a:tr>
+              <a:tr h="571500">
+                <a:tc>
+                  <a:txBody>
+                    <a:bodyPr wrap="square"/>
+                    <a:lstStyle/>
+                    <a:p>
+                      <a:pPr algn="ctr">
+                        <a:lnSpc>
+                          <a:spcPct val="100000"/>
+                        </a:lnSpc>
+                      </a:pPr>
+                      <a:r>
+                        <a:rPr sz="1100" b="1">
+                          <a:solidFill>
+                            <a:srgbClr val="FFFFFF"/>
+                          </a:solidFill>
+                          <a:latin typeface="Open Sans"/>
+                        </a:rPr>
+                        <a:t>50 000 €</a:t>
+                      </a:r>
+                    </a:p>
+                  </a:txBody>
+                  <a:tcPr marL="76200" marR="76200" marT="25400" marB="25400" anchor="ctr">
+                    <a:solidFill>
+                      <a:srgbClr val="26408F"/>
+                    </a:solidFill>
+                    <a:lnL w="6350" cap="flat" cmpd="sng" algn="ctr">
+                      <a:solidFill>
+                        <a:srgbClr val="D9DCE6"/>
+                      </a:solidFill>
+                    </a:lnL>
+                    <a:lnR w="6350" cap="flat" cmpd="sng" algn="ctr">
+                      <a:solidFill>
+                        <a:srgbClr val="D9DCE6"/>
+                      </a:solidFill>
+                    </a:lnR>
+                    <a:lnT w="6350" cap="flat" cmpd="sng" algn="ctr">
+                      <a:solidFill>
+                        <a:srgbClr val="D9DCE6"/>
+                      </a:solidFill>
+                    </a:lnT>
+                    <a:lnB w="6350" cap="flat" cmpd="sng" algn="ctr">
+                      <a:solidFill>
+                        <a:srgbClr val="D9DCE6"/>
+                      </a:solidFill>
+                    </a:lnB>
+                  </a:tcPr>
+                </a:tc>
+                <a:tc>
+                  <a:txBody>
+                    <a:bodyPr wrap="square"/>
+                    <a:lstStyle/>
+                    <a:p>
+                      <a:pPr algn="ctr">
+                        <a:lnSpc>
+                          <a:spcPct val="100000"/>
+                        </a:lnSpc>
+                      </a:pPr>
+                      <a:r>
+                        <a:rPr sz="800" b="1">
+                          <a:solidFill>
+                            <a:srgbClr val="2B2B2B"/>
+                          </a:solidFill>
+                          <a:latin typeface="Open Sans"/>
+                        </a:rPr>
+                        <a:t>300 entrepreneurs</a:t>
+                      </a:r>
+                      <a:r>
+                        <a:rPr sz="800" b="0">
+                          <a:solidFill>
+                            <a:srgbClr val="2B2B2B"/>
+                          </a:solidFill>
+                          <a:latin typeface="Open Sans"/>
+                        </a:rPr>
+                        <a:t> accèdent à l’assurance sociale et solidaire </a:t>
+                      </a:r>
+                    </a:p>
+                    <a:p>
+                      <a:pPr algn="ctr">
+                        <a:lnSpc>
+                          <a:spcPct val="100000"/>
+                        </a:lnSpc>
+                      </a:pPr>
+                      <a:r>
+                        <a:rPr sz="800" b="0">
+                          <a:solidFill>
+                            <a:srgbClr val="2B2B2B"/>
+                          </a:solidFill>
+                          <a:latin typeface="Open Sans"/>
+                        </a:rPr>
+                        <a:t>ou</a:t>
+                      </a:r>
+                    </a:p>
+                    <a:p>
+                      <a:pPr algn="ctr">
+                        <a:lnSpc>
+                          <a:spcPct val="100000"/>
+                        </a:lnSpc>
+                      </a:pPr>
+                      <a:r>
+                        <a:rPr sz="800" b="1">
+                          <a:solidFill>
+                            <a:srgbClr val="2B2B2B"/>
+                          </a:solidFill>
+                          <a:latin typeface="Open Sans"/>
+                        </a:rPr>
+                        <a:t>220 entrepreneurs</a:t>
+                      </a:r>
+                      <a:r>
+                        <a:rPr sz="800" b="0">
+                          <a:solidFill>
+                            <a:srgbClr val="2B2B2B"/>
+                          </a:solidFill>
+                          <a:latin typeface="Open Sans"/>
+                        </a:rPr>
+                        <a:t> sont formés à la gestion des risques</a:t>
+                      </a:r>
+                    </a:p>
+                  </a:txBody>
+                  <a:tcPr marL="76200" marR="76200" marT="25400" marB="25400" anchor="ctr">
+                    <a:solidFill>
+                      <a:srgbClr val="E6EAF5"/>
+                    </a:solidFill>
+                    <a:lnL w="6350" cap="flat" cmpd="sng" algn="ctr">
+                      <a:solidFill>
+                        <a:srgbClr val="D9DCE6"/>
+                      </a:solidFill>
+                    </a:lnL>
+                    <a:lnR w="6350" cap="flat" cmpd="sng" algn="ctr">
+                      <a:solidFill>
+                        <a:srgbClr val="D9DCE6"/>
+                      </a:solidFill>
+                    </a:lnR>
+                    <a:lnT w="6350" cap="flat" cmpd="sng" algn="ctr">
+                      <a:solidFill>
+                        <a:srgbClr val="D9DCE6"/>
+                      </a:solidFill>
+                    </a:lnT>
+                    <a:lnB w="6350" cap="flat" cmpd="sng" algn="ctr">
+                      <a:solidFill>
+                        <a:srgbClr val="D9DCE6"/>
+                      </a:solidFill>
+                    </a:lnB>
+                  </a:tcPr>
+                </a:tc>
+              </a:tr>
+            </a:tbl>
+          </a:graphicData>
+        </a:graphic>
+      </p:graphicFrame>
+      <p:sp>
+        <p:nvSpPr>
+          <p:cNvPr id="10" name="Quel est le coût net de votre mécénat ?"/>
           <p:cNvSpPr txBox="1"/>
           <p:nvPr/>
         </p:nvSpPr>
         <p:spPr>
           <a:xfrm>
-            <a:off x="584200" y="2413000"/>
-            <a:ext cx="1321752" cy="127000"/>
-          </a:xfrm>
-          <a:prstGeom prst="rect">
-            <a:avLst/>
-          </a:prstGeom>
-          <a:noFill/>
-        </p:spPr>
-        <p:txBody>
-          <a:bodyPr wrap="square" lIns="0" rIns="0" tIns="0" bIns="0" anchor="t">
-            <a:noAutofit/>
-          </a:bodyPr>
-          <a:lstStyle/>
-          <a:p>
-            <a:pPr algn="l">
-              <a:lnSpc>
-                <a:spcPct val="120000"/>
-              </a:lnSpc>
-              <a:spcAft>
-                <a:spcPts val="0"/>
-              </a:spcAft>
-            </a:pPr>
-            <a:r>
-              <a:rPr sz="680" b="1" i="0" spc="120">
-                <a:solidFill>
-                  <a:srgbClr val="26408F"/>
-                </a:solidFill>
-                <a:latin typeface="Open Sans"/>
-              </a:rPr>
-              <a:t>DON</a:t>
-            </a:r>
-          </a:p>
-        </p:txBody>
-      </p:sp>
-      <p:sp>
-        <p:nvSpPr>
-          <p:cNvPr id="16" name="Carte don 5 000 € – montant"/>
-          <p:cNvSpPr txBox="1"/>
-          <p:nvPr/>
-        </p:nvSpPr>
-        <p:spPr>
-          <a:xfrm>
-            <a:off x="584200" y="2540000"/>
-            <a:ext cx="1321752" cy="304800"/>
+            <a:off x="457200" y="4699000"/>
+            <a:ext cx="6645909" cy="219075"/>
           </a:xfrm>
           <a:prstGeom prst="rect">
             <a:avLst/>
@@ -6717,1083 +6778,6 @@
               </a:spcAft>
             </a:pPr>
             <a:r>
-              <a:rPr sz="1700" b="1" i="0">
-                <a:solidFill>
-                  <a:srgbClr val="26408F"/>
-                </a:solidFill>
-                <a:latin typeface="Poppins"/>
-              </a:rPr>
-              <a:t>5 000 €</a:t>
-            </a:r>
-          </a:p>
-        </p:txBody>
-      </p:sp>
-      <p:sp>
-        <p:nvSpPr>
-          <p:cNvPr id="17" name="Carte don 5 000 € – libellé impact"/>
-          <p:cNvSpPr txBox="1"/>
-          <p:nvPr/>
-        </p:nvSpPr>
-        <p:spPr>
-          <a:xfrm>
-            <a:off x="584200" y="3009900"/>
-            <a:ext cx="1321752" cy="127000"/>
-          </a:xfrm>
-          <a:prstGeom prst="rect">
-            <a:avLst/>
-          </a:prstGeom>
-          <a:noFill/>
-        </p:spPr>
-        <p:txBody>
-          <a:bodyPr wrap="square" lIns="0" rIns="0" tIns="0" bIns="0" anchor="t">
-            <a:noAutofit/>
-          </a:bodyPr>
-          <a:lstStyle/>
-          <a:p>
-            <a:pPr algn="l">
-              <a:lnSpc>
-                <a:spcPct val="120000"/>
-              </a:lnSpc>
-              <a:spcAft>
-                <a:spcPts val="0"/>
-              </a:spcAft>
-            </a:pPr>
-            <a:r>
-              <a:rPr sz="630" b="1" i="0" spc="100">
-                <a:solidFill>
-                  <a:srgbClr val="F89410"/>
-                </a:solidFill>
-                <a:latin typeface="Open Sans"/>
-              </a:rPr>
-              <a:t>IMPACT MESURABLE</a:t>
-            </a:r>
-          </a:p>
-        </p:txBody>
-      </p:sp>
-      <p:sp>
-        <p:nvSpPr>
-          <p:cNvPr id="18" name="Carte don 5 000 € – impact"/>
-          <p:cNvSpPr txBox="1"/>
-          <p:nvPr/>
-        </p:nvSpPr>
-        <p:spPr>
-          <a:xfrm>
-            <a:off x="584200" y="3175000"/>
-            <a:ext cx="1372552" cy="1193800"/>
-          </a:xfrm>
-          <a:prstGeom prst="rect">
-            <a:avLst/>
-          </a:prstGeom>
-          <a:noFill/>
-        </p:spPr>
-        <p:txBody>
-          <a:bodyPr wrap="square" lIns="0" rIns="0" tIns="0" bIns="0" anchor="t">
-            <a:noAutofit/>
-          </a:bodyPr>
-          <a:lstStyle/>
-          <a:p>
-            <a:pPr algn="l">
-              <a:lnSpc>
-                <a:spcPct val="115000"/>
-              </a:lnSpc>
-              <a:spcAft>
-                <a:spcPts val="300"/>
-              </a:spcAft>
-            </a:pPr>
-            <a:r>
-              <a:rPr sz="780" b="1" i="0">
-                <a:solidFill>
-                  <a:srgbClr val="2B2B2B"/>
-                </a:solidFill>
-                <a:latin typeface="Open Sans"/>
-              </a:rPr>
-              <a:t>30 entrepreneurs</a:t>
-            </a:r>
-            <a:r>
-              <a:rPr sz="780" b="0" i="0">
-                <a:solidFill>
-                  <a:srgbClr val="2B2B2B"/>
-                </a:solidFill>
-                <a:latin typeface="Open Sans"/>
-              </a:rPr>
-              <a:t> accèdent à l’assurance sociale et solidaire et sont accompagnés pendant 1 an</a:t>
-            </a:r>
-          </a:p>
-        </p:txBody>
-      </p:sp>
-      <p:sp>
-        <p:nvSpPr>
-          <p:cNvPr id="19" name="Carte don 10 000 € – fond"/>
-          <p:cNvSpPr/>
-          <p:nvPr/>
-        </p:nvSpPr>
-        <p:spPr>
-          <a:xfrm>
-            <a:off x="2147252" y="2324100"/>
-            <a:ext cx="1575752" cy="2082800"/>
-          </a:xfrm>
-          <a:prstGeom prst="roundRect">
-            <a:avLst>
-              <a:gd name="adj" fmla="val 7253"/>
-            </a:avLst>
-          </a:prstGeom>
-          <a:solidFill>
-            <a:srgbClr val="FEEFDB"/>
-          </a:solidFill>
-          <a:ln w="12700">
-            <a:solidFill>
-              <a:srgbClr val="F89410"/>
-            </a:solidFill>
-          </a:ln>
-          <a:effectLst/>
-        </p:spPr>
-        <p:txBody>
-          <a:bodyPr rtlCol="0" anchor="ctr"/>
-          <a:lstStyle/>
-          <a:p/>
-        </p:txBody>
-      </p:sp>
-      <p:sp>
-        <p:nvSpPr>
-          <p:cNvPr id="20" name="Carte don 10 000 € – bandeau"/>
-          <p:cNvSpPr/>
-          <p:nvPr/>
-        </p:nvSpPr>
-        <p:spPr>
-          <a:xfrm>
-            <a:off x="2147252" y="2324100"/>
-            <a:ext cx="1575752" cy="584200"/>
-          </a:xfrm>
-          <a:prstGeom prst="roundRect">
-            <a:avLst>
-              <a:gd name="adj" fmla="val 19565"/>
-            </a:avLst>
-          </a:prstGeom>
-          <a:solidFill>
-            <a:srgbClr val="F89410"/>
-          </a:solidFill>
-          <a:ln>
-            <a:noFill/>
-          </a:ln>
-          <a:effectLst/>
-        </p:spPr>
-        <p:txBody>
-          <a:bodyPr rtlCol="0" anchor="ctr"/>
-          <a:lstStyle/>
-          <a:p/>
-        </p:txBody>
-      </p:sp>
-      <p:sp>
-        <p:nvSpPr>
-          <p:cNvPr id="21" name="Carte don 10 000 € – bandeau (raccord)"/>
-          <p:cNvSpPr/>
-          <p:nvPr/>
-        </p:nvSpPr>
-        <p:spPr>
-          <a:xfrm>
-            <a:off x="2147252" y="2705100"/>
-            <a:ext cx="1575752" cy="203200"/>
-          </a:xfrm>
-          <a:prstGeom prst="rect">
-            <a:avLst/>
-          </a:prstGeom>
-          <a:solidFill>
-            <a:srgbClr val="F89410"/>
-          </a:solidFill>
-          <a:ln>
-            <a:noFill/>
-          </a:ln>
-          <a:effectLst/>
-        </p:spPr>
-        <p:txBody>
-          <a:bodyPr rtlCol="0" anchor="ctr"/>
-          <a:lstStyle/>
-          <a:p/>
-        </p:txBody>
-      </p:sp>
-      <p:sp>
-        <p:nvSpPr>
-          <p:cNvPr id="22" name="Carte don 10 000 € – libellé"/>
-          <p:cNvSpPr txBox="1"/>
-          <p:nvPr/>
-        </p:nvSpPr>
-        <p:spPr>
-          <a:xfrm>
-            <a:off x="2274252" y="2413000"/>
-            <a:ext cx="1321752" cy="127000"/>
-          </a:xfrm>
-          <a:prstGeom prst="rect">
-            <a:avLst/>
-          </a:prstGeom>
-          <a:noFill/>
-        </p:spPr>
-        <p:txBody>
-          <a:bodyPr wrap="square" lIns="0" rIns="0" tIns="0" bIns="0" anchor="t">
-            <a:noAutofit/>
-          </a:bodyPr>
-          <a:lstStyle/>
-          <a:p>
-            <a:pPr algn="l">
-              <a:lnSpc>
-                <a:spcPct val="120000"/>
-              </a:lnSpc>
-              <a:spcAft>
-                <a:spcPts val="0"/>
-              </a:spcAft>
-            </a:pPr>
-            <a:r>
-              <a:rPr sz="680" b="1" i="0" spc="120">
-                <a:solidFill>
-                  <a:srgbClr val="FFFFFF"/>
-                </a:solidFill>
-                <a:latin typeface="Open Sans"/>
-              </a:rPr>
-              <a:t>DON</a:t>
-            </a:r>
-          </a:p>
-        </p:txBody>
-      </p:sp>
-      <p:sp>
-        <p:nvSpPr>
-          <p:cNvPr id="23" name="Carte don 10 000 € – montant"/>
-          <p:cNvSpPr txBox="1"/>
-          <p:nvPr/>
-        </p:nvSpPr>
-        <p:spPr>
-          <a:xfrm>
-            <a:off x="2274252" y="2540000"/>
-            <a:ext cx="1321752" cy="304800"/>
-          </a:xfrm>
-          <a:prstGeom prst="rect">
-            <a:avLst/>
-          </a:prstGeom>
-          <a:noFill/>
-        </p:spPr>
-        <p:txBody>
-          <a:bodyPr wrap="square" lIns="0" rIns="0" tIns="0" bIns="0" anchor="t">
-            <a:noAutofit/>
-          </a:bodyPr>
-          <a:lstStyle/>
-          <a:p>
-            <a:pPr algn="l">
-              <a:lnSpc>
-                <a:spcPct val="100000"/>
-              </a:lnSpc>
-              <a:spcAft>
-                <a:spcPts val="0"/>
-              </a:spcAft>
-            </a:pPr>
-            <a:r>
-              <a:rPr sz="1700" b="1" i="0">
-                <a:solidFill>
-                  <a:srgbClr val="FFFFFF"/>
-                </a:solidFill>
-                <a:latin typeface="Poppins"/>
-              </a:rPr>
-              <a:t>10 000 €</a:t>
-            </a:r>
-          </a:p>
-        </p:txBody>
-      </p:sp>
-      <p:sp>
-        <p:nvSpPr>
-          <p:cNvPr id="24" name="Carte don 10 000 € – libellé impact"/>
-          <p:cNvSpPr txBox="1"/>
-          <p:nvPr/>
-        </p:nvSpPr>
-        <p:spPr>
-          <a:xfrm>
-            <a:off x="2274252" y="3009900"/>
-            <a:ext cx="1321752" cy="127000"/>
-          </a:xfrm>
-          <a:prstGeom prst="rect">
-            <a:avLst/>
-          </a:prstGeom>
-          <a:noFill/>
-        </p:spPr>
-        <p:txBody>
-          <a:bodyPr wrap="square" lIns="0" rIns="0" tIns="0" bIns="0" anchor="t">
-            <a:noAutofit/>
-          </a:bodyPr>
-          <a:lstStyle/>
-          <a:p>
-            <a:pPr algn="l">
-              <a:lnSpc>
-                <a:spcPct val="120000"/>
-              </a:lnSpc>
-              <a:spcAft>
-                <a:spcPts val="0"/>
-              </a:spcAft>
-            </a:pPr>
-            <a:r>
-              <a:rPr sz="630" b="1" i="0" spc="100">
-                <a:solidFill>
-                  <a:srgbClr val="F89410"/>
-                </a:solidFill>
-                <a:latin typeface="Open Sans"/>
-              </a:rPr>
-              <a:t>IMPACT MESURABLE</a:t>
-            </a:r>
-          </a:p>
-        </p:txBody>
-      </p:sp>
-      <p:sp>
-        <p:nvSpPr>
-          <p:cNvPr id="25" name="Carte don 10 000 € – impact"/>
-          <p:cNvSpPr txBox="1"/>
-          <p:nvPr/>
-        </p:nvSpPr>
-        <p:spPr>
-          <a:xfrm>
-            <a:off x="2274252" y="3175000"/>
-            <a:ext cx="1372552" cy="1193800"/>
-          </a:xfrm>
-          <a:prstGeom prst="rect">
-            <a:avLst/>
-          </a:prstGeom>
-          <a:noFill/>
-        </p:spPr>
-        <p:txBody>
-          <a:bodyPr wrap="square" lIns="0" rIns="0" tIns="0" bIns="0" anchor="t">
-            <a:noAutofit/>
-          </a:bodyPr>
-          <a:lstStyle/>
-          <a:p>
-            <a:pPr algn="l">
-              <a:lnSpc>
-                <a:spcPct val="115000"/>
-              </a:lnSpc>
-              <a:spcAft>
-                <a:spcPts val="300"/>
-              </a:spcAft>
-            </a:pPr>
-            <a:r>
-              <a:rPr sz="780" b="1" i="0">
-                <a:solidFill>
-                  <a:srgbClr val="2B2B2B"/>
-                </a:solidFill>
-                <a:latin typeface="Open Sans"/>
-              </a:rPr>
-              <a:t>60 entrepreneurs</a:t>
-            </a:r>
-            <a:r>
-              <a:rPr sz="780" b="0" i="0">
-                <a:solidFill>
-                  <a:srgbClr val="2B2B2B"/>
-                </a:solidFill>
-                <a:latin typeface="Open Sans"/>
-              </a:rPr>
-              <a:t> accèdent à l’assurance sociale et solidaire </a:t>
-            </a:r>
-          </a:p>
-          <a:p>
-            <a:pPr algn="l">
-              <a:lnSpc>
-                <a:spcPct val="115000"/>
-              </a:lnSpc>
-              <a:spcAft>
-                <a:spcPts val="300"/>
-              </a:spcAft>
-            </a:pPr>
-            <a:r>
-              <a:rPr sz="780" b="1" i="1">
-                <a:solidFill>
-                  <a:srgbClr val="F89410"/>
-                </a:solidFill>
-                <a:latin typeface="Open Sans"/>
-              </a:rPr>
-              <a:t>ou</a:t>
-            </a:r>
-          </a:p>
-          <a:p>
-            <a:pPr algn="l">
-              <a:lnSpc>
-                <a:spcPct val="115000"/>
-              </a:lnSpc>
-              <a:spcAft>
-                <a:spcPts val="300"/>
-              </a:spcAft>
-            </a:pPr>
-            <a:r>
-              <a:rPr sz="780" b="1" i="0">
-                <a:solidFill>
-                  <a:srgbClr val="2B2B2B"/>
-                </a:solidFill>
-                <a:latin typeface="Open Sans"/>
-              </a:rPr>
-              <a:t>44 entrepreneurs</a:t>
-            </a:r>
-            <a:r>
-              <a:rPr sz="780" b="0" i="0">
-                <a:solidFill>
-                  <a:srgbClr val="2B2B2B"/>
-                </a:solidFill>
-                <a:latin typeface="Open Sans"/>
-              </a:rPr>
-              <a:t> sont formés à la gestion des risques liés à l’entrepreneuriat</a:t>
-            </a:r>
-          </a:p>
-        </p:txBody>
-      </p:sp>
-      <p:sp>
-        <p:nvSpPr>
-          <p:cNvPr id="26" name="Carte don 20 000 € – fond"/>
-          <p:cNvSpPr/>
-          <p:nvPr/>
-        </p:nvSpPr>
-        <p:spPr>
-          <a:xfrm>
-            <a:off x="3837304" y="2324100"/>
-            <a:ext cx="1575752" cy="2082800"/>
-          </a:xfrm>
-          <a:prstGeom prst="roundRect">
-            <a:avLst>
-              <a:gd name="adj" fmla="val 7253"/>
-            </a:avLst>
-          </a:prstGeom>
-          <a:solidFill>
-            <a:srgbClr val="FDE8E6"/>
-          </a:solidFill>
-          <a:ln w="12700">
-            <a:solidFill>
-              <a:srgbClr val="EF3F34"/>
-            </a:solidFill>
-          </a:ln>
-          <a:effectLst/>
-        </p:spPr>
-        <p:txBody>
-          <a:bodyPr rtlCol="0" anchor="ctr"/>
-          <a:lstStyle/>
-          <a:p/>
-        </p:txBody>
-      </p:sp>
-      <p:sp>
-        <p:nvSpPr>
-          <p:cNvPr id="27" name="Carte don 20 000 € – bandeau"/>
-          <p:cNvSpPr/>
-          <p:nvPr/>
-        </p:nvSpPr>
-        <p:spPr>
-          <a:xfrm>
-            <a:off x="3837304" y="2324100"/>
-            <a:ext cx="1575752" cy="584200"/>
-          </a:xfrm>
-          <a:prstGeom prst="roundRect">
-            <a:avLst>
-              <a:gd name="adj" fmla="val 19565"/>
-            </a:avLst>
-          </a:prstGeom>
-          <a:solidFill>
-            <a:srgbClr val="EF3F34"/>
-          </a:solidFill>
-          <a:ln>
-            <a:noFill/>
-          </a:ln>
-          <a:effectLst/>
-        </p:spPr>
-        <p:txBody>
-          <a:bodyPr rtlCol="0" anchor="ctr"/>
-          <a:lstStyle/>
-          <a:p/>
-        </p:txBody>
-      </p:sp>
-      <p:sp>
-        <p:nvSpPr>
-          <p:cNvPr id="28" name="Carte don 20 000 € – bandeau (raccord)"/>
-          <p:cNvSpPr/>
-          <p:nvPr/>
-        </p:nvSpPr>
-        <p:spPr>
-          <a:xfrm>
-            <a:off x="3837304" y="2705100"/>
-            <a:ext cx="1575752" cy="203200"/>
-          </a:xfrm>
-          <a:prstGeom prst="rect">
-            <a:avLst/>
-          </a:prstGeom>
-          <a:solidFill>
-            <a:srgbClr val="EF3F34"/>
-          </a:solidFill>
-          <a:ln>
-            <a:noFill/>
-          </a:ln>
-          <a:effectLst/>
-        </p:spPr>
-        <p:txBody>
-          <a:bodyPr rtlCol="0" anchor="ctr"/>
-          <a:lstStyle/>
-          <a:p/>
-        </p:txBody>
-      </p:sp>
-      <p:sp>
-        <p:nvSpPr>
-          <p:cNvPr id="29" name="Carte don 20 000 € – libellé"/>
-          <p:cNvSpPr txBox="1"/>
-          <p:nvPr/>
-        </p:nvSpPr>
-        <p:spPr>
-          <a:xfrm>
-            <a:off x="3964304" y="2413000"/>
-            <a:ext cx="1321752" cy="127000"/>
-          </a:xfrm>
-          <a:prstGeom prst="rect">
-            <a:avLst/>
-          </a:prstGeom>
-          <a:noFill/>
-        </p:spPr>
-        <p:txBody>
-          <a:bodyPr wrap="square" lIns="0" rIns="0" tIns="0" bIns="0" anchor="t">
-            <a:noAutofit/>
-          </a:bodyPr>
-          <a:lstStyle/>
-          <a:p>
-            <a:pPr algn="l">
-              <a:lnSpc>
-                <a:spcPct val="120000"/>
-              </a:lnSpc>
-              <a:spcAft>
-                <a:spcPts val="0"/>
-              </a:spcAft>
-            </a:pPr>
-            <a:r>
-              <a:rPr sz="680" b="1" i="0" spc="120">
-                <a:solidFill>
-                  <a:srgbClr val="FFFFFF"/>
-                </a:solidFill>
-                <a:latin typeface="Open Sans"/>
-              </a:rPr>
-              <a:t>DON</a:t>
-            </a:r>
-          </a:p>
-        </p:txBody>
-      </p:sp>
-      <p:sp>
-        <p:nvSpPr>
-          <p:cNvPr id="30" name="Carte don 20 000 € – montant"/>
-          <p:cNvSpPr txBox="1"/>
-          <p:nvPr/>
-        </p:nvSpPr>
-        <p:spPr>
-          <a:xfrm>
-            <a:off x="3964304" y="2540000"/>
-            <a:ext cx="1321752" cy="304800"/>
-          </a:xfrm>
-          <a:prstGeom prst="rect">
-            <a:avLst/>
-          </a:prstGeom>
-          <a:noFill/>
-        </p:spPr>
-        <p:txBody>
-          <a:bodyPr wrap="square" lIns="0" rIns="0" tIns="0" bIns="0" anchor="t">
-            <a:noAutofit/>
-          </a:bodyPr>
-          <a:lstStyle/>
-          <a:p>
-            <a:pPr algn="l">
-              <a:lnSpc>
-                <a:spcPct val="100000"/>
-              </a:lnSpc>
-              <a:spcAft>
-                <a:spcPts val="0"/>
-              </a:spcAft>
-            </a:pPr>
-            <a:r>
-              <a:rPr sz="1700" b="1" i="0">
-                <a:solidFill>
-                  <a:srgbClr val="FFFFFF"/>
-                </a:solidFill>
-                <a:latin typeface="Poppins"/>
-              </a:rPr>
-              <a:t>20 000 €</a:t>
-            </a:r>
-          </a:p>
-        </p:txBody>
-      </p:sp>
-      <p:sp>
-        <p:nvSpPr>
-          <p:cNvPr id="31" name="Carte don 20 000 € – libellé impact"/>
-          <p:cNvSpPr txBox="1"/>
-          <p:nvPr/>
-        </p:nvSpPr>
-        <p:spPr>
-          <a:xfrm>
-            <a:off x="3964304" y="3009900"/>
-            <a:ext cx="1321752" cy="127000"/>
-          </a:xfrm>
-          <a:prstGeom prst="rect">
-            <a:avLst/>
-          </a:prstGeom>
-          <a:noFill/>
-        </p:spPr>
-        <p:txBody>
-          <a:bodyPr wrap="square" lIns="0" rIns="0" tIns="0" bIns="0" anchor="t">
-            <a:noAutofit/>
-          </a:bodyPr>
-          <a:lstStyle/>
-          <a:p>
-            <a:pPr algn="l">
-              <a:lnSpc>
-                <a:spcPct val="120000"/>
-              </a:lnSpc>
-              <a:spcAft>
-                <a:spcPts val="0"/>
-              </a:spcAft>
-            </a:pPr>
-            <a:r>
-              <a:rPr sz="630" b="1" i="0" spc="100">
-                <a:solidFill>
-                  <a:srgbClr val="EF3F34"/>
-                </a:solidFill>
-                <a:latin typeface="Open Sans"/>
-              </a:rPr>
-              <a:t>IMPACT MESURABLE</a:t>
-            </a:r>
-          </a:p>
-        </p:txBody>
-      </p:sp>
-      <p:sp>
-        <p:nvSpPr>
-          <p:cNvPr id="32" name="Carte don 20 000 € – impact"/>
-          <p:cNvSpPr txBox="1"/>
-          <p:nvPr/>
-        </p:nvSpPr>
-        <p:spPr>
-          <a:xfrm>
-            <a:off x="3964304" y="3175000"/>
-            <a:ext cx="1372552" cy="1193800"/>
-          </a:xfrm>
-          <a:prstGeom prst="rect">
-            <a:avLst/>
-          </a:prstGeom>
-          <a:noFill/>
-        </p:spPr>
-        <p:txBody>
-          <a:bodyPr wrap="square" lIns="0" rIns="0" tIns="0" bIns="0" anchor="t">
-            <a:noAutofit/>
-          </a:bodyPr>
-          <a:lstStyle/>
-          <a:p>
-            <a:pPr algn="l">
-              <a:lnSpc>
-                <a:spcPct val="115000"/>
-              </a:lnSpc>
-              <a:spcAft>
-                <a:spcPts val="300"/>
-              </a:spcAft>
-            </a:pPr>
-            <a:r>
-              <a:rPr sz="780" b="1" i="0">
-                <a:solidFill>
-                  <a:srgbClr val="2B2B2B"/>
-                </a:solidFill>
-                <a:latin typeface="Open Sans"/>
-              </a:rPr>
-              <a:t>120 entrepreneurs</a:t>
-            </a:r>
-            <a:r>
-              <a:rPr sz="780" b="0" i="0">
-                <a:solidFill>
-                  <a:srgbClr val="2B2B2B"/>
-                </a:solidFill>
-                <a:latin typeface="Open Sans"/>
-              </a:rPr>
-              <a:t> accèdent à l’assurance sociale et solidaire </a:t>
-            </a:r>
-          </a:p>
-          <a:p>
-            <a:pPr algn="l">
-              <a:lnSpc>
-                <a:spcPct val="115000"/>
-              </a:lnSpc>
-              <a:spcAft>
-                <a:spcPts val="300"/>
-              </a:spcAft>
-            </a:pPr>
-            <a:r>
-              <a:rPr sz="780" b="1" i="1">
-                <a:solidFill>
-                  <a:srgbClr val="EF3F34"/>
-                </a:solidFill>
-                <a:latin typeface="Open Sans"/>
-              </a:rPr>
-              <a:t>ou</a:t>
-            </a:r>
-          </a:p>
-          <a:p>
-            <a:pPr algn="l">
-              <a:lnSpc>
-                <a:spcPct val="115000"/>
-              </a:lnSpc>
-              <a:spcAft>
-                <a:spcPts val="300"/>
-              </a:spcAft>
-            </a:pPr>
-            <a:r>
-              <a:rPr sz="780" b="1" i="0">
-                <a:solidFill>
-                  <a:srgbClr val="2B2B2B"/>
-                </a:solidFill>
-                <a:latin typeface="Open Sans"/>
-              </a:rPr>
-              <a:t>88 entrepreneurs</a:t>
-            </a:r>
-            <a:r>
-              <a:rPr sz="780" b="0" i="0">
-                <a:solidFill>
-                  <a:srgbClr val="2B2B2B"/>
-                </a:solidFill>
-                <a:latin typeface="Open Sans"/>
-              </a:rPr>
-              <a:t> sont formés à la gestion des risques</a:t>
-            </a:r>
-          </a:p>
-        </p:txBody>
-      </p:sp>
-      <p:sp>
-        <p:nvSpPr>
-          <p:cNvPr id="33" name="Carte don 50 000 € – fond"/>
-          <p:cNvSpPr/>
-          <p:nvPr/>
-        </p:nvSpPr>
-        <p:spPr>
-          <a:xfrm>
-            <a:off x="5527357" y="2324100"/>
-            <a:ext cx="1575752" cy="2082800"/>
-          </a:xfrm>
-          <a:prstGeom prst="roundRect">
-            <a:avLst>
-              <a:gd name="adj" fmla="val 7253"/>
-            </a:avLst>
-          </a:prstGeom>
-          <a:solidFill>
-            <a:srgbClr val="E6EAF5"/>
-          </a:solidFill>
-          <a:ln w="12700">
-            <a:solidFill>
-              <a:srgbClr val="26408F"/>
-            </a:solidFill>
-          </a:ln>
-          <a:effectLst/>
-        </p:spPr>
-        <p:txBody>
-          <a:bodyPr rtlCol="0" anchor="ctr"/>
-          <a:lstStyle/>
-          <a:p/>
-        </p:txBody>
-      </p:sp>
-      <p:sp>
-        <p:nvSpPr>
-          <p:cNvPr id="34" name="Carte don 50 000 € – bandeau"/>
-          <p:cNvSpPr/>
-          <p:nvPr/>
-        </p:nvSpPr>
-        <p:spPr>
-          <a:xfrm>
-            <a:off x="5527357" y="2324100"/>
-            <a:ext cx="1575752" cy="584200"/>
-          </a:xfrm>
-          <a:prstGeom prst="roundRect">
-            <a:avLst>
-              <a:gd name="adj" fmla="val 19565"/>
-            </a:avLst>
-          </a:prstGeom>
-          <a:solidFill>
-            <a:srgbClr val="26408F"/>
-          </a:solidFill>
-          <a:ln>
-            <a:noFill/>
-          </a:ln>
-          <a:effectLst/>
-        </p:spPr>
-        <p:txBody>
-          <a:bodyPr rtlCol="0" anchor="ctr"/>
-          <a:lstStyle/>
-          <a:p/>
-        </p:txBody>
-      </p:sp>
-      <p:sp>
-        <p:nvSpPr>
-          <p:cNvPr id="35" name="Carte don 50 000 € – bandeau (raccord)"/>
-          <p:cNvSpPr/>
-          <p:nvPr/>
-        </p:nvSpPr>
-        <p:spPr>
-          <a:xfrm>
-            <a:off x="5527357" y="2705100"/>
-            <a:ext cx="1575752" cy="203200"/>
-          </a:xfrm>
-          <a:prstGeom prst="rect">
-            <a:avLst/>
-          </a:prstGeom>
-          <a:solidFill>
-            <a:srgbClr val="26408F"/>
-          </a:solidFill>
-          <a:ln>
-            <a:noFill/>
-          </a:ln>
-          <a:effectLst/>
-        </p:spPr>
-        <p:txBody>
-          <a:bodyPr rtlCol="0" anchor="ctr"/>
-          <a:lstStyle/>
-          <a:p/>
-        </p:txBody>
-      </p:sp>
-      <p:sp>
-        <p:nvSpPr>
-          <p:cNvPr id="36" name="Carte don 50 000 € – libellé"/>
-          <p:cNvSpPr txBox="1"/>
-          <p:nvPr/>
-        </p:nvSpPr>
-        <p:spPr>
-          <a:xfrm>
-            <a:off x="5654357" y="2413000"/>
-            <a:ext cx="1321752" cy="127000"/>
-          </a:xfrm>
-          <a:prstGeom prst="rect">
-            <a:avLst/>
-          </a:prstGeom>
-          <a:noFill/>
-        </p:spPr>
-        <p:txBody>
-          <a:bodyPr wrap="square" lIns="0" rIns="0" tIns="0" bIns="0" anchor="t">
-            <a:noAutofit/>
-          </a:bodyPr>
-          <a:lstStyle/>
-          <a:p>
-            <a:pPr algn="l">
-              <a:lnSpc>
-                <a:spcPct val="120000"/>
-              </a:lnSpc>
-              <a:spcAft>
-                <a:spcPts val="0"/>
-              </a:spcAft>
-            </a:pPr>
-            <a:r>
-              <a:rPr sz="680" b="1" i="0" spc="120">
-                <a:solidFill>
-                  <a:srgbClr val="FFFFFF"/>
-                </a:solidFill>
-                <a:latin typeface="Open Sans"/>
-              </a:rPr>
-              <a:t>DON</a:t>
-            </a:r>
-          </a:p>
-        </p:txBody>
-      </p:sp>
-      <p:sp>
-        <p:nvSpPr>
-          <p:cNvPr id="37" name="Carte don 50 000 € – montant"/>
-          <p:cNvSpPr txBox="1"/>
-          <p:nvPr/>
-        </p:nvSpPr>
-        <p:spPr>
-          <a:xfrm>
-            <a:off x="5654357" y="2540000"/>
-            <a:ext cx="1321752" cy="304800"/>
-          </a:xfrm>
-          <a:prstGeom prst="rect">
-            <a:avLst/>
-          </a:prstGeom>
-          <a:noFill/>
-        </p:spPr>
-        <p:txBody>
-          <a:bodyPr wrap="square" lIns="0" rIns="0" tIns="0" bIns="0" anchor="t">
-            <a:noAutofit/>
-          </a:bodyPr>
-          <a:lstStyle/>
-          <a:p>
-            <a:pPr algn="l">
-              <a:lnSpc>
-                <a:spcPct val="100000"/>
-              </a:lnSpc>
-              <a:spcAft>
-                <a:spcPts val="0"/>
-              </a:spcAft>
-            </a:pPr>
-            <a:r>
-              <a:rPr sz="1700" b="1" i="0">
-                <a:solidFill>
-                  <a:srgbClr val="FFFFFF"/>
-                </a:solidFill>
-                <a:latin typeface="Poppins"/>
-              </a:rPr>
-              <a:t>50 000 €</a:t>
-            </a:r>
-          </a:p>
-        </p:txBody>
-      </p:sp>
-      <p:sp>
-        <p:nvSpPr>
-          <p:cNvPr id="38" name="Carte don 50 000 € – libellé impact"/>
-          <p:cNvSpPr txBox="1"/>
-          <p:nvPr/>
-        </p:nvSpPr>
-        <p:spPr>
-          <a:xfrm>
-            <a:off x="5654357" y="3009900"/>
-            <a:ext cx="1321752" cy="127000"/>
-          </a:xfrm>
-          <a:prstGeom prst="rect">
-            <a:avLst/>
-          </a:prstGeom>
-          <a:noFill/>
-        </p:spPr>
-        <p:txBody>
-          <a:bodyPr wrap="square" lIns="0" rIns="0" tIns="0" bIns="0" anchor="t">
-            <a:noAutofit/>
-          </a:bodyPr>
-          <a:lstStyle/>
-          <a:p>
-            <a:pPr algn="l">
-              <a:lnSpc>
-                <a:spcPct val="120000"/>
-              </a:lnSpc>
-              <a:spcAft>
-                <a:spcPts val="0"/>
-              </a:spcAft>
-            </a:pPr>
-            <a:r>
-              <a:rPr sz="630" b="1" i="0" spc="100">
-                <a:solidFill>
-                  <a:srgbClr val="26408F"/>
-                </a:solidFill>
-                <a:latin typeface="Open Sans"/>
-              </a:rPr>
-              <a:t>IMPACT MESURABLE</a:t>
-            </a:r>
-          </a:p>
-        </p:txBody>
-      </p:sp>
-      <p:sp>
-        <p:nvSpPr>
-          <p:cNvPr id="39" name="Carte don 50 000 € – impact"/>
-          <p:cNvSpPr txBox="1"/>
-          <p:nvPr/>
-        </p:nvSpPr>
-        <p:spPr>
-          <a:xfrm>
-            <a:off x="5654357" y="3175000"/>
-            <a:ext cx="1372552" cy="1193800"/>
-          </a:xfrm>
-          <a:prstGeom prst="rect">
-            <a:avLst/>
-          </a:prstGeom>
-          <a:noFill/>
-        </p:spPr>
-        <p:txBody>
-          <a:bodyPr wrap="square" lIns="0" rIns="0" tIns="0" bIns="0" anchor="t">
-            <a:noAutofit/>
-          </a:bodyPr>
-          <a:lstStyle/>
-          <a:p>
-            <a:pPr algn="l">
-              <a:lnSpc>
-                <a:spcPct val="115000"/>
-              </a:lnSpc>
-              <a:spcAft>
-                <a:spcPts val="300"/>
-              </a:spcAft>
-            </a:pPr>
-            <a:r>
-              <a:rPr sz="780" b="1" i="0">
-                <a:solidFill>
-                  <a:srgbClr val="2B2B2B"/>
-                </a:solidFill>
-                <a:latin typeface="Open Sans"/>
-              </a:rPr>
-              <a:t>300 entrepreneurs</a:t>
-            </a:r>
-            <a:r>
-              <a:rPr sz="780" b="0" i="0">
-                <a:solidFill>
-                  <a:srgbClr val="2B2B2B"/>
-                </a:solidFill>
-                <a:latin typeface="Open Sans"/>
-              </a:rPr>
-              <a:t> accèdent à l’assurance sociale et solidaire </a:t>
-            </a:r>
-          </a:p>
-          <a:p>
-            <a:pPr algn="l">
-              <a:lnSpc>
-                <a:spcPct val="115000"/>
-              </a:lnSpc>
-              <a:spcAft>
-                <a:spcPts val="300"/>
-              </a:spcAft>
-            </a:pPr>
-            <a:r>
-              <a:rPr sz="780" b="1" i="1">
-                <a:solidFill>
-                  <a:srgbClr val="26408F"/>
-                </a:solidFill>
-                <a:latin typeface="Open Sans"/>
-              </a:rPr>
-              <a:t>ou</a:t>
-            </a:r>
-          </a:p>
-          <a:p>
-            <a:pPr algn="l">
-              <a:lnSpc>
-                <a:spcPct val="115000"/>
-              </a:lnSpc>
-              <a:spcAft>
-                <a:spcPts val="300"/>
-              </a:spcAft>
-            </a:pPr>
-            <a:r>
-              <a:rPr sz="780" b="1" i="0">
-                <a:solidFill>
-                  <a:srgbClr val="2B2B2B"/>
-                </a:solidFill>
-                <a:latin typeface="Open Sans"/>
-              </a:rPr>
-              <a:t>220 entrepreneurs</a:t>
-            </a:r>
-            <a:r>
-              <a:rPr sz="780" b="0" i="0">
-                <a:solidFill>
-                  <a:srgbClr val="2B2B2B"/>
-                </a:solidFill>
-                <a:latin typeface="Open Sans"/>
-              </a:rPr>
-              <a:t> sont formés à la gestion des risques</a:t>
-            </a:r>
-          </a:p>
-        </p:txBody>
-      </p:sp>
-      <p:sp>
-        <p:nvSpPr>
-          <p:cNvPr id="40" name="Quel est le coût net de votre mécénat ?"/>
-          <p:cNvSpPr txBox="1"/>
-          <p:nvPr/>
-        </p:nvSpPr>
-        <p:spPr>
-          <a:xfrm>
-            <a:off x="457200" y="4584700"/>
-            <a:ext cx="6645909" cy="219075"/>
-          </a:xfrm>
-          <a:prstGeom prst="rect">
-            <a:avLst/>
-          </a:prstGeom>
-          <a:noFill/>
-        </p:spPr>
-        <p:txBody>
-          <a:bodyPr wrap="square" lIns="0" rIns="0" tIns="0" bIns="0" anchor="t">
-            <a:noAutofit/>
-          </a:bodyPr>
-          <a:lstStyle/>
-          <a:p>
-            <a:pPr algn="l">
-              <a:lnSpc>
-                <a:spcPct val="100000"/>
-              </a:lnSpc>
-              <a:spcAft>
-                <a:spcPts val="0"/>
-              </a:spcAft>
-            </a:pPr>
-            <a:r>
               <a:rPr sz="1150" b="1" i="0">
                 <a:solidFill>
                   <a:srgbClr val="26408F"/>
@@ -7807,13 +6791,13 @@
       </p:sp>
       <p:sp>
         <p:nvSpPr>
-          <p:cNvPr id="41" name="Coût net – texte"/>
+          <p:cNvPr id="11" name="Coût net – texte"/>
           <p:cNvSpPr txBox="1"/>
           <p:nvPr/>
         </p:nvSpPr>
         <p:spPr>
           <a:xfrm>
-            <a:off x="457200" y="4838700"/>
+            <a:off x="457200" y="4953000"/>
             <a:ext cx="6645909" cy="330200"/>
           </a:xfrm>
           <a:prstGeom prst="rect">
@@ -7849,14 +6833,14 @@
       </p:sp>
       <p:graphicFrame>
         <p:nvGraphicFramePr>
-          <p:cNvPr id="42" name="Tableau coût net du mécénat"/>
+          <p:cNvPr id="12" name="Tableau coût net du mécénat"/>
           <p:cNvGraphicFramePr>
             <a:graphicFrameLocks noGrp="1"/>
           </p:cNvGraphicFramePr>
           <p:nvPr/>
         </p:nvGraphicFramePr>
         <p:xfrm>
-          <a:off x="457200" y="5270500"/>
+          <a:off x="457200" y="5384800"/>
           <a:ext cx="4724400" cy="1371600"/>
         </p:xfrm>
         <a:graphic>
@@ -8623,7 +7607,7 @@
       </p:graphicFrame>
       <p:pic>
         <p:nvPicPr>
-          <p:cNvPr id="43" name="Illustration – analyse du document" descr="analyse_document.png"/>
+          <p:cNvPr id="13" name="Illustration – analyse du document" descr="analyse_document.png"/>
           <p:cNvPicPr>
             <a:picLocks noChangeAspect="1"/>
           </p:cNvPicPr>
@@ -8637,7 +7621,7 @@
         </p:blipFill>
         <p:spPr>
           <a:xfrm>
-            <a:off x="5359400" y="5245100"/>
+            <a:off x="5359400" y="5359400"/>
             <a:ext cx="1743709" cy="1150848"/>
           </a:xfrm>
           <a:prstGeom prst="rect">
@@ -8647,13 +7631,13 @@
       </p:pic>
       <p:sp>
         <p:nvSpPr>
-          <p:cNvPr id="44" name="Note fiscale"/>
+          <p:cNvPr id="14" name="Note fiscale"/>
           <p:cNvSpPr txBox="1"/>
           <p:nvPr/>
         </p:nvSpPr>
         <p:spPr>
           <a:xfrm>
-            <a:off x="457200" y="6756400"/>
+            <a:off x="457200" y="6870700"/>
             <a:ext cx="6645909" cy="635000"/>
           </a:xfrm>
           <a:prstGeom prst="rect">
@@ -8689,13 +7673,13 @@
       </p:sp>
       <p:sp>
         <p:nvSpPr>
-          <p:cNvPr id="45" name="Engagement – fond"/>
+          <p:cNvPr id="15" name="Engagement – fond"/>
           <p:cNvSpPr/>
           <p:nvPr/>
         </p:nvSpPr>
         <p:spPr>
           <a:xfrm>
-            <a:off x="457200" y="7366000"/>
+            <a:off x="457200" y="7480300"/>
             <a:ext cx="6645909" cy="304800"/>
           </a:xfrm>
           <a:prstGeom prst="roundRect">
@@ -8719,13 +7703,13 @@
       </p:sp>
       <p:sp>
         <p:nvSpPr>
-          <p:cNvPr id="46" name="Engagement – puce"/>
+          <p:cNvPr id="16" name="Engagement – puce"/>
           <p:cNvSpPr/>
           <p:nvPr/>
         </p:nvSpPr>
         <p:spPr>
           <a:xfrm>
-            <a:off x="609600" y="7480300"/>
+            <a:off x="609600" y="7594600"/>
             <a:ext cx="76200" cy="76200"/>
           </a:xfrm>
           <a:prstGeom prst="ellipse">
@@ -8749,13 +7733,13 @@
       </p:sp>
       <p:sp>
         <p:nvSpPr>
-          <p:cNvPr id="47" name="Engagement – texte"/>
+          <p:cNvPr id="17" name="Engagement – texte"/>
           <p:cNvSpPr txBox="1"/>
           <p:nvPr/>
         </p:nvSpPr>
         <p:spPr>
           <a:xfrm>
-            <a:off x="787400" y="7366000"/>
+            <a:off x="787400" y="7480300"/>
             <a:ext cx="6188709" cy="304800"/>
           </a:xfrm>
           <a:prstGeom prst="rect">
@@ -8791,18 +7775,18 @@
       </p:sp>
       <p:sp>
         <p:nvSpPr>
-          <p:cNvPr id="48" name="Contact – fond bleu"/>
+          <p:cNvPr id="18" name="Contact – fond bleu"/>
           <p:cNvSpPr/>
           <p:nvPr/>
         </p:nvSpPr>
         <p:spPr>
           <a:xfrm>
-            <a:off x="457200" y="7772400"/>
-            <a:ext cx="6645909" cy="2360929"/>
+            <a:off x="457200" y="7886700"/>
+            <a:ext cx="6645909" cy="2246629"/>
           </a:xfrm>
           <a:prstGeom prst="roundRect">
             <a:avLst>
-              <a:gd name="adj" fmla="val 6455"/>
+              <a:gd name="adj" fmla="val 6783"/>
             </a:avLst>
           </a:prstGeom>
           <a:solidFill>
@@ -8821,7 +7805,7 @@
       </p:sp>
       <p:sp>
         <p:nvSpPr>
-          <p:cNvPr id="49" name="Décor – cercle contact"/>
+          <p:cNvPr id="19" name="Décor – cercle contact"/>
           <p:cNvSpPr/>
           <p:nvPr/>
         </p:nvSpPr>
@@ -8851,7 +7835,7 @@
       </p:sp>
       <p:pic>
         <p:nvPicPr>
-          <p:cNvPr id="50" name="Illustration – interlocutrice" descr="interlocutrice_crop.png"/>
+          <p:cNvPr id="20" name="Illustration – interlocutrice" descr="interlocutrice_crop.png"/>
           <p:cNvPicPr>
             <a:picLocks noChangeAspect="1"/>
           </p:cNvPicPr>
@@ -8875,13 +7859,13 @@
       </p:pic>
       <p:sp>
         <p:nvSpPr>
-          <p:cNvPr id="51" name="Contact – titre"/>
+          <p:cNvPr id="21" name="Contact – titre"/>
           <p:cNvSpPr txBox="1"/>
           <p:nvPr/>
         </p:nvSpPr>
         <p:spPr>
           <a:xfrm>
-            <a:off x="685800" y="7950200"/>
+            <a:off x="685800" y="8039100"/>
             <a:ext cx="4572000" cy="304800"/>
           </a:xfrm>
           <a:prstGeom prst="rect">
@@ -8917,14 +7901,14 @@
       </p:sp>
       <p:sp>
         <p:nvSpPr>
-          <p:cNvPr id="52" name="Contact – texte"/>
+          <p:cNvPr id="22" name="Contact – texte"/>
           <p:cNvSpPr txBox="1"/>
           <p:nvPr/>
         </p:nvSpPr>
         <p:spPr>
           <a:xfrm>
-            <a:off x="685800" y="8305800"/>
-            <a:ext cx="5080000" cy="330200"/>
+            <a:off x="685800" y="8394700"/>
+            <a:ext cx="5080000" cy="457200"/>
           </a:xfrm>
           <a:prstGeom prst="rect">
             <a:avLst/>
@@ -8939,7 +7923,7 @@
           <a:p>
             <a:pPr algn="l">
               <a:lnSpc>
-                <a:spcPct val="120000"/>
+                <a:spcPct val="135000"/>
               </a:lnSpc>
               <a:spcAft>
                 <a:spcPts val="0"/>
@@ -8970,98 +7954,8 @@
                 </a:solidFill>
                 <a:latin typeface="Open Sans"/>
               </a:rPr>
-              <a:t> :</a:t>
-            </a:r>
-          </a:p>
-        </p:txBody>
-      </p:sp>
-      <p:sp>
-        <p:nvSpPr>
-          <p:cNvPr id="53" name="Picto e-mail – enveloppe"/>
-          <p:cNvSpPr/>
-          <p:nvPr/>
-        </p:nvSpPr>
-        <p:spPr>
-          <a:xfrm>
-            <a:off x="685800" y="8724900"/>
-            <a:ext cx="139700" cy="94996"/>
-          </a:xfrm>
-          <a:prstGeom prst="rect">
-            <a:avLst/>
-          </a:prstGeom>
-          <a:noFill/>
-          <a:ln w="11430">
-            <a:solidFill>
-              <a:srgbClr val="FFCB1F"/>
-            </a:solidFill>
-          </a:ln>
-          <a:effectLst/>
-        </p:spPr>
-        <p:txBody>
-          <a:bodyPr rtlCol="0" anchor="ctr"/>
-          <a:lstStyle/>
-          <a:p/>
-        </p:txBody>
-      </p:sp>
-      <p:sp>
-        <p:nvSpPr>
-          <p:cNvPr id="54" name="Picto e-mail – rabat"/>
-          <p:cNvSpPr/>
-          <p:nvPr/>
-        </p:nvSpPr>
-        <p:spPr>
-          <a:xfrm>
-            <a:off x="685800" y="8724900"/>
-            <a:ext cx="139700" cy="52247"/>
-          </a:xfrm>
-          <a:prstGeom prst="flowChartMerge">
-            <a:avLst/>
-          </a:prstGeom>
-          <a:noFill/>
-          <a:ln w="11430">
-            <a:solidFill>
-              <a:srgbClr val="FFCB1F"/>
-            </a:solidFill>
-          </a:ln>
-        </p:spPr>
-        <p:txBody>
-          <a:bodyPr rtlCol="0" anchor="ctr"/>
-          <a:lstStyle/>
-          <a:p>
-            <a:pPr algn="ctr"/>
-          </a:p>
-        </p:txBody>
-      </p:sp>
-      <p:sp>
-        <p:nvSpPr>
-          <p:cNvPr id="55" name="Contact – e-mail"/>
-          <p:cNvSpPr txBox="1"/>
-          <p:nvPr/>
-        </p:nvSpPr>
-        <p:spPr>
-          <a:xfrm>
-            <a:off x="901700" y="8686800"/>
-            <a:ext cx="4191000" cy="165100"/>
-          </a:xfrm>
-          <a:prstGeom prst="rect">
-            <a:avLst/>
-          </a:prstGeom>
-          <a:noFill/>
-        </p:spPr>
-        <p:txBody>
-          <a:bodyPr wrap="square" lIns="0" rIns="0" tIns="0" bIns="0" anchor="t">
-            <a:noAutofit/>
-          </a:bodyPr>
-          <a:lstStyle/>
-          <a:p>
-            <a:pPr algn="l">
-              <a:lnSpc>
-                <a:spcPct val="120000"/>
-              </a:lnSpc>
-              <a:spcAft>
-                <a:spcPts val="0"/>
-              </a:spcAft>
-            </a:pPr>
+              <a:t> : </a:t>
+            </a:r>
             <a:r>
               <a:rPr sz="880" b="1" i="0" u="sng">
                 <a:solidFill>
@@ -9077,13 +7971,13 @@
       </p:sp>
       <p:cxnSp>
         <p:nvCxnSpPr>
-          <p:cNvPr id="56" name="Contact – séparateur"/>
+          <p:cNvPr id="23" name="Contact – séparateur"/>
           <p:cNvCxnSpPr/>
           <p:nvPr/>
         </p:nvCxnSpPr>
         <p:spPr>
           <a:xfrm>
-            <a:off x="685800" y="8953500"/>
+            <a:off x="685800" y="8928100"/>
             <a:ext cx="4318000" cy="0"/>
           </a:xfrm>
           <a:prstGeom prst="line">
@@ -9098,13 +7992,13 @@
       </p:cxnSp>
       <p:sp>
         <p:nvSpPr>
-          <p:cNvPr id="57" name="Picto adresse – pointe"/>
+          <p:cNvPr id="24" name="Picto adresse – pointe"/>
           <p:cNvSpPr/>
           <p:nvPr/>
         </p:nvSpPr>
         <p:spPr>
           <a:xfrm>
-            <a:off x="713613" y="9152572"/>
+            <a:off x="713613" y="9127172"/>
             <a:ext cx="77724" cy="80962"/>
           </a:xfrm>
           <a:prstGeom prst="flowChartMerge">
@@ -9127,13 +8021,13 @@
       </p:sp>
       <p:sp>
         <p:nvSpPr>
-          <p:cNvPr id="58" name="Picto adresse – tête"/>
+          <p:cNvPr id="25" name="Picto adresse – tête"/>
           <p:cNvSpPr/>
           <p:nvPr/>
         </p:nvSpPr>
         <p:spPr>
           <a:xfrm>
-            <a:off x="698500" y="9093200"/>
+            <a:off x="698500" y="9067800"/>
             <a:ext cx="107950" cy="107950"/>
           </a:xfrm>
           <a:prstGeom prst="ellipse">
@@ -9157,13 +8051,13 @@
       </p:sp>
       <p:sp>
         <p:nvSpPr>
-          <p:cNvPr id="59" name="Picto adresse – centre"/>
+          <p:cNvPr id="26" name="Picto adresse – centre"/>
           <p:cNvSpPr/>
           <p:nvPr/>
         </p:nvSpPr>
         <p:spPr>
           <a:xfrm>
-            <a:off x="730885" y="9125585"/>
+            <a:off x="730885" y="9100185"/>
             <a:ext cx="43180" cy="43180"/>
           </a:xfrm>
           <a:prstGeom prst="ellipse">
@@ -9187,13 +8081,13 @@
       </p:sp>
       <p:sp>
         <p:nvSpPr>
-          <p:cNvPr id="60" name="Contact – adresse"/>
+          <p:cNvPr id="27" name="Contact – adresse"/>
           <p:cNvSpPr txBox="1"/>
           <p:nvPr/>
         </p:nvSpPr>
         <p:spPr>
           <a:xfrm>
-            <a:off x="901700" y="9055100"/>
+            <a:off x="901700" y="9029700"/>
             <a:ext cx="4191000" cy="355600"/>
           </a:xfrm>
           <a:prstGeom prst="rect">
@@ -9248,13 +8142,13 @@
       </p:sp>
       <p:sp>
         <p:nvSpPr>
-          <p:cNvPr id="61" name="Picto web – globe"/>
+          <p:cNvPr id="28" name="Picto web – globe"/>
           <p:cNvSpPr/>
           <p:nvPr/>
         </p:nvSpPr>
         <p:spPr>
           <a:xfrm>
-            <a:off x="685800" y="9461500"/>
+            <a:off x="685800" y="9436100"/>
             <a:ext cx="127000" cy="127000"/>
           </a:xfrm>
           <a:prstGeom prst="ellipse">
@@ -9277,13 +8171,13 @@
       </p:sp>
       <p:sp>
         <p:nvSpPr>
-          <p:cNvPr id="62" name="Picto web – méridien"/>
+          <p:cNvPr id="29" name="Picto web – méridien"/>
           <p:cNvSpPr/>
           <p:nvPr/>
         </p:nvSpPr>
         <p:spPr>
           <a:xfrm>
-            <a:off x="723900" y="9461500"/>
+            <a:off x="723900" y="9436100"/>
             <a:ext cx="50800" cy="127000"/>
           </a:xfrm>
           <a:prstGeom prst="ellipse">
@@ -9306,13 +8200,13 @@
       </p:sp>
       <p:cxnSp>
         <p:nvCxnSpPr>
-          <p:cNvPr id="63" name="Picto web – équateur"/>
+          <p:cNvPr id="30" name="Picto web – équateur"/>
           <p:cNvCxnSpPr/>
           <p:nvPr/>
         </p:nvCxnSpPr>
         <p:spPr>
           <a:xfrm>
-            <a:off x="685800" y="9525000"/>
+            <a:off x="685800" y="9499600"/>
             <a:ext cx="127000" cy="0"/>
           </a:xfrm>
           <a:prstGeom prst="line">
@@ -9327,13 +8221,13 @@
       </p:cxnSp>
       <p:sp>
         <p:nvSpPr>
-          <p:cNvPr id="64" name="Contact – site web"/>
+          <p:cNvPr id="31" name="Contact – site web"/>
           <p:cNvSpPr txBox="1"/>
           <p:nvPr/>
         </p:nvSpPr>
         <p:spPr>
           <a:xfrm>
-            <a:off x="901700" y="9448800"/>
+            <a:off x="901700" y="9423400"/>
             <a:ext cx="4191000" cy="165100"/>
           </a:xfrm>
           <a:prstGeom prst="rect">
@@ -9370,13 +8264,13 @@
       </p:sp>
       <p:sp>
         <p:nvSpPr>
-          <p:cNvPr id="65" name="Contact – accroche"/>
+          <p:cNvPr id="32" name="Contact – accroche"/>
           <p:cNvSpPr txBox="1"/>
           <p:nvPr/>
         </p:nvSpPr>
         <p:spPr>
           <a:xfrm>
-            <a:off x="685800" y="9715500"/>
+            <a:off x="685800" y="9677400"/>
             <a:ext cx="4445000" cy="355600"/>
           </a:xfrm>
           <a:prstGeom prst="rect">
@@ -9406,6 +8300,78 @@
                 <a:latin typeface="Open Sans"/>
               </a:rPr>
               <a:t>Prenons contact pour construire un partenariat à la hauteur de vos engagements.</a:t>
+            </a:r>
+          </a:p>
+        </p:txBody>
+      </p:sp>
+      <p:cxnSp>
+        <p:nvCxnSpPr>
+          <p:cNvPr id="33" name="Pied de page – filet"/>
+          <p:cNvCxnSpPr/>
+          <p:nvPr/>
+        </p:nvCxnSpPr>
+        <p:spPr>
+          <a:xfrm>
+            <a:off x="457200" y="10260330"/>
+            <a:ext cx="6645909" cy="0"/>
+          </a:xfrm>
+          <a:prstGeom prst="line">
+            <a:avLst/>
+          </a:prstGeom>
+          <a:ln w="9525">
+            <a:solidFill>
+              <a:srgbClr val="EF3F34"/>
+            </a:solidFill>
+          </a:ln>
+        </p:spPr>
+      </p:cxnSp>
+      <p:sp>
+        <p:nvSpPr>
+          <p:cNvPr id="34" name="Pied de page"/>
+          <p:cNvSpPr txBox="1"/>
+          <p:nvPr/>
+        </p:nvSpPr>
+        <p:spPr>
+          <a:xfrm>
+            <a:off x="457200" y="10349230"/>
+            <a:ext cx="6645909" cy="127000"/>
+          </a:xfrm>
+          <a:prstGeom prst="rect">
+            <a:avLst/>
+          </a:prstGeom>
+          <a:noFill/>
+        </p:spPr>
+        <p:txBody>
+          <a:bodyPr wrap="square" lIns="0" rIns="0" tIns="0" bIns="0" anchor="t">
+            <a:noAutofit/>
+          </a:bodyPr>
+          <a:lstStyle/>
+          <a:p>
+            <a:pPr algn="ctr">
+              <a:lnSpc>
+                <a:spcPct val="120000"/>
+              </a:lnSpc>
+              <a:spcAft>
+                <a:spcPts val="0"/>
+              </a:spcAft>
+            </a:pPr>
+            <a:r>
+              <a:rPr sz="680" b="1" i="0" spc="30">
+                <a:solidFill>
+                  <a:srgbClr val="EF3F34"/>
+                </a:solidFill>
+                <a:latin typeface="Open Sans"/>
+              </a:rPr>
+              <a:t>ENTREPRENEURS DE LA CITÉ</a:t>
+            </a:r>
+            <a:r>
+              <a:rPr sz="680" b="0" i="0" spc="30">
+                <a:solidFill>
+                  <a:srgbClr val="6B6B6B"/>
+                </a:solidFill>
+                <a:latin typeface="Open Sans"/>
+              </a:rPr>
+              <a:t>  •  Prévenir, protéger, pérenniser</a:t>
             </a:r>
           </a:p>
         </p:txBody>

</xml_diff>

<commit_message>
Plaquette EDLC : e-mail de contact dans sa propre zone de texte (couleur conservée dans Canva)
Co-Authored-By: Claude Opus 5.5 <noreply@anthropic.com>
Claude-Session: https://claude.ai/code/session_013b5GF7ZW93Jhurg8kHyqui
</commit_message>
<xml_diff>
--- a/edlc-plaquette/EDLC_Plaquette_mecenat.pptx
+++ b/edlc-plaquette/EDLC_Plaquette_mecenat.pptx
@@ -7908,7 +7908,7 @@
         <p:spPr>
           <a:xfrm>
             <a:off x="685800" y="8394700"/>
-            <a:ext cx="5080000" cy="457200"/>
+            <a:ext cx="5080000" cy="177800"/>
           </a:xfrm>
           <a:prstGeom prst="rect">
             <a:avLst/>
@@ -7923,7 +7923,7 @@
           <a:p>
             <a:pPr algn="l">
               <a:lnSpc>
-                <a:spcPct val="135000"/>
+                <a:spcPct val="120000"/>
               </a:lnSpc>
               <a:spcAft>
                 <a:spcPts val="0"/>
@@ -7954,8 +7954,41 @@
                 </a:solidFill>
                 <a:latin typeface="Open Sans"/>
               </a:rPr>
-              <a:t> : </a:t>
-            </a:r>
+              <a:t> :</a:t>
+            </a:r>
+          </a:p>
+        </p:txBody>
+      </p:sp>
+      <p:sp>
+        <p:nvSpPr>
+          <p:cNvPr id="23" name="Contact – e-mail"/>
+          <p:cNvSpPr txBox="1"/>
+          <p:nvPr/>
+        </p:nvSpPr>
+        <p:spPr>
+          <a:xfrm>
+            <a:off x="685800" y="8610600"/>
+            <a:ext cx="5080000" cy="177800"/>
+          </a:xfrm>
+          <a:prstGeom prst="rect">
+            <a:avLst/>
+          </a:prstGeom>
+          <a:noFill/>
+        </p:spPr>
+        <p:txBody>
+          <a:bodyPr wrap="square" lIns="0" rIns="0" tIns="0" bIns="0" anchor="t">
+            <a:noAutofit/>
+          </a:bodyPr>
+          <a:lstStyle/>
+          <a:p>
+            <a:pPr algn="l">
+              <a:lnSpc>
+                <a:spcPct val="120000"/>
+              </a:lnSpc>
+              <a:spcAft>
+                <a:spcPts val="0"/>
+              </a:spcAft>
+            </a:pPr>
             <a:r>
               <a:rPr sz="880" b="1" i="0" u="sng">
                 <a:solidFill>
@@ -7971,7 +8004,7 @@
       </p:sp>
       <p:cxnSp>
         <p:nvCxnSpPr>
-          <p:cNvPr id="23" name="Contact – séparateur"/>
+          <p:cNvPr id="24" name="Contact – séparateur"/>
           <p:cNvCxnSpPr/>
           <p:nvPr/>
         </p:nvCxnSpPr>
@@ -7992,7 +8025,7 @@
       </p:cxnSp>
       <p:sp>
         <p:nvSpPr>
-          <p:cNvPr id="24" name="Picto adresse – pointe"/>
+          <p:cNvPr id="25" name="Picto adresse – pointe"/>
           <p:cNvSpPr/>
           <p:nvPr/>
         </p:nvSpPr>
@@ -8021,7 +8054,7 @@
       </p:sp>
       <p:sp>
         <p:nvSpPr>
-          <p:cNvPr id="25" name="Picto adresse – tête"/>
+          <p:cNvPr id="26" name="Picto adresse – tête"/>
           <p:cNvSpPr/>
           <p:nvPr/>
         </p:nvSpPr>
@@ -8051,7 +8084,7 @@
       </p:sp>
       <p:sp>
         <p:nvSpPr>
-          <p:cNvPr id="26" name="Picto adresse – centre"/>
+          <p:cNvPr id="27" name="Picto adresse – centre"/>
           <p:cNvSpPr/>
           <p:nvPr/>
         </p:nvSpPr>
@@ -8081,7 +8114,7 @@
       </p:sp>
       <p:sp>
         <p:nvSpPr>
-          <p:cNvPr id="27" name="Contact – adresse"/>
+          <p:cNvPr id="28" name="Contact – adresse"/>
           <p:cNvSpPr txBox="1"/>
           <p:nvPr/>
         </p:nvSpPr>
@@ -8142,7 +8175,7 @@
       </p:sp>
       <p:sp>
         <p:nvSpPr>
-          <p:cNvPr id="28" name="Picto web – globe"/>
+          <p:cNvPr id="29" name="Picto web – globe"/>
           <p:cNvSpPr/>
           <p:nvPr/>
         </p:nvSpPr>
@@ -8171,7 +8204,7 @@
       </p:sp>
       <p:sp>
         <p:nvSpPr>
-          <p:cNvPr id="29" name="Picto web – méridien"/>
+          <p:cNvPr id="30" name="Picto web – méridien"/>
           <p:cNvSpPr/>
           <p:nvPr/>
         </p:nvSpPr>
@@ -8200,7 +8233,7 @@
       </p:sp>
       <p:cxnSp>
         <p:nvCxnSpPr>
-          <p:cNvPr id="30" name="Picto web – équateur"/>
+          <p:cNvPr id="31" name="Picto web – équateur"/>
           <p:cNvCxnSpPr/>
           <p:nvPr/>
         </p:nvCxnSpPr>
@@ -8221,7 +8254,7 @@
       </p:cxnSp>
       <p:sp>
         <p:nvSpPr>
-          <p:cNvPr id="31" name="Contact – site web"/>
+          <p:cNvPr id="32" name="Contact – site web"/>
           <p:cNvSpPr txBox="1"/>
           <p:nvPr/>
         </p:nvSpPr>
@@ -8264,7 +8297,7 @@
       </p:sp>
       <p:sp>
         <p:nvSpPr>
-          <p:cNvPr id="32" name="Contact – accroche"/>
+          <p:cNvPr id="33" name="Contact – accroche"/>
           <p:cNvSpPr txBox="1"/>
           <p:nvPr/>
         </p:nvSpPr>
@@ -8306,7 +8339,7 @@
       </p:sp>
       <p:cxnSp>
         <p:nvCxnSpPr>
-          <p:cNvPr id="33" name="Pied de page – filet"/>
+          <p:cNvPr id="34" name="Pied de page – filet"/>
           <p:cNvCxnSpPr/>
           <p:nvPr/>
         </p:nvCxnSpPr>
@@ -8327,7 +8360,7 @@
       </p:cxnSp>
       <p:sp>
         <p:nvSpPr>
-          <p:cNvPr id="34" name="Pied de page"/>
+          <p:cNvPr id="35" name="Pied de page"/>
           <p:cNvSpPr txBox="1"/>
           <p:nvPr/>
         </p:nvSpPr>

</xml_diff>